<commit_message>
DEV:0.3.2 (Added search system)
</commit_message>
<xml_diff>
--- a/config/presentation.pptx
+++ b/config/presentation.pptx
@@ -7,6 +7,13 @@
   <p:sldIdLst>
     <p:sldId id="256" r:id="rId2"/>
     <p:sldId id="257" r:id="rId3"/>
+    <p:sldId id="258" r:id="rId4"/>
+    <p:sldId id="259" r:id="rId5"/>
+    <p:sldId id="260" r:id="rId6"/>
+    <p:sldId id="261" r:id="rId7"/>
+    <p:sldId id="262" r:id="rId8"/>
+    <p:sldId id="263" r:id="rId9"/>
+    <p:sldId id="264" r:id="rId10"/>
   </p:sldIdLst>
   <p:sldSz cx="12192000" cy="6858000"/>
   <p:notesSz cx="6858000" cy="9144000"/>
@@ -260,7 +267,7 @@
           <a:p>
             <a:fld id="{5E57A919-6E1B-4A8F-B4AD-9FFE74647BA4}" type="datetimeFigureOut">
               <a:rPr lang="ru-RU" smtClean="0"/>
-              <a:t>11.05.2026</a:t>
+              <a:t>12.05.2026</a:t>
             </a:fld>
             <a:endParaRPr lang="ru-RU"/>
           </a:p>
@@ -458,7 +465,7 @@
           <a:p>
             <a:fld id="{5E57A919-6E1B-4A8F-B4AD-9FFE74647BA4}" type="datetimeFigureOut">
               <a:rPr lang="ru-RU" smtClean="0"/>
-              <a:t>11.05.2026</a:t>
+              <a:t>12.05.2026</a:t>
             </a:fld>
             <a:endParaRPr lang="ru-RU"/>
           </a:p>
@@ -666,7 +673,7 @@
           <a:p>
             <a:fld id="{5E57A919-6E1B-4A8F-B4AD-9FFE74647BA4}" type="datetimeFigureOut">
               <a:rPr lang="ru-RU" smtClean="0"/>
-              <a:t>11.05.2026</a:t>
+              <a:t>12.05.2026</a:t>
             </a:fld>
             <a:endParaRPr lang="ru-RU"/>
           </a:p>
@@ -864,7 +871,7 @@
           <a:p>
             <a:fld id="{5E57A919-6E1B-4A8F-B4AD-9FFE74647BA4}" type="datetimeFigureOut">
               <a:rPr lang="ru-RU" smtClean="0"/>
-              <a:t>11.05.2026</a:t>
+              <a:t>12.05.2026</a:t>
             </a:fld>
             <a:endParaRPr lang="ru-RU"/>
           </a:p>
@@ -1139,7 +1146,7 @@
           <a:p>
             <a:fld id="{5E57A919-6E1B-4A8F-B4AD-9FFE74647BA4}" type="datetimeFigureOut">
               <a:rPr lang="ru-RU" smtClean="0"/>
-              <a:t>11.05.2026</a:t>
+              <a:t>12.05.2026</a:t>
             </a:fld>
             <a:endParaRPr lang="ru-RU"/>
           </a:p>
@@ -1404,7 +1411,7 @@
           <a:p>
             <a:fld id="{5E57A919-6E1B-4A8F-B4AD-9FFE74647BA4}" type="datetimeFigureOut">
               <a:rPr lang="ru-RU" smtClean="0"/>
-              <a:t>11.05.2026</a:t>
+              <a:t>12.05.2026</a:t>
             </a:fld>
             <a:endParaRPr lang="ru-RU"/>
           </a:p>
@@ -1816,7 +1823,7 @@
           <a:p>
             <a:fld id="{5E57A919-6E1B-4A8F-B4AD-9FFE74647BA4}" type="datetimeFigureOut">
               <a:rPr lang="ru-RU" smtClean="0"/>
-              <a:t>11.05.2026</a:t>
+              <a:t>12.05.2026</a:t>
             </a:fld>
             <a:endParaRPr lang="ru-RU"/>
           </a:p>
@@ -1957,7 +1964,7 @@
           <a:p>
             <a:fld id="{5E57A919-6E1B-4A8F-B4AD-9FFE74647BA4}" type="datetimeFigureOut">
               <a:rPr lang="ru-RU" smtClean="0"/>
-              <a:t>11.05.2026</a:t>
+              <a:t>12.05.2026</a:t>
             </a:fld>
             <a:endParaRPr lang="ru-RU"/>
           </a:p>
@@ -2070,7 +2077,7 @@
           <a:p>
             <a:fld id="{5E57A919-6E1B-4A8F-B4AD-9FFE74647BA4}" type="datetimeFigureOut">
               <a:rPr lang="ru-RU" smtClean="0"/>
-              <a:t>11.05.2026</a:t>
+              <a:t>12.05.2026</a:t>
             </a:fld>
             <a:endParaRPr lang="ru-RU"/>
           </a:p>
@@ -2381,7 +2388,7 @@
           <a:p>
             <a:fld id="{5E57A919-6E1B-4A8F-B4AD-9FFE74647BA4}" type="datetimeFigureOut">
               <a:rPr lang="ru-RU" smtClean="0"/>
-              <a:t>11.05.2026</a:t>
+              <a:t>12.05.2026</a:t>
             </a:fld>
             <a:endParaRPr lang="ru-RU"/>
           </a:p>
@@ -2669,7 +2676,7 @@
           <a:p>
             <a:fld id="{5E57A919-6E1B-4A8F-B4AD-9FFE74647BA4}" type="datetimeFigureOut">
               <a:rPr lang="ru-RU" smtClean="0"/>
-              <a:t>11.05.2026</a:t>
+              <a:t>12.05.2026</a:t>
             </a:fld>
             <a:endParaRPr lang="ru-RU"/>
           </a:p>
@@ -2910,7 +2917,7 @@
           <a:p>
             <a:fld id="{5E57A919-6E1B-4A8F-B4AD-9FFE74647BA4}" type="datetimeFigureOut">
               <a:rPr lang="ru-RU" smtClean="0"/>
-              <a:t>11.05.2026</a:t>
+              <a:t>12.05.2026</a:t>
             </a:fld>
             <a:endParaRPr lang="ru-RU"/>
           </a:p>
@@ -3354,20 +3361,22 @@
           <a:lstStyle/>
           <a:p>
             <a:r>
-              <a:rPr lang="en-US" dirty="0" err="1">
+              <a:rPr lang="en-US" dirty="0" smtClean="0">
                 <a:solidFill>
                   <a:srgbClr val="36A9E1"/>
                 </a:solidFill>
-                <a:latin typeface="Fredoka One (RUS BY ME)" panose="02000000000000000000" pitchFamily="2" charset="-52"/>
+                <a:latin typeface="Segoe UI Black" panose="020B0A02040204020203" pitchFamily="34" charset="0"/>
+                <a:ea typeface="Segoe UI Black" panose="020B0A02040204020203" pitchFamily="34" charset="0"/>
                 <a:cs typeface="Fredoka" pitchFamily="2" charset="-79"/>
               </a:rPr>
-              <a:t>FaceSpace</a:t>
+              <a:t>Face Space</a:t>
             </a:r>
             <a:endParaRPr lang="ru-RU" dirty="0">
               <a:solidFill>
                 <a:srgbClr val="36A9E1"/>
               </a:solidFill>
-              <a:latin typeface="Fredoka One (RUS BY ME)" panose="02000000000000000000" pitchFamily="2" charset="-52"/>
+              <a:latin typeface="Segoe UI Black" panose="020B0A02040204020203" pitchFamily="34" charset="0"/>
+              <a:ea typeface="Segoe UI Black" panose="020B0A02040204020203" pitchFamily="34" charset="0"/>
               <a:cs typeface="Fredoka" pitchFamily="2" charset="-79"/>
             </a:endParaRPr>
           </a:p>
@@ -3408,9 +3417,9 @@
                     <a:lumMod val="50000"/>
                   </a:schemeClr>
                 </a:solidFill>
-                <a:latin typeface="Segoe UI Black" panose="020B0A02040204020203" pitchFamily="34" charset="0"/>
-                <a:ea typeface="Segoe UI Black" panose="020B0A02040204020203" pitchFamily="34" charset="0"/>
-                <a:cs typeface="Leelawadee UI Semilight" panose="020B0402040204020203" pitchFamily="34" charset="-34"/>
+                <a:latin typeface="Segoe UI Light" panose="020B0502040204020203" pitchFamily="34" charset="0"/>
+                <a:ea typeface="Segoe UI Black" panose="020B0A02040204020203" pitchFamily="34" charset="0"/>
+                <a:cs typeface="Segoe UI Light" panose="020B0502040204020203" pitchFamily="34" charset="0"/>
               </a:rPr>
               <a:t>Платформа для встреч</a:t>
             </a:r>
@@ -3438,7 +3447,7 @@
                 <a14:useLocalDpi xmlns:a14="http://schemas.microsoft.com/office/drawing/2010/main" val="0"/>
               </a:ext>
               <a:ext uri="{96DAC541-7B7A-43D3-8B79-37D633B846F1}">
-                <asvg:svgBlip xmlns:asvg="http://schemas.microsoft.com/office/drawing/2016/SVG/main" r:embed="rId3"/>
+                <asvg:svgBlip xmlns:asvg="http://schemas.microsoft.com/office/drawing/2016/SVG/main" xmlns="" r:embed="rId3"/>
               </a:ext>
             </a:extLst>
           </a:blip>
@@ -3541,6 +3550,8 @@
                 <a:solidFill>
                   <a:schemeClr val="bg1"/>
                 </a:solidFill>
+                <a:latin typeface="Segoe UI Black" panose="020B0A02040204020203" pitchFamily="34" charset="0"/>
+                <a:ea typeface="Segoe UI Black" panose="020B0A02040204020203" pitchFamily="34" charset="0"/>
               </a:rPr>
               <a:t>Автор: Бендерский Стефан</a:t>
             </a:r>
@@ -3581,6 +3592,8 @@
                 <a:solidFill>
                   <a:schemeClr val="bg1"/>
                 </a:solidFill>
+                <a:latin typeface="Segoe UI Black" panose="020B0A02040204020203" pitchFamily="34" charset="0"/>
+                <a:ea typeface="Segoe UI Black" panose="020B0A02040204020203" pitchFamily="34" charset="0"/>
               </a:rPr>
               <a:t>Сыктывкар, 2026 год</a:t>
             </a:r>
@@ -4217,8 +4230,10 @@
             <a:r>
               <a:rPr lang="ru-RU" sz="4000" dirty="0">
                 <a:solidFill>
-                  <a:srgbClr val="36A9E1"/>
+                  <a:srgbClr val="00B0F0"/>
                 </a:solidFill>
+                <a:latin typeface="Segoe UI Black" panose="020B0A02040204020203" pitchFamily="34" charset="0"/>
+                <a:ea typeface="Segoe UI Black" panose="020B0A02040204020203" pitchFamily="34" charset="0"/>
               </a:rPr>
               <a:t>Описание</a:t>
             </a:r>
@@ -4243,51 +4258,137 @@
         </p:nvSpPr>
         <p:spPr/>
         <p:txBody>
-          <a:bodyPr/>
+          <a:bodyPr>
+            <a:normAutofit/>
+          </a:bodyPr>
           <a:lstStyle/>
           <a:p>
             <a:pPr marL="0" indent="0">
               <a:buNone/>
             </a:pPr>
             <a:r>
-              <a:rPr lang="ru-RU" dirty="0" err="1">
+              <a:rPr lang="ru-RU" sz="2400" i="1" dirty="0" err="1" smtClean="0">
                 <a:solidFill>
-                  <a:schemeClr val="bg2">
-                    <a:lumMod val="50000"/>
-                  </a:schemeClr>
+                  <a:srgbClr val="36A9E1"/>
                 </a:solidFill>
-              </a:rPr>
-              <a:t>FaceSpace</a:t>
-            </a:r>
-            <a:r>
-              <a:rPr lang="ru-RU" dirty="0">
+                <a:latin typeface="Segoe UI" panose="020B0502040204020203" pitchFamily="34" charset="0"/>
+                <a:ea typeface="Segoe UI Black" panose="020B0A02040204020203" pitchFamily="34" charset="0"/>
+                <a:cs typeface="Segoe UI" panose="020B0502040204020203" pitchFamily="34" charset="0"/>
+              </a:rPr>
+              <a:t>Face</a:t>
+            </a:r>
+            <a:r>
+              <a:rPr lang="en-US" sz="2400" i="1" dirty="0" smtClean="0">
                 <a:solidFill>
-                  <a:schemeClr val="bg2">
-                    <a:lumMod val="50000"/>
-                  </a:schemeClr>
+                  <a:srgbClr val="36A9E1"/>
                 </a:solidFill>
-              </a:rPr>
-              <a:t> - это уникальная платформа, где ты </a:t>
-            </a:r>
-            <a:r>
-              <a:rPr lang="ru-RU" dirty="0" err="1">
+                <a:latin typeface="Segoe UI" panose="020B0502040204020203" pitchFamily="34" charset="0"/>
+                <a:ea typeface="Segoe UI Black" panose="020B0A02040204020203" pitchFamily="34" charset="0"/>
+                <a:cs typeface="Segoe UI" panose="020B0502040204020203" pitchFamily="34" charset="0"/>
+              </a:rPr>
+              <a:t> </a:t>
+            </a:r>
+            <a:r>
+              <a:rPr lang="ru-RU" sz="2400" i="1" dirty="0" err="1" smtClean="0">
                 <a:solidFill>
-                  <a:schemeClr val="bg2">
-                    <a:lumMod val="50000"/>
-                  </a:schemeClr>
+                  <a:srgbClr val="36A9E1"/>
                 </a:solidFill>
-              </a:rPr>
-              <a:t>можеь</a:t>
-            </a:r>
-            <a:r>
-              <a:rPr lang="ru-RU" dirty="0">
+                <a:latin typeface="Segoe UI" panose="020B0502040204020203" pitchFamily="34" charset="0"/>
+                <a:ea typeface="Segoe UI Black" panose="020B0A02040204020203" pitchFamily="34" charset="0"/>
+                <a:cs typeface="Segoe UI" panose="020B0502040204020203" pitchFamily="34" charset="0"/>
+              </a:rPr>
+              <a:t>Space</a:t>
+            </a:r>
+            <a:r>
+              <a:rPr lang="ru-RU" sz="2400" dirty="0" smtClean="0">
                 <a:solidFill>
-                  <a:schemeClr val="bg2">
-                    <a:lumMod val="50000"/>
-                  </a:schemeClr>
+                  <a:srgbClr val="36A9E1"/>
                 </a:solidFill>
-              </a:rPr>
-              <a:t> найти подходящего человека для деловых, дружеских, любовных и прочего рода встреч.</a:t>
+                <a:latin typeface="Segoe UI Light" panose="020B0502040204020203" pitchFamily="34" charset="0"/>
+                <a:ea typeface="Segoe UI Black" panose="020B0A02040204020203" pitchFamily="34" charset="0"/>
+                <a:cs typeface="Segoe UI Light" panose="020B0502040204020203" pitchFamily="34" charset="0"/>
+              </a:rPr>
+              <a:t> </a:t>
+            </a:r>
+            <a:r>
+              <a:rPr lang="ru-RU" sz="2400" dirty="0">
+                <a:latin typeface="Segoe UI Light" panose="020B0502040204020203" pitchFamily="34" charset="0"/>
+                <a:ea typeface="Segoe UI Black" panose="020B0A02040204020203" pitchFamily="34" charset="0"/>
+                <a:cs typeface="Segoe UI Light" panose="020B0502040204020203" pitchFamily="34" charset="0"/>
+              </a:rPr>
+              <a:t>- это уникальная платформа, где ты </a:t>
+            </a:r>
+            <a:r>
+              <a:rPr lang="ru-RU" sz="2400" dirty="0" smtClean="0">
+                <a:latin typeface="Segoe UI Light" panose="020B0502040204020203" pitchFamily="34" charset="0"/>
+                <a:ea typeface="Segoe UI Black" panose="020B0A02040204020203" pitchFamily="34" charset="0"/>
+                <a:cs typeface="Segoe UI Light" panose="020B0502040204020203" pitchFamily="34" charset="0"/>
+              </a:rPr>
+              <a:t>може</a:t>
+            </a:r>
+            <a:r>
+              <a:rPr lang="ru-RU" sz="2400" dirty="0" smtClean="0">
+                <a:latin typeface="Segoe UI Light" panose="020B0502040204020203" pitchFamily="34" charset="0"/>
+                <a:ea typeface="Segoe UI Black" panose="020B0A02040204020203" pitchFamily="34" charset="0"/>
+                <a:cs typeface="Segoe UI Light" panose="020B0502040204020203" pitchFamily="34" charset="0"/>
+              </a:rPr>
+              <a:t>шь</a:t>
+            </a:r>
+            <a:r>
+              <a:rPr lang="ru-RU" sz="2400" dirty="0" smtClean="0">
+                <a:latin typeface="Segoe UI Light" panose="020B0502040204020203" pitchFamily="34" charset="0"/>
+                <a:ea typeface="Segoe UI Black" panose="020B0A02040204020203" pitchFamily="34" charset="0"/>
+                <a:cs typeface="Segoe UI Light" panose="020B0502040204020203" pitchFamily="34" charset="0"/>
+              </a:rPr>
+              <a:t> </a:t>
+            </a:r>
+            <a:r>
+              <a:rPr lang="ru-RU" sz="2400" dirty="0">
+                <a:latin typeface="Segoe UI Light" panose="020B0502040204020203" pitchFamily="34" charset="0"/>
+                <a:ea typeface="Segoe UI Black" panose="020B0A02040204020203" pitchFamily="34" charset="0"/>
+                <a:cs typeface="Segoe UI Light" panose="020B0502040204020203" pitchFamily="34" charset="0"/>
+              </a:rPr>
+              <a:t>найти подходящего человека для деловых, </a:t>
+            </a:r>
+            <a:r>
+              <a:rPr lang="ru-RU" sz="2400" dirty="0" smtClean="0">
+                <a:latin typeface="Segoe UI Light" panose="020B0502040204020203" pitchFamily="34" charset="0"/>
+                <a:ea typeface="Segoe UI Black" panose="020B0A02040204020203" pitchFamily="34" charset="0"/>
+                <a:cs typeface="Segoe UI Light" panose="020B0502040204020203" pitchFamily="34" charset="0"/>
+              </a:rPr>
+              <a:t>дружеских</a:t>
+            </a:r>
+            <a:r>
+              <a:rPr lang="ru-RU" sz="2400" dirty="0">
+                <a:latin typeface="Segoe UI Light" panose="020B0502040204020203" pitchFamily="34" charset="0"/>
+                <a:ea typeface="Segoe UI Black" panose="020B0A02040204020203" pitchFamily="34" charset="0"/>
+                <a:cs typeface="Segoe UI Light" panose="020B0502040204020203" pitchFamily="34" charset="0"/>
+              </a:rPr>
+              <a:t> </a:t>
+            </a:r>
+            <a:r>
+              <a:rPr lang="ru-RU" sz="2400" dirty="0" smtClean="0">
+                <a:latin typeface="Segoe UI Light" panose="020B0502040204020203" pitchFamily="34" charset="0"/>
+                <a:ea typeface="Segoe UI Black" panose="020B0A02040204020203" pitchFamily="34" charset="0"/>
+                <a:cs typeface="Segoe UI Light" panose="020B0502040204020203" pitchFamily="34" charset="0"/>
+              </a:rPr>
+              <a:t>романтических</a:t>
+            </a:r>
+            <a:r>
+              <a:rPr lang="ru-RU" sz="2400" dirty="0" smtClean="0">
+                <a:latin typeface="Segoe UI Light" panose="020B0502040204020203" pitchFamily="34" charset="0"/>
+                <a:ea typeface="Segoe UI Black" panose="020B0A02040204020203" pitchFamily="34" charset="0"/>
+                <a:cs typeface="Segoe UI Light" panose="020B0502040204020203" pitchFamily="34" charset="0"/>
+              </a:rPr>
+              <a:t> </a:t>
+            </a:r>
+            <a:r>
+              <a:rPr lang="ru-RU" sz="2400" dirty="0">
+                <a:latin typeface="Segoe UI Light" panose="020B0502040204020203" pitchFamily="34" charset="0"/>
+                <a:ea typeface="Segoe UI Black" panose="020B0A02040204020203" pitchFamily="34" charset="0"/>
+                <a:cs typeface="Segoe UI Light" panose="020B0502040204020203" pitchFamily="34" charset="0"/>
+              </a:rPr>
+              <a:t>и прочего рода встреч.</a:t>
             </a:r>
           </a:p>
         </p:txBody>
@@ -4302,6 +4403,4583 @@
   <p:clrMapOvr>
     <a:masterClrMapping/>
   </p:clrMapOvr>
+  <p:timing>
+    <p:tnLst>
+      <p:par>
+        <p:cTn id="1" dur="indefinite" restart="never" nodeType="tmRoot">
+          <p:childTnLst>
+            <p:seq concurrent="1" nextAc="seek">
+              <p:cTn id="2" dur="indefinite" nodeType="mainSeq">
+                <p:childTnLst>
+                  <p:par>
+                    <p:cTn id="3" fill="hold">
+                      <p:stCondLst>
+                        <p:cond delay="indefinite"/>
+                        <p:cond evt="onBegin" delay="0">
+                          <p:tn val="2"/>
+                        </p:cond>
+                      </p:stCondLst>
+                      <p:childTnLst>
+                        <p:par>
+                          <p:cTn id="4" fill="hold">
+                            <p:stCondLst>
+                              <p:cond delay="0"/>
+                            </p:stCondLst>
+                            <p:childTnLst>
+                              <p:par>
+                                <p:cTn id="5" presetID="47" presetClass="entr" presetSubtype="0" fill="hold" grpId="0" nodeType="afterEffect">
+                                  <p:stCondLst>
+                                    <p:cond delay="0"/>
+                                  </p:stCondLst>
+                                  <p:childTnLst>
+                                    <p:set>
+                                      <p:cBhvr>
+                                        <p:cTn id="6" dur="1" fill="hold">
+                                          <p:stCondLst>
+                                            <p:cond delay="0"/>
+                                          </p:stCondLst>
+                                        </p:cTn>
+                                        <p:tgtEl>
+                                          <p:spTgt spid="2"/>
+                                        </p:tgtEl>
+                                        <p:attrNameLst>
+                                          <p:attrName>style.visibility</p:attrName>
+                                        </p:attrNameLst>
+                                      </p:cBhvr>
+                                      <p:to>
+                                        <p:strVal val="visible"/>
+                                      </p:to>
+                                    </p:set>
+                                    <p:animEffect transition="in" filter="fade">
+                                      <p:cBhvr>
+                                        <p:cTn id="7" dur="1000"/>
+                                        <p:tgtEl>
+                                          <p:spTgt spid="2"/>
+                                        </p:tgtEl>
+                                      </p:cBhvr>
+                                    </p:animEffect>
+                                    <p:anim calcmode="lin" valueType="num">
+                                      <p:cBhvr>
+                                        <p:cTn id="8" dur="1000" fill="hold"/>
+                                        <p:tgtEl>
+                                          <p:spTgt spid="2"/>
+                                        </p:tgtEl>
+                                        <p:attrNameLst>
+                                          <p:attrName>ppt_x</p:attrName>
+                                        </p:attrNameLst>
+                                      </p:cBhvr>
+                                      <p:tavLst>
+                                        <p:tav tm="0">
+                                          <p:val>
+                                            <p:strVal val="#ppt_x"/>
+                                          </p:val>
+                                        </p:tav>
+                                        <p:tav tm="100000">
+                                          <p:val>
+                                            <p:strVal val="#ppt_x"/>
+                                          </p:val>
+                                        </p:tav>
+                                      </p:tavLst>
+                                    </p:anim>
+                                    <p:anim calcmode="lin" valueType="num">
+                                      <p:cBhvr>
+                                        <p:cTn id="9" dur="1000" fill="hold"/>
+                                        <p:tgtEl>
+                                          <p:spTgt spid="2"/>
+                                        </p:tgtEl>
+                                        <p:attrNameLst>
+                                          <p:attrName>ppt_y</p:attrName>
+                                        </p:attrNameLst>
+                                      </p:cBhvr>
+                                      <p:tavLst>
+                                        <p:tav tm="0">
+                                          <p:val>
+                                            <p:strVal val="#ppt_y-.1"/>
+                                          </p:val>
+                                        </p:tav>
+                                        <p:tav tm="100000">
+                                          <p:val>
+                                            <p:strVal val="#ppt_y"/>
+                                          </p:val>
+                                        </p:tav>
+                                      </p:tavLst>
+                                    </p:anim>
+                                  </p:childTnLst>
+                                </p:cTn>
+                              </p:par>
+                            </p:childTnLst>
+                          </p:cTn>
+                        </p:par>
+                        <p:par>
+                          <p:cTn id="10" fill="hold">
+                            <p:stCondLst>
+                              <p:cond delay="1000"/>
+                            </p:stCondLst>
+                            <p:childTnLst>
+                              <p:par>
+                                <p:cTn id="11" presetID="10" presetClass="entr" presetSubtype="0" fill="hold" nodeType="afterEffect">
+                                  <p:stCondLst>
+                                    <p:cond delay="0"/>
+                                  </p:stCondLst>
+                                  <p:childTnLst>
+                                    <p:set>
+                                      <p:cBhvr>
+                                        <p:cTn id="12" dur="1" fill="hold">
+                                          <p:stCondLst>
+                                            <p:cond delay="0"/>
+                                          </p:stCondLst>
+                                        </p:cTn>
+                                        <p:tgtEl>
+                                          <p:spTgt spid="3">
+                                            <p:txEl>
+                                              <p:pRg st="0" end="0"/>
+                                            </p:txEl>
+                                          </p:spTgt>
+                                        </p:tgtEl>
+                                        <p:attrNameLst>
+                                          <p:attrName>style.visibility</p:attrName>
+                                        </p:attrNameLst>
+                                      </p:cBhvr>
+                                      <p:to>
+                                        <p:strVal val="visible"/>
+                                      </p:to>
+                                    </p:set>
+                                    <p:animEffect transition="in" filter="fade">
+                                      <p:cBhvr>
+                                        <p:cTn id="13" dur="500"/>
+                                        <p:tgtEl>
+                                          <p:spTgt spid="3">
+                                            <p:txEl>
+                                              <p:pRg st="0" end="0"/>
+                                            </p:txEl>
+                                          </p:spTgt>
+                                        </p:tgtEl>
+                                      </p:cBhvr>
+                                    </p:animEffect>
+                                  </p:childTnLst>
+                                </p:cTn>
+                              </p:par>
+                            </p:childTnLst>
+                          </p:cTn>
+                        </p:par>
+                      </p:childTnLst>
+                    </p:cTn>
+                  </p:par>
+                </p:childTnLst>
+              </p:cTn>
+              <p:prevCondLst>
+                <p:cond evt="onPrev" delay="0">
+                  <p:tgtEl>
+                    <p:sldTgt/>
+                  </p:tgtEl>
+                </p:cond>
+              </p:prevCondLst>
+              <p:nextCondLst>
+                <p:cond evt="onNext" delay="0">
+                  <p:tgtEl>
+                    <p:sldTgt/>
+                  </p:tgtEl>
+                </p:cond>
+              </p:nextCondLst>
+            </p:seq>
+          </p:childTnLst>
+        </p:cTn>
+      </p:par>
+    </p:tnLst>
+    <p:bldLst>
+      <p:bldP spid="2" grpId="0"/>
+    </p:bldLst>
+  </p:timing>
+</p:sld>
+</file>
+
+<file path=ppt/slides/slide3.xml><?xml version="1.0" encoding="utf-8"?>
+<p:sld xmlns:a="http://schemas.openxmlformats.org/drawingml/2006/main" xmlns:r="http://schemas.openxmlformats.org/officeDocument/2006/relationships" xmlns:p="http://schemas.openxmlformats.org/presentationml/2006/main">
+  <p:cSld>
+    <p:spTree>
+      <p:nvGrpSpPr>
+        <p:cNvPr id="1" name=""/>
+        <p:cNvGrpSpPr/>
+        <p:nvPr/>
+      </p:nvGrpSpPr>
+      <p:grpSpPr>
+        <a:xfrm>
+          <a:off x="0" y="0"/>
+          <a:ext cx="0" cy="0"/>
+          <a:chOff x="0" y="0"/>
+          <a:chExt cx="0" cy="0"/>
+        </a:xfrm>
+      </p:grpSpPr>
+      <p:sp>
+        <p:nvSpPr>
+          <p:cNvPr id="2" name="Заголовок 1">
+            <a:extLst>
+              <a:ext uri="{FF2B5EF4-FFF2-40B4-BE49-F238E27FC236}">
+                <a16:creationId xmlns:a16="http://schemas.microsoft.com/office/drawing/2014/main" id="{F209A495-8E3F-4CFE-86E0-75920089882B}"/>
+              </a:ext>
+            </a:extLst>
+          </p:cNvPr>
+          <p:cNvSpPr>
+            <a:spLocks noGrp="1"/>
+          </p:cNvSpPr>
+          <p:nvPr>
+            <p:ph type="title"/>
+          </p:nvPr>
+        </p:nvSpPr>
+        <p:spPr/>
+        <p:txBody>
+          <a:bodyPr>
+            <a:normAutofit/>
+          </a:bodyPr>
+          <a:lstStyle/>
+          <a:p>
+            <a:pPr algn="ctr"/>
+            <a:r>
+              <a:rPr lang="ru-RU" sz="4000" dirty="0" smtClean="0">
+                <a:solidFill>
+                  <a:srgbClr val="36A9E1"/>
+                </a:solidFill>
+                <a:latin typeface="Segoe UI Black" panose="020B0A02040204020203" pitchFamily="34" charset="0"/>
+                <a:ea typeface="Segoe UI Black" panose="020B0A02040204020203" pitchFamily="34" charset="0"/>
+              </a:rPr>
+              <a:t>Технические задачи</a:t>
+            </a:r>
+            <a:endParaRPr lang="ru-RU" sz="4000" dirty="0">
+              <a:solidFill>
+                <a:srgbClr val="36A9E1"/>
+              </a:solidFill>
+              <a:latin typeface="Segoe UI Black" panose="020B0A02040204020203" pitchFamily="34" charset="0"/>
+              <a:ea typeface="Segoe UI Black" panose="020B0A02040204020203" pitchFamily="34" charset="0"/>
+            </a:endParaRPr>
+          </a:p>
+        </p:txBody>
+      </p:sp>
+      <p:sp>
+        <p:nvSpPr>
+          <p:cNvPr id="3" name="Объект 2">
+            <a:extLst>
+              <a:ext uri="{FF2B5EF4-FFF2-40B4-BE49-F238E27FC236}">
+                <a16:creationId xmlns:a16="http://schemas.microsoft.com/office/drawing/2014/main" id="{6B41888E-AA9C-4D55-AAD7-6D821BC62010}"/>
+              </a:ext>
+            </a:extLst>
+          </p:cNvPr>
+          <p:cNvSpPr>
+            <a:spLocks noGrp="1"/>
+          </p:cNvSpPr>
+          <p:nvPr>
+            <p:ph idx="1"/>
+          </p:nvPr>
+        </p:nvSpPr>
+        <p:spPr>
+          <a:xfrm>
+            <a:off x="480060" y="1767436"/>
+            <a:ext cx="11231880" cy="4351338"/>
+          </a:xfrm>
+        </p:spPr>
+        <p:txBody>
+          <a:bodyPr>
+            <a:noAutofit/>
+          </a:bodyPr>
+          <a:lstStyle/>
+          <a:p>
+            <a:pPr marL="0" indent="0">
+              <a:buNone/>
+            </a:pPr>
+            <a:r>
+              <a:rPr lang="ru-RU" sz="2400" dirty="0">
+                <a:latin typeface="Segoe UI Light" panose="020B0502040204020203" pitchFamily="34" charset="0"/>
+                <a:ea typeface="Segoe UI Black" panose="020B0A02040204020203" pitchFamily="34" charset="0"/>
+                <a:cs typeface="Segoe UI Light" panose="020B0502040204020203" pitchFamily="34" charset="0"/>
+              </a:rPr>
+              <a:t>1) При помощи библиотеки </a:t>
+            </a:r>
+            <a:r>
+              <a:rPr lang="ru-RU" sz="2400" b="1" i="1" dirty="0" err="1">
+                <a:solidFill>
+                  <a:srgbClr val="36A9E1"/>
+                </a:solidFill>
+                <a:latin typeface="Segoe UI Light" panose="020B0502040204020203" pitchFamily="34" charset="0"/>
+                <a:ea typeface="Segoe UI Black" panose="020B0A02040204020203" pitchFamily="34" charset="0"/>
+                <a:cs typeface="Segoe UI Light" panose="020B0502040204020203" pitchFamily="34" charset="0"/>
+              </a:rPr>
+              <a:t>flask</a:t>
+            </a:r>
+            <a:r>
+              <a:rPr lang="ru-RU" sz="2400" dirty="0">
+                <a:latin typeface="Segoe UI Light" panose="020B0502040204020203" pitchFamily="34" charset="0"/>
+                <a:ea typeface="Segoe UI Black" panose="020B0A02040204020203" pitchFamily="34" charset="0"/>
+                <a:cs typeface="Segoe UI Light" panose="020B0502040204020203" pitchFamily="34" charset="0"/>
+              </a:rPr>
+              <a:t> создать серверное приложение</a:t>
+            </a:r>
+          </a:p>
+          <a:p>
+            <a:pPr marL="0" indent="0">
+              <a:buNone/>
+            </a:pPr>
+            <a:r>
+              <a:rPr lang="ru-RU" sz="2400" dirty="0">
+                <a:latin typeface="Segoe UI Light" panose="020B0502040204020203" pitchFamily="34" charset="0"/>
+                <a:ea typeface="Segoe UI Black" panose="020B0A02040204020203" pitchFamily="34" charset="0"/>
+                <a:cs typeface="Segoe UI Light" panose="020B0502040204020203" pitchFamily="34" charset="0"/>
+              </a:rPr>
+              <a:t>2) При помощи библиотеки </a:t>
+            </a:r>
+            <a:r>
+              <a:rPr lang="ru-RU" sz="2400" b="1" i="1" dirty="0" err="1">
+                <a:solidFill>
+                  <a:srgbClr val="36A9E1"/>
+                </a:solidFill>
+                <a:latin typeface="Segoe UI Light" panose="020B0502040204020203" pitchFamily="34" charset="0"/>
+                <a:ea typeface="Segoe UI Black" panose="020B0A02040204020203" pitchFamily="34" charset="0"/>
+                <a:cs typeface="Segoe UI Light" panose="020B0502040204020203" pitchFamily="34" charset="0"/>
+              </a:rPr>
+              <a:t>sqlalchemy</a:t>
+            </a:r>
+            <a:r>
+              <a:rPr lang="ru-RU" sz="2400" dirty="0">
+                <a:latin typeface="Segoe UI Light" panose="020B0502040204020203" pitchFamily="34" charset="0"/>
+                <a:ea typeface="Segoe UI Black" panose="020B0A02040204020203" pitchFamily="34" charset="0"/>
+                <a:cs typeface="Segoe UI Light" panose="020B0502040204020203" pitchFamily="34" charset="0"/>
+              </a:rPr>
+              <a:t> реализовать взаимодействие с базой данных</a:t>
+            </a:r>
+          </a:p>
+          <a:p>
+            <a:pPr marL="0" indent="0">
+              <a:buNone/>
+            </a:pPr>
+            <a:r>
+              <a:rPr lang="ru-RU" sz="2400" dirty="0">
+                <a:latin typeface="Segoe UI Light" panose="020B0502040204020203" pitchFamily="34" charset="0"/>
+                <a:ea typeface="Segoe UI Black" panose="020B0A02040204020203" pitchFamily="34" charset="0"/>
+                <a:cs typeface="Segoe UI Light" panose="020B0502040204020203" pitchFamily="34" charset="0"/>
+              </a:rPr>
+              <a:t>3) Добавить модель данных пользователя, объявления, категории объявления, действия</a:t>
+            </a:r>
+          </a:p>
+          <a:p>
+            <a:pPr marL="0" indent="0">
+              <a:buNone/>
+            </a:pPr>
+            <a:r>
+              <a:rPr lang="ru-RU" sz="2400" dirty="0">
+                <a:latin typeface="Segoe UI Light" panose="020B0502040204020203" pitchFamily="34" charset="0"/>
+                <a:ea typeface="Segoe UI Black" panose="020B0A02040204020203" pitchFamily="34" charset="0"/>
+                <a:cs typeface="Segoe UI Light" panose="020B0502040204020203" pitchFamily="34" charset="0"/>
+              </a:rPr>
+              <a:t>4) Разработать главную страницу сайта</a:t>
+            </a:r>
+          </a:p>
+          <a:p>
+            <a:pPr marL="0" indent="0">
+              <a:buNone/>
+            </a:pPr>
+            <a:r>
+              <a:rPr lang="ru-RU" sz="2400" dirty="0">
+                <a:latin typeface="Segoe UI Light" panose="020B0502040204020203" pitchFamily="34" charset="0"/>
+                <a:ea typeface="Segoe UI Black" panose="020B0A02040204020203" pitchFamily="34" charset="0"/>
+                <a:cs typeface="Segoe UI Light" panose="020B0502040204020203" pitchFamily="34" charset="0"/>
+              </a:rPr>
+              <a:t>5) Разработать страницу входа и </a:t>
+            </a:r>
+            <a:r>
+              <a:rPr lang="ru-RU" sz="2400" dirty="0" err="1">
+                <a:latin typeface="Segoe UI Light" panose="020B0502040204020203" pitchFamily="34" charset="0"/>
+                <a:ea typeface="Segoe UI Black" panose="020B0A02040204020203" pitchFamily="34" charset="0"/>
+                <a:cs typeface="Segoe UI Light" panose="020B0502040204020203" pitchFamily="34" charset="0"/>
+              </a:rPr>
+              <a:t>регистрации,а</a:t>
+            </a:r>
+            <a:r>
+              <a:rPr lang="ru-RU" sz="2400" dirty="0">
+                <a:latin typeface="Segoe UI Light" panose="020B0502040204020203" pitchFamily="34" charset="0"/>
+                <a:ea typeface="Segoe UI Black" panose="020B0A02040204020203" pitchFamily="34" charset="0"/>
+                <a:cs typeface="Segoe UI Light" panose="020B0502040204020203" pitchFamily="34" charset="0"/>
+              </a:rPr>
+              <a:t> также реализовать регистрацию и вход пользователя на </a:t>
+            </a:r>
+            <a:r>
+              <a:rPr lang="ru-RU" sz="2400" dirty="0" err="1">
+                <a:latin typeface="Segoe UI Light" panose="020B0502040204020203" pitchFamily="34" charset="0"/>
+                <a:ea typeface="Segoe UI Black" panose="020B0A02040204020203" pitchFamily="34" charset="0"/>
+                <a:cs typeface="Segoe UI Light" panose="020B0502040204020203" pitchFamily="34" charset="0"/>
+              </a:rPr>
+              <a:t>бэкенде</a:t>
+            </a:r>
+            <a:r>
+              <a:rPr lang="ru-RU" sz="2400" dirty="0" smtClean="0">
+                <a:latin typeface="Segoe UI Light" panose="020B0502040204020203" pitchFamily="34" charset="0"/>
+                <a:ea typeface="Segoe UI Black" panose="020B0A02040204020203" pitchFamily="34" charset="0"/>
+                <a:cs typeface="Segoe UI Light" panose="020B0502040204020203" pitchFamily="34" charset="0"/>
+              </a:rPr>
+              <a:t>.</a:t>
+            </a:r>
+            <a:endParaRPr lang="ru-RU" sz="2400" dirty="0">
+              <a:latin typeface="Segoe UI Light" panose="020B0502040204020203" pitchFamily="34" charset="0"/>
+              <a:ea typeface="Segoe UI Black" panose="020B0A02040204020203" pitchFamily="34" charset="0"/>
+              <a:cs typeface="Segoe UI Light" panose="020B0502040204020203" pitchFamily="34" charset="0"/>
+            </a:endParaRPr>
+          </a:p>
+        </p:txBody>
+      </p:sp>
+    </p:spTree>
+    <p:extLst>
+      <p:ext uri="{BB962C8B-B14F-4D97-AF65-F5344CB8AC3E}">
+        <p14:creationId xmlns:p14="http://schemas.microsoft.com/office/powerpoint/2010/main" val="2494177753"/>
+      </p:ext>
+    </p:extLst>
+  </p:cSld>
+  <p:clrMapOvr>
+    <a:masterClrMapping/>
+  </p:clrMapOvr>
+  <p:timing>
+    <p:tnLst>
+      <p:par>
+        <p:cTn id="1" dur="indefinite" restart="never" nodeType="tmRoot">
+          <p:childTnLst>
+            <p:seq concurrent="1" nextAc="seek">
+              <p:cTn id="2" dur="indefinite" nodeType="mainSeq">
+                <p:childTnLst>
+                  <p:par>
+                    <p:cTn id="3" fill="hold">
+                      <p:stCondLst>
+                        <p:cond delay="indefinite"/>
+                        <p:cond evt="onBegin" delay="0">
+                          <p:tn val="2"/>
+                        </p:cond>
+                      </p:stCondLst>
+                      <p:childTnLst>
+                        <p:par>
+                          <p:cTn id="4" fill="hold">
+                            <p:stCondLst>
+                              <p:cond delay="0"/>
+                            </p:stCondLst>
+                            <p:childTnLst>
+                              <p:par>
+                                <p:cTn id="5" presetID="47" presetClass="entr" presetSubtype="0" fill="hold" grpId="0" nodeType="afterEffect">
+                                  <p:stCondLst>
+                                    <p:cond delay="0"/>
+                                  </p:stCondLst>
+                                  <p:childTnLst>
+                                    <p:set>
+                                      <p:cBhvr>
+                                        <p:cTn id="6" dur="1" fill="hold">
+                                          <p:stCondLst>
+                                            <p:cond delay="0"/>
+                                          </p:stCondLst>
+                                        </p:cTn>
+                                        <p:tgtEl>
+                                          <p:spTgt spid="2"/>
+                                        </p:tgtEl>
+                                        <p:attrNameLst>
+                                          <p:attrName>style.visibility</p:attrName>
+                                        </p:attrNameLst>
+                                      </p:cBhvr>
+                                      <p:to>
+                                        <p:strVal val="visible"/>
+                                      </p:to>
+                                    </p:set>
+                                    <p:animEffect transition="in" filter="fade">
+                                      <p:cBhvr>
+                                        <p:cTn id="7" dur="1000"/>
+                                        <p:tgtEl>
+                                          <p:spTgt spid="2"/>
+                                        </p:tgtEl>
+                                      </p:cBhvr>
+                                    </p:animEffect>
+                                    <p:anim calcmode="lin" valueType="num">
+                                      <p:cBhvr>
+                                        <p:cTn id="8" dur="1000" fill="hold"/>
+                                        <p:tgtEl>
+                                          <p:spTgt spid="2"/>
+                                        </p:tgtEl>
+                                        <p:attrNameLst>
+                                          <p:attrName>ppt_x</p:attrName>
+                                        </p:attrNameLst>
+                                      </p:cBhvr>
+                                      <p:tavLst>
+                                        <p:tav tm="0">
+                                          <p:val>
+                                            <p:strVal val="#ppt_x"/>
+                                          </p:val>
+                                        </p:tav>
+                                        <p:tav tm="100000">
+                                          <p:val>
+                                            <p:strVal val="#ppt_x"/>
+                                          </p:val>
+                                        </p:tav>
+                                      </p:tavLst>
+                                    </p:anim>
+                                    <p:anim calcmode="lin" valueType="num">
+                                      <p:cBhvr>
+                                        <p:cTn id="9" dur="1000" fill="hold"/>
+                                        <p:tgtEl>
+                                          <p:spTgt spid="2"/>
+                                        </p:tgtEl>
+                                        <p:attrNameLst>
+                                          <p:attrName>ppt_y</p:attrName>
+                                        </p:attrNameLst>
+                                      </p:cBhvr>
+                                      <p:tavLst>
+                                        <p:tav tm="0">
+                                          <p:val>
+                                            <p:strVal val="#ppt_y-.1"/>
+                                          </p:val>
+                                        </p:tav>
+                                        <p:tav tm="100000">
+                                          <p:val>
+                                            <p:strVal val="#ppt_y"/>
+                                          </p:val>
+                                        </p:tav>
+                                      </p:tavLst>
+                                    </p:anim>
+                                  </p:childTnLst>
+                                </p:cTn>
+                              </p:par>
+                            </p:childTnLst>
+                          </p:cTn>
+                        </p:par>
+                        <p:par>
+                          <p:cTn id="10" fill="hold">
+                            <p:stCondLst>
+                              <p:cond delay="1000"/>
+                            </p:stCondLst>
+                            <p:childTnLst>
+                              <p:par>
+                                <p:cTn id="11" presetID="10" presetClass="entr" presetSubtype="0" fill="hold" nodeType="afterEffect">
+                                  <p:stCondLst>
+                                    <p:cond delay="0"/>
+                                  </p:stCondLst>
+                                  <p:childTnLst>
+                                    <p:set>
+                                      <p:cBhvr>
+                                        <p:cTn id="12" dur="1" fill="hold">
+                                          <p:stCondLst>
+                                            <p:cond delay="0"/>
+                                          </p:stCondLst>
+                                        </p:cTn>
+                                        <p:tgtEl>
+                                          <p:spTgt spid="3">
+                                            <p:txEl>
+                                              <p:pRg st="0" end="0"/>
+                                            </p:txEl>
+                                          </p:spTgt>
+                                        </p:tgtEl>
+                                        <p:attrNameLst>
+                                          <p:attrName>style.visibility</p:attrName>
+                                        </p:attrNameLst>
+                                      </p:cBhvr>
+                                      <p:to>
+                                        <p:strVal val="visible"/>
+                                      </p:to>
+                                    </p:set>
+                                    <p:animEffect transition="in" filter="fade">
+                                      <p:cBhvr>
+                                        <p:cTn id="13" dur="500"/>
+                                        <p:tgtEl>
+                                          <p:spTgt spid="3">
+                                            <p:txEl>
+                                              <p:pRg st="0" end="0"/>
+                                            </p:txEl>
+                                          </p:spTgt>
+                                        </p:tgtEl>
+                                      </p:cBhvr>
+                                    </p:animEffect>
+                                  </p:childTnLst>
+                                </p:cTn>
+                              </p:par>
+                            </p:childTnLst>
+                          </p:cTn>
+                        </p:par>
+                        <p:par>
+                          <p:cTn id="14" fill="hold">
+                            <p:stCondLst>
+                              <p:cond delay="1500"/>
+                            </p:stCondLst>
+                            <p:childTnLst>
+                              <p:par>
+                                <p:cTn id="15" presetID="10" presetClass="entr" presetSubtype="0" fill="hold" nodeType="afterEffect">
+                                  <p:stCondLst>
+                                    <p:cond delay="0"/>
+                                  </p:stCondLst>
+                                  <p:childTnLst>
+                                    <p:set>
+                                      <p:cBhvr>
+                                        <p:cTn id="16" dur="1" fill="hold">
+                                          <p:stCondLst>
+                                            <p:cond delay="0"/>
+                                          </p:stCondLst>
+                                        </p:cTn>
+                                        <p:tgtEl>
+                                          <p:spTgt spid="3">
+                                            <p:txEl>
+                                              <p:pRg st="1" end="1"/>
+                                            </p:txEl>
+                                          </p:spTgt>
+                                        </p:tgtEl>
+                                        <p:attrNameLst>
+                                          <p:attrName>style.visibility</p:attrName>
+                                        </p:attrNameLst>
+                                      </p:cBhvr>
+                                      <p:to>
+                                        <p:strVal val="visible"/>
+                                      </p:to>
+                                    </p:set>
+                                    <p:animEffect transition="in" filter="fade">
+                                      <p:cBhvr>
+                                        <p:cTn id="17" dur="500"/>
+                                        <p:tgtEl>
+                                          <p:spTgt spid="3">
+                                            <p:txEl>
+                                              <p:pRg st="1" end="1"/>
+                                            </p:txEl>
+                                          </p:spTgt>
+                                        </p:tgtEl>
+                                      </p:cBhvr>
+                                    </p:animEffect>
+                                  </p:childTnLst>
+                                </p:cTn>
+                              </p:par>
+                            </p:childTnLst>
+                          </p:cTn>
+                        </p:par>
+                        <p:par>
+                          <p:cTn id="18" fill="hold">
+                            <p:stCondLst>
+                              <p:cond delay="2000"/>
+                            </p:stCondLst>
+                            <p:childTnLst>
+                              <p:par>
+                                <p:cTn id="19" presetID="10" presetClass="entr" presetSubtype="0" fill="hold" nodeType="afterEffect">
+                                  <p:stCondLst>
+                                    <p:cond delay="0"/>
+                                  </p:stCondLst>
+                                  <p:childTnLst>
+                                    <p:set>
+                                      <p:cBhvr>
+                                        <p:cTn id="20" dur="1" fill="hold">
+                                          <p:stCondLst>
+                                            <p:cond delay="0"/>
+                                          </p:stCondLst>
+                                        </p:cTn>
+                                        <p:tgtEl>
+                                          <p:spTgt spid="3">
+                                            <p:txEl>
+                                              <p:pRg st="2" end="2"/>
+                                            </p:txEl>
+                                          </p:spTgt>
+                                        </p:tgtEl>
+                                        <p:attrNameLst>
+                                          <p:attrName>style.visibility</p:attrName>
+                                        </p:attrNameLst>
+                                      </p:cBhvr>
+                                      <p:to>
+                                        <p:strVal val="visible"/>
+                                      </p:to>
+                                    </p:set>
+                                    <p:animEffect transition="in" filter="fade">
+                                      <p:cBhvr>
+                                        <p:cTn id="21" dur="500"/>
+                                        <p:tgtEl>
+                                          <p:spTgt spid="3">
+                                            <p:txEl>
+                                              <p:pRg st="2" end="2"/>
+                                            </p:txEl>
+                                          </p:spTgt>
+                                        </p:tgtEl>
+                                      </p:cBhvr>
+                                    </p:animEffect>
+                                  </p:childTnLst>
+                                </p:cTn>
+                              </p:par>
+                            </p:childTnLst>
+                          </p:cTn>
+                        </p:par>
+                        <p:par>
+                          <p:cTn id="22" fill="hold">
+                            <p:stCondLst>
+                              <p:cond delay="2500"/>
+                            </p:stCondLst>
+                            <p:childTnLst>
+                              <p:par>
+                                <p:cTn id="23" presetID="10" presetClass="entr" presetSubtype="0" fill="hold" nodeType="afterEffect">
+                                  <p:stCondLst>
+                                    <p:cond delay="0"/>
+                                  </p:stCondLst>
+                                  <p:childTnLst>
+                                    <p:set>
+                                      <p:cBhvr>
+                                        <p:cTn id="24" dur="1" fill="hold">
+                                          <p:stCondLst>
+                                            <p:cond delay="0"/>
+                                          </p:stCondLst>
+                                        </p:cTn>
+                                        <p:tgtEl>
+                                          <p:spTgt spid="3">
+                                            <p:txEl>
+                                              <p:pRg st="3" end="3"/>
+                                            </p:txEl>
+                                          </p:spTgt>
+                                        </p:tgtEl>
+                                        <p:attrNameLst>
+                                          <p:attrName>style.visibility</p:attrName>
+                                        </p:attrNameLst>
+                                      </p:cBhvr>
+                                      <p:to>
+                                        <p:strVal val="visible"/>
+                                      </p:to>
+                                    </p:set>
+                                    <p:animEffect transition="in" filter="fade">
+                                      <p:cBhvr>
+                                        <p:cTn id="25" dur="500"/>
+                                        <p:tgtEl>
+                                          <p:spTgt spid="3">
+                                            <p:txEl>
+                                              <p:pRg st="3" end="3"/>
+                                            </p:txEl>
+                                          </p:spTgt>
+                                        </p:tgtEl>
+                                      </p:cBhvr>
+                                    </p:animEffect>
+                                  </p:childTnLst>
+                                </p:cTn>
+                              </p:par>
+                            </p:childTnLst>
+                          </p:cTn>
+                        </p:par>
+                        <p:par>
+                          <p:cTn id="26" fill="hold">
+                            <p:stCondLst>
+                              <p:cond delay="3000"/>
+                            </p:stCondLst>
+                            <p:childTnLst>
+                              <p:par>
+                                <p:cTn id="27" presetID="10" presetClass="entr" presetSubtype="0" fill="hold" nodeType="afterEffect">
+                                  <p:stCondLst>
+                                    <p:cond delay="0"/>
+                                  </p:stCondLst>
+                                  <p:childTnLst>
+                                    <p:set>
+                                      <p:cBhvr>
+                                        <p:cTn id="28" dur="1" fill="hold">
+                                          <p:stCondLst>
+                                            <p:cond delay="0"/>
+                                          </p:stCondLst>
+                                        </p:cTn>
+                                        <p:tgtEl>
+                                          <p:spTgt spid="3">
+                                            <p:txEl>
+                                              <p:pRg st="4" end="4"/>
+                                            </p:txEl>
+                                          </p:spTgt>
+                                        </p:tgtEl>
+                                        <p:attrNameLst>
+                                          <p:attrName>style.visibility</p:attrName>
+                                        </p:attrNameLst>
+                                      </p:cBhvr>
+                                      <p:to>
+                                        <p:strVal val="visible"/>
+                                      </p:to>
+                                    </p:set>
+                                    <p:animEffect transition="in" filter="fade">
+                                      <p:cBhvr>
+                                        <p:cTn id="29" dur="500"/>
+                                        <p:tgtEl>
+                                          <p:spTgt spid="3">
+                                            <p:txEl>
+                                              <p:pRg st="4" end="4"/>
+                                            </p:txEl>
+                                          </p:spTgt>
+                                        </p:tgtEl>
+                                      </p:cBhvr>
+                                    </p:animEffect>
+                                  </p:childTnLst>
+                                </p:cTn>
+                              </p:par>
+                            </p:childTnLst>
+                          </p:cTn>
+                        </p:par>
+                      </p:childTnLst>
+                    </p:cTn>
+                  </p:par>
+                </p:childTnLst>
+              </p:cTn>
+              <p:prevCondLst>
+                <p:cond evt="onPrev" delay="0">
+                  <p:tgtEl>
+                    <p:sldTgt/>
+                  </p:tgtEl>
+                </p:cond>
+              </p:prevCondLst>
+              <p:nextCondLst>
+                <p:cond evt="onNext" delay="0">
+                  <p:tgtEl>
+                    <p:sldTgt/>
+                  </p:tgtEl>
+                </p:cond>
+              </p:nextCondLst>
+            </p:seq>
+          </p:childTnLst>
+        </p:cTn>
+      </p:par>
+    </p:tnLst>
+    <p:bldLst>
+      <p:bldP spid="2" grpId="0"/>
+    </p:bldLst>
+  </p:timing>
+</p:sld>
+</file>
+
+<file path=ppt/slides/slide4.xml><?xml version="1.0" encoding="utf-8"?>
+<p:sld xmlns:a="http://schemas.openxmlformats.org/drawingml/2006/main" xmlns:r="http://schemas.openxmlformats.org/officeDocument/2006/relationships" xmlns:p="http://schemas.openxmlformats.org/presentationml/2006/main">
+  <p:cSld>
+    <p:spTree>
+      <p:nvGrpSpPr>
+        <p:cNvPr id="1" name=""/>
+        <p:cNvGrpSpPr/>
+        <p:nvPr/>
+      </p:nvGrpSpPr>
+      <p:grpSpPr>
+        <a:xfrm>
+          <a:off x="0" y="0"/>
+          <a:ext cx="0" cy="0"/>
+          <a:chOff x="0" y="0"/>
+          <a:chExt cx="0" cy="0"/>
+        </a:xfrm>
+      </p:grpSpPr>
+      <p:sp>
+        <p:nvSpPr>
+          <p:cNvPr id="2" name="Заголовок 1">
+            <a:extLst>
+              <a:ext uri="{FF2B5EF4-FFF2-40B4-BE49-F238E27FC236}">
+                <a16:creationId xmlns:a16="http://schemas.microsoft.com/office/drawing/2014/main" id="{F209A495-8E3F-4CFE-86E0-75920089882B}"/>
+              </a:ext>
+            </a:extLst>
+          </p:cNvPr>
+          <p:cNvSpPr>
+            <a:spLocks noGrp="1"/>
+          </p:cNvSpPr>
+          <p:nvPr>
+            <p:ph type="title"/>
+          </p:nvPr>
+        </p:nvSpPr>
+        <p:spPr/>
+        <p:txBody>
+          <a:bodyPr>
+            <a:normAutofit/>
+          </a:bodyPr>
+          <a:lstStyle/>
+          <a:p>
+            <a:pPr algn="ctr"/>
+            <a:r>
+              <a:rPr lang="ru-RU" sz="4000" dirty="0" smtClean="0">
+                <a:solidFill>
+                  <a:srgbClr val="36A9E1"/>
+                </a:solidFill>
+                <a:latin typeface="Segoe UI Black" panose="020B0A02040204020203" pitchFamily="34" charset="0"/>
+                <a:ea typeface="Segoe UI Black" panose="020B0A02040204020203" pitchFamily="34" charset="0"/>
+              </a:rPr>
+              <a:t>Технические задачи</a:t>
+            </a:r>
+            <a:endParaRPr lang="ru-RU" sz="4000" dirty="0">
+              <a:solidFill>
+                <a:srgbClr val="36A9E1"/>
+              </a:solidFill>
+              <a:latin typeface="Segoe UI Black" panose="020B0A02040204020203" pitchFamily="34" charset="0"/>
+              <a:ea typeface="Segoe UI Black" panose="020B0A02040204020203" pitchFamily="34" charset="0"/>
+            </a:endParaRPr>
+          </a:p>
+        </p:txBody>
+      </p:sp>
+      <p:sp>
+        <p:nvSpPr>
+          <p:cNvPr id="3" name="Объект 2">
+            <a:extLst>
+              <a:ext uri="{FF2B5EF4-FFF2-40B4-BE49-F238E27FC236}">
+                <a16:creationId xmlns:a16="http://schemas.microsoft.com/office/drawing/2014/main" id="{6B41888E-AA9C-4D55-AAD7-6D821BC62010}"/>
+              </a:ext>
+            </a:extLst>
+          </p:cNvPr>
+          <p:cNvSpPr>
+            <a:spLocks noGrp="1"/>
+          </p:cNvSpPr>
+          <p:nvPr>
+            <p:ph idx="1"/>
+          </p:nvPr>
+        </p:nvSpPr>
+        <p:spPr>
+          <a:xfrm>
+            <a:off x="480060" y="1690688"/>
+            <a:ext cx="11231880" cy="4351338"/>
+          </a:xfrm>
+        </p:spPr>
+        <p:txBody>
+          <a:bodyPr>
+            <a:noAutofit/>
+          </a:bodyPr>
+          <a:lstStyle/>
+          <a:p>
+            <a:pPr marL="0" indent="0">
+              <a:buNone/>
+            </a:pPr>
+            <a:r>
+              <a:rPr lang="ru-RU" sz="2400" dirty="0">
+                <a:latin typeface="Segoe UI Light" panose="020B0502040204020203" pitchFamily="34" charset="0"/>
+                <a:ea typeface="Segoe UI Black" panose="020B0A02040204020203" pitchFamily="34" charset="0"/>
+                <a:cs typeface="Segoe UI Light" panose="020B0502040204020203" pitchFamily="34" charset="0"/>
+              </a:rPr>
+              <a:t>6) Разработать страницу профиля пользователя.</a:t>
+            </a:r>
+          </a:p>
+          <a:p>
+            <a:pPr marL="0" indent="0">
+              <a:buNone/>
+            </a:pPr>
+            <a:r>
+              <a:rPr lang="ru-RU" sz="2400" dirty="0">
+                <a:latin typeface="Segoe UI Light" panose="020B0502040204020203" pitchFamily="34" charset="0"/>
+                <a:ea typeface="Segoe UI Black" panose="020B0A02040204020203" pitchFamily="34" charset="0"/>
+                <a:cs typeface="Segoe UI Light" panose="020B0502040204020203" pitchFamily="34" charset="0"/>
+              </a:rPr>
+              <a:t>7) Разработать страницу объявления.</a:t>
+            </a:r>
+          </a:p>
+          <a:p>
+            <a:pPr marL="0" indent="0">
+              <a:buNone/>
+            </a:pPr>
+            <a:r>
+              <a:rPr lang="ru-RU" sz="2400" dirty="0">
+                <a:latin typeface="Segoe UI Light" panose="020B0502040204020203" pitchFamily="34" charset="0"/>
+                <a:ea typeface="Segoe UI Black" panose="020B0A02040204020203" pitchFamily="34" charset="0"/>
+                <a:cs typeface="Segoe UI Light" panose="020B0502040204020203" pitchFamily="34" charset="0"/>
+              </a:rPr>
+              <a:t>8) Разработать страницу настроек.</a:t>
+            </a:r>
+          </a:p>
+          <a:p>
+            <a:pPr marL="0" indent="0">
+              <a:buNone/>
+            </a:pPr>
+            <a:r>
+              <a:rPr lang="ru-RU" sz="2400" dirty="0">
+                <a:latin typeface="Segoe UI Light" panose="020B0502040204020203" pitchFamily="34" charset="0"/>
+                <a:ea typeface="Segoe UI Black" panose="020B0A02040204020203" pitchFamily="34" charset="0"/>
+                <a:cs typeface="Segoe UI Light" panose="020B0502040204020203" pitchFamily="34" charset="0"/>
+              </a:rPr>
+              <a:t>9) Добавить возможность создания и редактирования  объявления</a:t>
+            </a:r>
+          </a:p>
+          <a:p>
+            <a:pPr marL="0" indent="0">
+              <a:buNone/>
+            </a:pPr>
+            <a:r>
+              <a:rPr lang="ru-RU" sz="2400" dirty="0">
+                <a:latin typeface="Segoe UI Light" panose="020B0502040204020203" pitchFamily="34" charset="0"/>
+                <a:ea typeface="Segoe UI Black" panose="020B0A02040204020203" pitchFamily="34" charset="0"/>
+                <a:cs typeface="Segoe UI Light" panose="020B0502040204020203" pitchFamily="34" charset="0"/>
+              </a:rPr>
+              <a:t>10) Добавить возможность ставить реакцию на объявление.</a:t>
+            </a:r>
+          </a:p>
+          <a:p>
+            <a:pPr marL="0" indent="0">
+              <a:buNone/>
+            </a:pPr>
+            <a:r>
+              <a:rPr lang="ru-RU" sz="2400" dirty="0">
+                <a:latin typeface="Segoe UI Light" panose="020B0502040204020203" pitchFamily="34" charset="0"/>
+                <a:ea typeface="Segoe UI Black" panose="020B0A02040204020203" pitchFamily="34" charset="0"/>
+                <a:cs typeface="Segoe UI Light" panose="020B0502040204020203" pitchFamily="34" charset="0"/>
+              </a:rPr>
+              <a:t>11) Добавить систему рекомендаций и систему поиска.</a:t>
+            </a:r>
+            <a:endParaRPr lang="ru-RU" sz="2400" dirty="0">
+              <a:latin typeface="Segoe UI Light" panose="020B0502040204020203" pitchFamily="34" charset="0"/>
+              <a:ea typeface="Segoe UI Black" panose="020B0A02040204020203" pitchFamily="34" charset="0"/>
+              <a:cs typeface="Segoe UI Light" panose="020B0502040204020203" pitchFamily="34" charset="0"/>
+            </a:endParaRPr>
+          </a:p>
+        </p:txBody>
+      </p:sp>
+    </p:spTree>
+    <p:extLst>
+      <p:ext uri="{BB962C8B-B14F-4D97-AF65-F5344CB8AC3E}">
+        <p14:creationId xmlns:p14="http://schemas.microsoft.com/office/powerpoint/2010/main" val="3394567366"/>
+      </p:ext>
+    </p:extLst>
+  </p:cSld>
+  <p:clrMapOvr>
+    <a:masterClrMapping/>
+  </p:clrMapOvr>
+  <p:timing>
+    <p:tnLst>
+      <p:par>
+        <p:cTn id="1" dur="indefinite" restart="never" nodeType="tmRoot">
+          <p:childTnLst>
+            <p:seq concurrent="1" nextAc="seek">
+              <p:cTn id="2" dur="indefinite" nodeType="mainSeq">
+                <p:childTnLst>
+                  <p:par>
+                    <p:cTn id="3" fill="hold">
+                      <p:stCondLst>
+                        <p:cond delay="indefinite"/>
+                        <p:cond evt="onBegin" delay="0">
+                          <p:tn val="2"/>
+                        </p:cond>
+                      </p:stCondLst>
+                      <p:childTnLst>
+                        <p:par>
+                          <p:cTn id="4" fill="hold">
+                            <p:stCondLst>
+                              <p:cond delay="0"/>
+                            </p:stCondLst>
+                            <p:childTnLst>
+                              <p:par>
+                                <p:cTn id="5" presetID="47" presetClass="entr" presetSubtype="0" fill="hold" grpId="0" nodeType="afterEffect">
+                                  <p:stCondLst>
+                                    <p:cond delay="0"/>
+                                  </p:stCondLst>
+                                  <p:childTnLst>
+                                    <p:set>
+                                      <p:cBhvr>
+                                        <p:cTn id="6" dur="1" fill="hold">
+                                          <p:stCondLst>
+                                            <p:cond delay="0"/>
+                                          </p:stCondLst>
+                                        </p:cTn>
+                                        <p:tgtEl>
+                                          <p:spTgt spid="2"/>
+                                        </p:tgtEl>
+                                        <p:attrNameLst>
+                                          <p:attrName>style.visibility</p:attrName>
+                                        </p:attrNameLst>
+                                      </p:cBhvr>
+                                      <p:to>
+                                        <p:strVal val="visible"/>
+                                      </p:to>
+                                    </p:set>
+                                    <p:animEffect transition="in" filter="fade">
+                                      <p:cBhvr>
+                                        <p:cTn id="7" dur="1000"/>
+                                        <p:tgtEl>
+                                          <p:spTgt spid="2"/>
+                                        </p:tgtEl>
+                                      </p:cBhvr>
+                                    </p:animEffect>
+                                    <p:anim calcmode="lin" valueType="num">
+                                      <p:cBhvr>
+                                        <p:cTn id="8" dur="1000" fill="hold"/>
+                                        <p:tgtEl>
+                                          <p:spTgt spid="2"/>
+                                        </p:tgtEl>
+                                        <p:attrNameLst>
+                                          <p:attrName>ppt_x</p:attrName>
+                                        </p:attrNameLst>
+                                      </p:cBhvr>
+                                      <p:tavLst>
+                                        <p:tav tm="0">
+                                          <p:val>
+                                            <p:strVal val="#ppt_x"/>
+                                          </p:val>
+                                        </p:tav>
+                                        <p:tav tm="100000">
+                                          <p:val>
+                                            <p:strVal val="#ppt_x"/>
+                                          </p:val>
+                                        </p:tav>
+                                      </p:tavLst>
+                                    </p:anim>
+                                    <p:anim calcmode="lin" valueType="num">
+                                      <p:cBhvr>
+                                        <p:cTn id="9" dur="1000" fill="hold"/>
+                                        <p:tgtEl>
+                                          <p:spTgt spid="2"/>
+                                        </p:tgtEl>
+                                        <p:attrNameLst>
+                                          <p:attrName>ppt_y</p:attrName>
+                                        </p:attrNameLst>
+                                      </p:cBhvr>
+                                      <p:tavLst>
+                                        <p:tav tm="0">
+                                          <p:val>
+                                            <p:strVal val="#ppt_y-.1"/>
+                                          </p:val>
+                                        </p:tav>
+                                        <p:tav tm="100000">
+                                          <p:val>
+                                            <p:strVal val="#ppt_y"/>
+                                          </p:val>
+                                        </p:tav>
+                                      </p:tavLst>
+                                    </p:anim>
+                                  </p:childTnLst>
+                                </p:cTn>
+                              </p:par>
+                            </p:childTnLst>
+                          </p:cTn>
+                        </p:par>
+                        <p:par>
+                          <p:cTn id="10" fill="hold">
+                            <p:stCondLst>
+                              <p:cond delay="1000"/>
+                            </p:stCondLst>
+                            <p:childTnLst>
+                              <p:par>
+                                <p:cTn id="11" presetID="10" presetClass="entr" presetSubtype="0" fill="hold" nodeType="afterEffect">
+                                  <p:stCondLst>
+                                    <p:cond delay="0"/>
+                                  </p:stCondLst>
+                                  <p:childTnLst>
+                                    <p:set>
+                                      <p:cBhvr>
+                                        <p:cTn id="12" dur="1" fill="hold">
+                                          <p:stCondLst>
+                                            <p:cond delay="0"/>
+                                          </p:stCondLst>
+                                        </p:cTn>
+                                        <p:tgtEl>
+                                          <p:spTgt spid="3">
+                                            <p:txEl>
+                                              <p:pRg st="0" end="0"/>
+                                            </p:txEl>
+                                          </p:spTgt>
+                                        </p:tgtEl>
+                                        <p:attrNameLst>
+                                          <p:attrName>style.visibility</p:attrName>
+                                        </p:attrNameLst>
+                                      </p:cBhvr>
+                                      <p:to>
+                                        <p:strVal val="visible"/>
+                                      </p:to>
+                                    </p:set>
+                                    <p:animEffect transition="in" filter="fade">
+                                      <p:cBhvr>
+                                        <p:cTn id="13" dur="500"/>
+                                        <p:tgtEl>
+                                          <p:spTgt spid="3">
+                                            <p:txEl>
+                                              <p:pRg st="0" end="0"/>
+                                            </p:txEl>
+                                          </p:spTgt>
+                                        </p:tgtEl>
+                                      </p:cBhvr>
+                                    </p:animEffect>
+                                  </p:childTnLst>
+                                </p:cTn>
+                              </p:par>
+                            </p:childTnLst>
+                          </p:cTn>
+                        </p:par>
+                        <p:par>
+                          <p:cTn id="14" fill="hold">
+                            <p:stCondLst>
+                              <p:cond delay="1500"/>
+                            </p:stCondLst>
+                            <p:childTnLst>
+                              <p:par>
+                                <p:cTn id="15" presetID="10" presetClass="entr" presetSubtype="0" fill="hold" nodeType="afterEffect">
+                                  <p:stCondLst>
+                                    <p:cond delay="0"/>
+                                  </p:stCondLst>
+                                  <p:childTnLst>
+                                    <p:set>
+                                      <p:cBhvr>
+                                        <p:cTn id="16" dur="1" fill="hold">
+                                          <p:stCondLst>
+                                            <p:cond delay="0"/>
+                                          </p:stCondLst>
+                                        </p:cTn>
+                                        <p:tgtEl>
+                                          <p:spTgt spid="3">
+                                            <p:txEl>
+                                              <p:pRg st="1" end="1"/>
+                                            </p:txEl>
+                                          </p:spTgt>
+                                        </p:tgtEl>
+                                        <p:attrNameLst>
+                                          <p:attrName>style.visibility</p:attrName>
+                                        </p:attrNameLst>
+                                      </p:cBhvr>
+                                      <p:to>
+                                        <p:strVal val="visible"/>
+                                      </p:to>
+                                    </p:set>
+                                    <p:animEffect transition="in" filter="fade">
+                                      <p:cBhvr>
+                                        <p:cTn id="17" dur="500"/>
+                                        <p:tgtEl>
+                                          <p:spTgt spid="3">
+                                            <p:txEl>
+                                              <p:pRg st="1" end="1"/>
+                                            </p:txEl>
+                                          </p:spTgt>
+                                        </p:tgtEl>
+                                      </p:cBhvr>
+                                    </p:animEffect>
+                                  </p:childTnLst>
+                                </p:cTn>
+                              </p:par>
+                            </p:childTnLst>
+                          </p:cTn>
+                        </p:par>
+                        <p:par>
+                          <p:cTn id="18" fill="hold">
+                            <p:stCondLst>
+                              <p:cond delay="2000"/>
+                            </p:stCondLst>
+                            <p:childTnLst>
+                              <p:par>
+                                <p:cTn id="19" presetID="10" presetClass="entr" presetSubtype="0" fill="hold" nodeType="afterEffect">
+                                  <p:stCondLst>
+                                    <p:cond delay="0"/>
+                                  </p:stCondLst>
+                                  <p:childTnLst>
+                                    <p:set>
+                                      <p:cBhvr>
+                                        <p:cTn id="20" dur="1" fill="hold">
+                                          <p:stCondLst>
+                                            <p:cond delay="0"/>
+                                          </p:stCondLst>
+                                        </p:cTn>
+                                        <p:tgtEl>
+                                          <p:spTgt spid="3">
+                                            <p:txEl>
+                                              <p:pRg st="2" end="2"/>
+                                            </p:txEl>
+                                          </p:spTgt>
+                                        </p:tgtEl>
+                                        <p:attrNameLst>
+                                          <p:attrName>style.visibility</p:attrName>
+                                        </p:attrNameLst>
+                                      </p:cBhvr>
+                                      <p:to>
+                                        <p:strVal val="visible"/>
+                                      </p:to>
+                                    </p:set>
+                                    <p:animEffect transition="in" filter="fade">
+                                      <p:cBhvr>
+                                        <p:cTn id="21" dur="500"/>
+                                        <p:tgtEl>
+                                          <p:spTgt spid="3">
+                                            <p:txEl>
+                                              <p:pRg st="2" end="2"/>
+                                            </p:txEl>
+                                          </p:spTgt>
+                                        </p:tgtEl>
+                                      </p:cBhvr>
+                                    </p:animEffect>
+                                  </p:childTnLst>
+                                </p:cTn>
+                              </p:par>
+                            </p:childTnLst>
+                          </p:cTn>
+                        </p:par>
+                        <p:par>
+                          <p:cTn id="22" fill="hold">
+                            <p:stCondLst>
+                              <p:cond delay="2500"/>
+                            </p:stCondLst>
+                            <p:childTnLst>
+                              <p:par>
+                                <p:cTn id="23" presetID="10" presetClass="entr" presetSubtype="0" fill="hold" nodeType="afterEffect">
+                                  <p:stCondLst>
+                                    <p:cond delay="0"/>
+                                  </p:stCondLst>
+                                  <p:childTnLst>
+                                    <p:set>
+                                      <p:cBhvr>
+                                        <p:cTn id="24" dur="1" fill="hold">
+                                          <p:stCondLst>
+                                            <p:cond delay="0"/>
+                                          </p:stCondLst>
+                                        </p:cTn>
+                                        <p:tgtEl>
+                                          <p:spTgt spid="3">
+                                            <p:txEl>
+                                              <p:pRg st="3" end="3"/>
+                                            </p:txEl>
+                                          </p:spTgt>
+                                        </p:tgtEl>
+                                        <p:attrNameLst>
+                                          <p:attrName>style.visibility</p:attrName>
+                                        </p:attrNameLst>
+                                      </p:cBhvr>
+                                      <p:to>
+                                        <p:strVal val="visible"/>
+                                      </p:to>
+                                    </p:set>
+                                    <p:animEffect transition="in" filter="fade">
+                                      <p:cBhvr>
+                                        <p:cTn id="25" dur="500"/>
+                                        <p:tgtEl>
+                                          <p:spTgt spid="3">
+                                            <p:txEl>
+                                              <p:pRg st="3" end="3"/>
+                                            </p:txEl>
+                                          </p:spTgt>
+                                        </p:tgtEl>
+                                      </p:cBhvr>
+                                    </p:animEffect>
+                                  </p:childTnLst>
+                                </p:cTn>
+                              </p:par>
+                            </p:childTnLst>
+                          </p:cTn>
+                        </p:par>
+                        <p:par>
+                          <p:cTn id="26" fill="hold">
+                            <p:stCondLst>
+                              <p:cond delay="3000"/>
+                            </p:stCondLst>
+                            <p:childTnLst>
+                              <p:par>
+                                <p:cTn id="27" presetID="10" presetClass="entr" presetSubtype="0" fill="hold" nodeType="afterEffect">
+                                  <p:stCondLst>
+                                    <p:cond delay="0"/>
+                                  </p:stCondLst>
+                                  <p:childTnLst>
+                                    <p:set>
+                                      <p:cBhvr>
+                                        <p:cTn id="28" dur="1" fill="hold">
+                                          <p:stCondLst>
+                                            <p:cond delay="0"/>
+                                          </p:stCondLst>
+                                        </p:cTn>
+                                        <p:tgtEl>
+                                          <p:spTgt spid="3">
+                                            <p:txEl>
+                                              <p:pRg st="4" end="4"/>
+                                            </p:txEl>
+                                          </p:spTgt>
+                                        </p:tgtEl>
+                                        <p:attrNameLst>
+                                          <p:attrName>style.visibility</p:attrName>
+                                        </p:attrNameLst>
+                                      </p:cBhvr>
+                                      <p:to>
+                                        <p:strVal val="visible"/>
+                                      </p:to>
+                                    </p:set>
+                                    <p:animEffect transition="in" filter="fade">
+                                      <p:cBhvr>
+                                        <p:cTn id="29" dur="500"/>
+                                        <p:tgtEl>
+                                          <p:spTgt spid="3">
+                                            <p:txEl>
+                                              <p:pRg st="4" end="4"/>
+                                            </p:txEl>
+                                          </p:spTgt>
+                                        </p:tgtEl>
+                                      </p:cBhvr>
+                                    </p:animEffect>
+                                  </p:childTnLst>
+                                </p:cTn>
+                              </p:par>
+                            </p:childTnLst>
+                          </p:cTn>
+                        </p:par>
+                        <p:par>
+                          <p:cTn id="30" fill="hold">
+                            <p:stCondLst>
+                              <p:cond delay="3500"/>
+                            </p:stCondLst>
+                            <p:childTnLst>
+                              <p:par>
+                                <p:cTn id="31" presetID="10" presetClass="entr" presetSubtype="0" fill="hold" nodeType="afterEffect">
+                                  <p:stCondLst>
+                                    <p:cond delay="0"/>
+                                  </p:stCondLst>
+                                  <p:childTnLst>
+                                    <p:set>
+                                      <p:cBhvr>
+                                        <p:cTn id="32" dur="1" fill="hold">
+                                          <p:stCondLst>
+                                            <p:cond delay="0"/>
+                                          </p:stCondLst>
+                                        </p:cTn>
+                                        <p:tgtEl>
+                                          <p:spTgt spid="3">
+                                            <p:txEl>
+                                              <p:pRg st="5" end="5"/>
+                                            </p:txEl>
+                                          </p:spTgt>
+                                        </p:tgtEl>
+                                        <p:attrNameLst>
+                                          <p:attrName>style.visibility</p:attrName>
+                                        </p:attrNameLst>
+                                      </p:cBhvr>
+                                      <p:to>
+                                        <p:strVal val="visible"/>
+                                      </p:to>
+                                    </p:set>
+                                    <p:animEffect transition="in" filter="fade">
+                                      <p:cBhvr>
+                                        <p:cTn id="33" dur="500"/>
+                                        <p:tgtEl>
+                                          <p:spTgt spid="3">
+                                            <p:txEl>
+                                              <p:pRg st="5" end="5"/>
+                                            </p:txEl>
+                                          </p:spTgt>
+                                        </p:tgtEl>
+                                      </p:cBhvr>
+                                    </p:animEffect>
+                                  </p:childTnLst>
+                                </p:cTn>
+                              </p:par>
+                            </p:childTnLst>
+                          </p:cTn>
+                        </p:par>
+                      </p:childTnLst>
+                    </p:cTn>
+                  </p:par>
+                </p:childTnLst>
+              </p:cTn>
+              <p:prevCondLst>
+                <p:cond evt="onPrev" delay="0">
+                  <p:tgtEl>
+                    <p:sldTgt/>
+                  </p:tgtEl>
+                </p:cond>
+              </p:prevCondLst>
+              <p:nextCondLst>
+                <p:cond evt="onNext" delay="0">
+                  <p:tgtEl>
+                    <p:sldTgt/>
+                  </p:tgtEl>
+                </p:cond>
+              </p:nextCondLst>
+            </p:seq>
+          </p:childTnLst>
+        </p:cTn>
+      </p:par>
+    </p:tnLst>
+    <p:bldLst>
+      <p:bldP spid="2" grpId="0"/>
+    </p:bldLst>
+  </p:timing>
+</p:sld>
+</file>
+
+<file path=ppt/slides/slide5.xml><?xml version="1.0" encoding="utf-8"?>
+<p:sld xmlns:a="http://schemas.openxmlformats.org/drawingml/2006/main" xmlns:r="http://schemas.openxmlformats.org/officeDocument/2006/relationships" xmlns:p="http://schemas.openxmlformats.org/presentationml/2006/main">
+  <p:cSld>
+    <p:spTree>
+      <p:nvGrpSpPr>
+        <p:cNvPr id="1" name=""/>
+        <p:cNvGrpSpPr/>
+        <p:nvPr/>
+      </p:nvGrpSpPr>
+      <p:grpSpPr>
+        <a:xfrm>
+          <a:off x="0" y="0"/>
+          <a:ext cx="0" cy="0"/>
+          <a:chOff x="0" y="0"/>
+          <a:chExt cx="0" cy="0"/>
+        </a:xfrm>
+      </p:grpSpPr>
+      <p:sp>
+        <p:nvSpPr>
+          <p:cNvPr id="2" name="Заголовок 1">
+            <a:extLst>
+              <a:ext uri="{FF2B5EF4-FFF2-40B4-BE49-F238E27FC236}">
+                <a16:creationId xmlns:a16="http://schemas.microsoft.com/office/drawing/2014/main" id="{F209A495-8E3F-4CFE-86E0-75920089882B}"/>
+              </a:ext>
+            </a:extLst>
+          </p:cNvPr>
+          <p:cNvSpPr>
+            <a:spLocks noGrp="1"/>
+          </p:cNvSpPr>
+          <p:nvPr>
+            <p:ph type="title"/>
+          </p:nvPr>
+        </p:nvSpPr>
+        <p:spPr/>
+        <p:txBody>
+          <a:bodyPr>
+            <a:normAutofit/>
+          </a:bodyPr>
+          <a:lstStyle/>
+          <a:p>
+            <a:pPr algn="ctr"/>
+            <a:r>
+              <a:rPr lang="ru-RU" sz="4000" dirty="0" smtClean="0">
+                <a:solidFill>
+                  <a:srgbClr val="36A9E1"/>
+                </a:solidFill>
+                <a:latin typeface="Segoe UI Black" panose="020B0A02040204020203" pitchFamily="34" charset="0"/>
+                <a:ea typeface="Segoe UI Black" panose="020B0A02040204020203" pitchFamily="34" charset="0"/>
+              </a:rPr>
+              <a:t>Реализация</a:t>
+            </a:r>
+            <a:endParaRPr lang="ru-RU" sz="4000" dirty="0">
+              <a:solidFill>
+                <a:srgbClr val="36A9E1"/>
+              </a:solidFill>
+              <a:latin typeface="Segoe UI Black" panose="020B0A02040204020203" pitchFamily="34" charset="0"/>
+              <a:ea typeface="Segoe UI Black" panose="020B0A02040204020203" pitchFamily="34" charset="0"/>
+            </a:endParaRPr>
+          </a:p>
+        </p:txBody>
+      </p:sp>
+      <p:sp>
+        <p:nvSpPr>
+          <p:cNvPr id="3" name="Объект 2">
+            <a:extLst>
+              <a:ext uri="{FF2B5EF4-FFF2-40B4-BE49-F238E27FC236}">
+                <a16:creationId xmlns:a16="http://schemas.microsoft.com/office/drawing/2014/main" id="{6B41888E-AA9C-4D55-AAD7-6D821BC62010}"/>
+              </a:ext>
+            </a:extLst>
+          </p:cNvPr>
+          <p:cNvSpPr>
+            <a:spLocks noGrp="1"/>
+          </p:cNvSpPr>
+          <p:nvPr>
+            <p:ph idx="1"/>
+          </p:nvPr>
+        </p:nvSpPr>
+        <p:spPr>
+          <a:xfrm>
+            <a:off x="480060" y="1690688"/>
+            <a:ext cx="11231880" cy="4351338"/>
+          </a:xfrm>
+        </p:spPr>
+        <p:txBody>
+          <a:bodyPr>
+            <a:noAutofit/>
+          </a:bodyPr>
+          <a:lstStyle/>
+          <a:p>
+            <a:pPr marL="0" indent="0">
+              <a:buNone/>
+            </a:pPr>
+            <a:r>
+              <a:rPr lang="ru-RU" sz="2400" dirty="0">
+                <a:latin typeface="Segoe UI Light" panose="020B0502040204020203" pitchFamily="34" charset="0"/>
+                <a:ea typeface="Segoe UI Black" panose="020B0A02040204020203" pitchFamily="34" charset="0"/>
+                <a:cs typeface="Segoe UI Light" panose="020B0502040204020203" pitchFamily="34" charset="0"/>
+              </a:rPr>
+              <a:t>- Серверное приложение и </a:t>
+            </a:r>
+            <a:r>
+              <a:rPr lang="ru-RU" sz="2400" dirty="0" err="1">
+                <a:latin typeface="Segoe UI Light" panose="020B0502040204020203" pitchFamily="34" charset="0"/>
+                <a:ea typeface="Segoe UI Black" panose="020B0A02040204020203" pitchFamily="34" charset="0"/>
+                <a:cs typeface="Segoe UI Light" panose="020B0502040204020203" pitchFamily="34" charset="0"/>
+              </a:rPr>
+              <a:t>роутинг</a:t>
+            </a:r>
+            <a:r>
+              <a:rPr lang="ru-RU" sz="2400" dirty="0">
+                <a:latin typeface="Segoe UI Light" panose="020B0502040204020203" pitchFamily="34" charset="0"/>
+                <a:ea typeface="Segoe UI Black" panose="020B0A02040204020203" pitchFamily="34" charset="0"/>
+                <a:cs typeface="Segoe UI Light" panose="020B0502040204020203" pitchFamily="34" charset="0"/>
+              </a:rPr>
+              <a:t> реализовано в скрипте </a:t>
+            </a:r>
+            <a:r>
+              <a:rPr lang="ru-RU" sz="2400" b="1" i="1" dirty="0" smtClean="0">
+                <a:solidFill>
+                  <a:srgbClr val="36A9E1"/>
+                </a:solidFill>
+                <a:latin typeface="Segoe UI Light" panose="020B0502040204020203" pitchFamily="34" charset="0"/>
+                <a:ea typeface="Segoe UI Black" panose="020B0A02040204020203" pitchFamily="34" charset="0"/>
+                <a:cs typeface="Segoe UI Light" panose="020B0502040204020203" pitchFamily="34" charset="0"/>
+              </a:rPr>
+              <a:t>app.py</a:t>
+            </a:r>
+            <a:r>
+              <a:rPr lang="ru-RU" sz="2400" dirty="0" smtClean="0">
+                <a:latin typeface="Segoe UI Light" panose="020B0502040204020203" pitchFamily="34" charset="0"/>
+                <a:ea typeface="Segoe UI Black" panose="020B0A02040204020203" pitchFamily="34" charset="0"/>
+                <a:cs typeface="Segoe UI Light" panose="020B0502040204020203" pitchFamily="34" charset="0"/>
+              </a:rPr>
+              <a:t>.</a:t>
+            </a:r>
+            <a:endParaRPr lang="ru-RU" sz="2400" dirty="0">
+              <a:latin typeface="Segoe UI Light" panose="020B0502040204020203" pitchFamily="34" charset="0"/>
+              <a:ea typeface="Segoe UI Black" panose="020B0A02040204020203" pitchFamily="34" charset="0"/>
+              <a:cs typeface="Segoe UI Light" panose="020B0502040204020203" pitchFamily="34" charset="0"/>
+            </a:endParaRPr>
+          </a:p>
+          <a:p>
+            <a:pPr marL="0" indent="0">
+              <a:buNone/>
+            </a:pPr>
+            <a:r>
+              <a:rPr lang="ru-RU" sz="2400" dirty="0">
+                <a:latin typeface="Segoe UI Light" panose="020B0502040204020203" pitchFamily="34" charset="0"/>
+                <a:ea typeface="Segoe UI Black" panose="020B0A02040204020203" pitchFamily="34" charset="0"/>
+                <a:cs typeface="Segoe UI Light" panose="020B0502040204020203" pitchFamily="34" charset="0"/>
+              </a:rPr>
+              <a:t>- Данные пользователей хранятся в SQL-</a:t>
+            </a:r>
+            <a:r>
+              <a:rPr lang="ru-RU" sz="2400" dirty="0" err="1">
+                <a:latin typeface="Segoe UI Light" panose="020B0502040204020203" pitchFamily="34" charset="0"/>
+                <a:ea typeface="Segoe UI Black" panose="020B0A02040204020203" pitchFamily="34" charset="0"/>
+                <a:cs typeface="Segoe UI Light" panose="020B0502040204020203" pitchFamily="34" charset="0"/>
+              </a:rPr>
+              <a:t>базахданных</a:t>
+            </a:r>
+            <a:r>
+              <a:rPr lang="ru-RU" sz="2400" dirty="0">
+                <a:latin typeface="Segoe UI Light" panose="020B0502040204020203" pitchFamily="34" charset="0"/>
+                <a:ea typeface="Segoe UI Black" panose="020B0A02040204020203" pitchFamily="34" charset="0"/>
+                <a:cs typeface="Segoe UI Light" panose="020B0502040204020203" pitchFamily="34" charset="0"/>
+              </a:rPr>
+              <a:t>. Взаимодействие с базой данных осуществляется при помощи </a:t>
+            </a:r>
+            <a:r>
+              <a:rPr lang="ru-RU" sz="2400" dirty="0" smtClean="0">
+                <a:latin typeface="Segoe UI Light" panose="020B0502040204020203" pitchFamily="34" charset="0"/>
+                <a:ea typeface="Segoe UI Black" panose="020B0A02040204020203" pitchFamily="34" charset="0"/>
+                <a:cs typeface="Segoe UI Light" panose="020B0502040204020203" pitchFamily="34" charset="0"/>
+              </a:rPr>
+              <a:t>класса </a:t>
+            </a:r>
+            <a:r>
+              <a:rPr lang="ru-RU" sz="2400" b="1" i="1" dirty="0" err="1" smtClean="0">
+                <a:solidFill>
+                  <a:srgbClr val="36A9E1"/>
+                </a:solidFill>
+                <a:latin typeface="Segoe UI Light" panose="020B0502040204020203" pitchFamily="34" charset="0"/>
+                <a:ea typeface="Segoe UI Black" panose="020B0A02040204020203" pitchFamily="34" charset="0"/>
+                <a:cs typeface="Segoe UI Light" panose="020B0502040204020203" pitchFamily="34" charset="0"/>
+              </a:rPr>
+              <a:t>Database</a:t>
+            </a:r>
+            <a:r>
+              <a:rPr lang="ru-RU" sz="2400" dirty="0" smtClean="0">
+                <a:latin typeface="Segoe UI Light" panose="020B0502040204020203" pitchFamily="34" charset="0"/>
+                <a:ea typeface="Segoe UI Black" panose="020B0A02040204020203" pitchFamily="34" charset="0"/>
+                <a:cs typeface="Segoe UI Light" panose="020B0502040204020203" pitchFamily="34" charset="0"/>
+              </a:rPr>
+              <a:t>.</a:t>
+            </a:r>
+            <a:endParaRPr lang="ru-RU" sz="2400" dirty="0">
+              <a:latin typeface="Segoe UI Light" panose="020B0502040204020203" pitchFamily="34" charset="0"/>
+              <a:ea typeface="Segoe UI Black" panose="020B0A02040204020203" pitchFamily="34" charset="0"/>
+              <a:cs typeface="Segoe UI Light" panose="020B0502040204020203" pitchFamily="34" charset="0"/>
+            </a:endParaRPr>
+          </a:p>
+          <a:p>
+            <a:pPr marL="0" indent="0">
+              <a:buNone/>
+            </a:pPr>
+            <a:r>
+              <a:rPr lang="ru-RU" sz="2400" dirty="0" smtClean="0">
+                <a:latin typeface="Segoe UI Light" panose="020B0502040204020203" pitchFamily="34" charset="0"/>
+                <a:ea typeface="Segoe UI Black" panose="020B0A02040204020203" pitchFamily="34" charset="0"/>
+                <a:cs typeface="Segoe UI Light" panose="020B0502040204020203" pitchFamily="34" charset="0"/>
+              </a:rPr>
+              <a:t>- Для </a:t>
+            </a:r>
+            <a:r>
+              <a:rPr lang="ru-RU" sz="2400" dirty="0">
+                <a:latin typeface="Segoe UI Light" panose="020B0502040204020203" pitchFamily="34" charset="0"/>
+                <a:ea typeface="Segoe UI Black" panose="020B0A02040204020203" pitchFamily="34" charset="0"/>
+                <a:cs typeface="Segoe UI Light" panose="020B0502040204020203" pitchFamily="34" charset="0"/>
+              </a:rPr>
+              <a:t>хранения данных </a:t>
+            </a:r>
+            <a:r>
+              <a:rPr lang="ru-RU" sz="2400" dirty="0" smtClean="0">
+                <a:latin typeface="Segoe UI Light" panose="020B0502040204020203" pitchFamily="34" charset="0"/>
+                <a:ea typeface="Segoe UI Black" panose="020B0A02040204020203" pitchFamily="34" charset="0"/>
+                <a:cs typeface="Segoe UI Light" panose="020B0502040204020203" pitchFamily="34" charset="0"/>
+              </a:rPr>
+              <a:t>пользователя, объявления, категории, действия </a:t>
+            </a:r>
+            <a:r>
+              <a:rPr lang="ru-RU" sz="2400" dirty="0">
+                <a:latin typeface="Segoe UI Light" panose="020B0502040204020203" pitchFamily="34" charset="0"/>
+                <a:ea typeface="Segoe UI Black" panose="020B0A02040204020203" pitchFamily="34" charset="0"/>
+                <a:cs typeface="Segoe UI Light" panose="020B0502040204020203" pitchFamily="34" charset="0"/>
+              </a:rPr>
+              <a:t>используются специальная модель данных, реализованная классом </a:t>
+            </a:r>
+            <a:r>
+              <a:rPr lang="ru-RU" sz="2400" b="1" i="1" dirty="0" err="1" smtClean="0">
+                <a:solidFill>
+                  <a:srgbClr val="36A9E1"/>
+                </a:solidFill>
+                <a:latin typeface="Segoe UI Light" panose="020B0502040204020203" pitchFamily="34" charset="0"/>
+                <a:ea typeface="Segoe UI Black" panose="020B0A02040204020203" pitchFamily="34" charset="0"/>
+                <a:cs typeface="Segoe UI Light" panose="020B0502040204020203" pitchFamily="34" charset="0"/>
+              </a:rPr>
+              <a:t>User</a:t>
+            </a:r>
+            <a:r>
+              <a:rPr lang="ru-RU" sz="2400" b="1" i="1" dirty="0" smtClean="0">
+                <a:solidFill>
+                  <a:srgbClr val="36A9E1"/>
+                </a:solidFill>
+                <a:latin typeface="Segoe UI Light" panose="020B0502040204020203" pitchFamily="34" charset="0"/>
+                <a:ea typeface="Segoe UI Black" panose="020B0A02040204020203" pitchFamily="34" charset="0"/>
+                <a:cs typeface="Segoe UI Light" panose="020B0502040204020203" pitchFamily="34" charset="0"/>
+              </a:rPr>
+              <a:t>, </a:t>
+            </a:r>
+            <a:r>
+              <a:rPr lang="ru-RU" sz="2400" b="1" i="1" dirty="0" err="1" smtClean="0">
+                <a:solidFill>
+                  <a:srgbClr val="36A9E1"/>
+                </a:solidFill>
+                <a:latin typeface="Segoe UI Light" panose="020B0502040204020203" pitchFamily="34" charset="0"/>
+                <a:ea typeface="Segoe UI Black" panose="020B0A02040204020203" pitchFamily="34" charset="0"/>
+                <a:cs typeface="Segoe UI Light" panose="020B0502040204020203" pitchFamily="34" charset="0"/>
+              </a:rPr>
+              <a:t>Advertisement</a:t>
+            </a:r>
+            <a:r>
+              <a:rPr lang="ru-RU" sz="2400" b="1" i="1" dirty="0" smtClean="0">
+                <a:solidFill>
+                  <a:srgbClr val="36A9E1"/>
+                </a:solidFill>
+                <a:latin typeface="Segoe UI Light" panose="020B0502040204020203" pitchFamily="34" charset="0"/>
+                <a:ea typeface="Segoe UI Black" panose="020B0A02040204020203" pitchFamily="34" charset="0"/>
+                <a:cs typeface="Segoe UI Light" panose="020B0502040204020203" pitchFamily="34" charset="0"/>
+              </a:rPr>
+              <a:t>, </a:t>
+            </a:r>
+            <a:r>
+              <a:rPr lang="ru-RU" sz="2400" b="1" i="1" dirty="0" err="1" smtClean="0">
+                <a:solidFill>
+                  <a:srgbClr val="36A9E1"/>
+                </a:solidFill>
+                <a:latin typeface="Segoe UI Light" panose="020B0502040204020203" pitchFamily="34" charset="0"/>
+                <a:ea typeface="Segoe UI Black" panose="020B0A02040204020203" pitchFamily="34" charset="0"/>
+                <a:cs typeface="Segoe UI Light" panose="020B0502040204020203" pitchFamily="34" charset="0"/>
+              </a:rPr>
+              <a:t>Category</a:t>
+            </a:r>
+            <a:r>
+              <a:rPr lang="ru-RU" sz="2400" b="1" i="1" dirty="0" smtClean="0">
+                <a:solidFill>
+                  <a:srgbClr val="36A9E1"/>
+                </a:solidFill>
+                <a:latin typeface="Segoe UI Light" panose="020B0502040204020203" pitchFamily="34" charset="0"/>
+                <a:ea typeface="Segoe UI Black" panose="020B0A02040204020203" pitchFamily="34" charset="0"/>
+                <a:cs typeface="Segoe UI Light" panose="020B0502040204020203" pitchFamily="34" charset="0"/>
+              </a:rPr>
+              <a:t>, </a:t>
+            </a:r>
+            <a:r>
+              <a:rPr lang="ru-RU" sz="2400" b="1" i="1" dirty="0" err="1" smtClean="0">
+                <a:solidFill>
+                  <a:srgbClr val="36A9E1"/>
+                </a:solidFill>
+                <a:latin typeface="Segoe UI Light" panose="020B0502040204020203" pitchFamily="34" charset="0"/>
+                <a:ea typeface="Segoe UI Black" panose="020B0A02040204020203" pitchFamily="34" charset="0"/>
+                <a:cs typeface="Segoe UI Light" panose="020B0502040204020203" pitchFamily="34" charset="0"/>
+              </a:rPr>
+              <a:t>Action</a:t>
+            </a:r>
+            <a:endParaRPr lang="ru-RU" sz="2400" b="1" i="1" dirty="0" smtClean="0">
+              <a:solidFill>
+                <a:srgbClr val="36A9E1"/>
+              </a:solidFill>
+              <a:latin typeface="Segoe UI Light" panose="020B0502040204020203" pitchFamily="34" charset="0"/>
+              <a:ea typeface="Segoe UI Black" panose="020B0A02040204020203" pitchFamily="34" charset="0"/>
+              <a:cs typeface="Segoe UI Light" panose="020B0502040204020203" pitchFamily="34" charset="0"/>
+            </a:endParaRPr>
+          </a:p>
+          <a:p>
+            <a:pPr marL="0" indent="0">
+              <a:buNone/>
+            </a:pPr>
+            <a:r>
+              <a:rPr lang="ru-RU" sz="2400" dirty="0">
+                <a:latin typeface="Segoe UI Light" panose="020B0502040204020203" pitchFamily="34" charset="0"/>
+                <a:ea typeface="Segoe UI Black" panose="020B0A02040204020203" pitchFamily="34" charset="0"/>
+                <a:cs typeface="Segoe UI Light" panose="020B0502040204020203" pitchFamily="34" charset="0"/>
+              </a:rPr>
+              <a:t>- Связь моделей данных осуществляется </a:t>
+            </a:r>
+            <a:r>
+              <a:rPr lang="ru-RU" sz="2400" dirty="0" smtClean="0">
+                <a:latin typeface="Segoe UI Light" panose="020B0502040204020203" pitchFamily="34" charset="0"/>
+                <a:ea typeface="Segoe UI Black" panose="020B0A02040204020203" pitchFamily="34" charset="0"/>
+                <a:cs typeface="Segoe UI Light" panose="020B0502040204020203" pitchFamily="34" charset="0"/>
+              </a:rPr>
+              <a:t>через </a:t>
+            </a:r>
+            <a:r>
+              <a:rPr lang="ru-RU" sz="2400" b="1" i="1" dirty="0" err="1">
+                <a:solidFill>
+                  <a:srgbClr val="36A9E1"/>
+                </a:solidFill>
+                <a:latin typeface="Segoe UI Light" panose="020B0502040204020203" pitchFamily="34" charset="0"/>
+                <a:ea typeface="Segoe UI Black" panose="020B0A02040204020203" pitchFamily="34" charset="0"/>
+                <a:cs typeface="Segoe UI Light" panose="020B0502040204020203" pitchFamily="34" charset="0"/>
+              </a:rPr>
+              <a:t>orm</a:t>
+            </a:r>
+            <a:r>
+              <a:rPr lang="ru-RU" sz="2400" dirty="0">
+                <a:latin typeface="Segoe UI Light" panose="020B0502040204020203" pitchFamily="34" charset="0"/>
+                <a:ea typeface="Segoe UI Black" panose="020B0A02040204020203" pitchFamily="34" charset="0"/>
+                <a:cs typeface="Segoe UI Light" panose="020B0502040204020203" pitchFamily="34" charset="0"/>
+              </a:rPr>
+              <a:t>.</a:t>
+            </a:r>
+          </a:p>
+          <a:p>
+            <a:pPr marL="0" indent="0">
+              <a:buNone/>
+            </a:pPr>
+            <a:r>
+              <a:rPr lang="ru-RU" sz="2400" dirty="0">
+                <a:latin typeface="Segoe UI Light" panose="020B0502040204020203" pitchFamily="34" charset="0"/>
+                <a:ea typeface="Segoe UI Black" panose="020B0A02040204020203" pitchFamily="34" charset="0"/>
+                <a:cs typeface="Segoe UI Light" panose="020B0502040204020203" pitchFamily="34" charset="0"/>
+              </a:rPr>
+              <a:t>- </a:t>
+            </a:r>
+            <a:r>
+              <a:rPr lang="ru-RU" sz="2400" dirty="0" smtClean="0">
+                <a:latin typeface="Segoe UI Light" panose="020B0502040204020203" pitchFamily="34" charset="0"/>
+                <a:ea typeface="Segoe UI Black" panose="020B0A02040204020203" pitchFamily="34" charset="0"/>
+                <a:cs typeface="Segoe UI Light" panose="020B0502040204020203" pitchFamily="34" charset="0"/>
+              </a:rPr>
+              <a:t>Для создание</a:t>
+            </a:r>
+            <a:r>
+              <a:rPr lang="ru-RU" sz="2400" dirty="0">
+                <a:latin typeface="Segoe UI Light" panose="020B0502040204020203" pitchFamily="34" charset="0"/>
+                <a:ea typeface="Segoe UI Black" panose="020B0A02040204020203" pitchFamily="34" charset="0"/>
+                <a:cs typeface="Segoe UI Light" panose="020B0502040204020203" pitchFamily="34" charset="0"/>
+              </a:rPr>
+              <a:t>, </a:t>
+            </a:r>
+            <a:r>
+              <a:rPr lang="ru-RU" sz="2400" dirty="0" smtClean="0">
+                <a:latin typeface="Segoe UI Light" panose="020B0502040204020203" pitchFamily="34" charset="0"/>
+                <a:ea typeface="Segoe UI Black" panose="020B0A02040204020203" pitchFamily="34" charset="0"/>
+                <a:cs typeface="Segoe UI Light" panose="020B0502040204020203" pitchFamily="34" charset="0"/>
+              </a:rPr>
+              <a:t>удаления </a:t>
+            </a:r>
+            <a:r>
+              <a:rPr lang="ru-RU" sz="2400" dirty="0">
+                <a:latin typeface="Segoe UI Light" panose="020B0502040204020203" pitchFamily="34" charset="0"/>
+                <a:ea typeface="Segoe UI Black" panose="020B0A02040204020203" pitchFamily="34" charset="0"/>
+                <a:cs typeface="Segoe UI Light" panose="020B0502040204020203" pitchFamily="34" charset="0"/>
+              </a:rPr>
+              <a:t>и </a:t>
+            </a:r>
+            <a:r>
+              <a:rPr lang="ru-RU" sz="2400" dirty="0" smtClean="0">
+                <a:latin typeface="Segoe UI Light" panose="020B0502040204020203" pitchFamily="34" charset="0"/>
+                <a:ea typeface="Segoe UI Black" panose="020B0A02040204020203" pitchFamily="34" charset="0"/>
+                <a:cs typeface="Segoe UI Light" panose="020B0502040204020203" pitchFamily="34" charset="0"/>
+              </a:rPr>
+              <a:t>взаимодействия с моделями данных используются специальные сервисы.</a:t>
+            </a:r>
+            <a:endParaRPr lang="ru-RU" sz="2400" dirty="0">
+              <a:latin typeface="Segoe UI Light" panose="020B0502040204020203" pitchFamily="34" charset="0"/>
+              <a:ea typeface="Segoe UI Black" panose="020B0A02040204020203" pitchFamily="34" charset="0"/>
+              <a:cs typeface="Segoe UI Light" panose="020B0502040204020203" pitchFamily="34" charset="0"/>
+            </a:endParaRPr>
+          </a:p>
+          <a:p>
+            <a:pPr>
+              <a:buFontTx/>
+              <a:buChar char="-"/>
+            </a:pPr>
+            <a:r>
+              <a:rPr lang="ru-RU" sz="2400" dirty="0" smtClean="0">
+                <a:latin typeface="Segoe UI Light" panose="020B0502040204020203" pitchFamily="34" charset="0"/>
+                <a:ea typeface="Segoe UI Black" panose="020B0A02040204020203" pitchFamily="34" charset="0"/>
+                <a:cs typeface="Segoe UI Light" panose="020B0502040204020203" pitchFamily="34" charset="0"/>
+              </a:rPr>
+              <a:t>Стороннее </a:t>
+            </a:r>
+            <a:r>
+              <a:rPr lang="ru-RU" sz="2400" dirty="0">
+                <a:latin typeface="Segoe UI Light" panose="020B0502040204020203" pitchFamily="34" charset="0"/>
+                <a:ea typeface="Segoe UI Black" panose="020B0A02040204020203" pitchFamily="34" charset="0"/>
+                <a:cs typeface="Segoe UI Light" panose="020B0502040204020203" pitchFamily="34" charset="0"/>
+              </a:rPr>
+              <a:t>взаимодействие с </a:t>
+            </a:r>
+            <a:r>
+              <a:rPr lang="ru-RU" sz="2400" dirty="0" smtClean="0">
+                <a:latin typeface="Segoe UI Light" panose="020B0502040204020203" pitchFamily="34" charset="0"/>
+                <a:ea typeface="Segoe UI Black" panose="020B0A02040204020203" pitchFamily="34" charset="0"/>
+                <a:cs typeface="Segoe UI Light" panose="020B0502040204020203" pitchFamily="34" charset="0"/>
+              </a:rPr>
+              <a:t>данными пользователя и объявлениями реализовано </a:t>
+            </a:r>
+            <a:r>
+              <a:rPr lang="ru-RU" sz="2400" dirty="0">
+                <a:latin typeface="Segoe UI Light" panose="020B0502040204020203" pitchFamily="34" charset="0"/>
+                <a:ea typeface="Segoe UI Black" panose="020B0A02040204020203" pitchFamily="34" charset="0"/>
+                <a:cs typeface="Segoe UI Light" panose="020B0502040204020203" pitchFamily="34" charset="0"/>
+              </a:rPr>
+              <a:t>в </a:t>
+            </a:r>
+            <a:r>
+              <a:rPr lang="ru-RU" sz="2400" dirty="0" smtClean="0">
+                <a:latin typeface="Segoe UI Light" panose="020B0502040204020203" pitchFamily="34" charset="0"/>
+                <a:ea typeface="Segoe UI Black" panose="020B0A02040204020203" pitchFamily="34" charset="0"/>
+                <a:cs typeface="Segoe UI Light" panose="020B0502040204020203" pitchFamily="34" charset="0"/>
+              </a:rPr>
+              <a:t>REST-AP</a:t>
+            </a:r>
+            <a:r>
+              <a:rPr lang="en-US" sz="2400" dirty="0" smtClean="0">
+                <a:latin typeface="Segoe UI Light" panose="020B0502040204020203" pitchFamily="34" charset="0"/>
+                <a:ea typeface="Segoe UI Black" panose="020B0A02040204020203" pitchFamily="34" charset="0"/>
+                <a:cs typeface="Segoe UI Light" panose="020B0502040204020203" pitchFamily="34" charset="0"/>
+              </a:rPr>
+              <a:t>I</a:t>
+            </a:r>
+            <a:endParaRPr lang="ru-RU" sz="2400" dirty="0">
+              <a:latin typeface="Segoe UI Light" panose="020B0502040204020203" pitchFamily="34" charset="0"/>
+              <a:ea typeface="Segoe UI Black" panose="020B0A02040204020203" pitchFamily="34" charset="0"/>
+              <a:cs typeface="Segoe UI Light" panose="020B0502040204020203" pitchFamily="34" charset="0"/>
+            </a:endParaRPr>
+          </a:p>
+        </p:txBody>
+      </p:sp>
+    </p:spTree>
+    <p:extLst>
+      <p:ext uri="{BB962C8B-B14F-4D97-AF65-F5344CB8AC3E}">
+        <p14:creationId xmlns:p14="http://schemas.microsoft.com/office/powerpoint/2010/main" val="1775180826"/>
+      </p:ext>
+    </p:extLst>
+  </p:cSld>
+  <p:clrMapOvr>
+    <a:masterClrMapping/>
+  </p:clrMapOvr>
+  <p:timing>
+    <p:tnLst>
+      <p:par>
+        <p:cTn id="1" dur="indefinite" restart="never" nodeType="tmRoot">
+          <p:childTnLst>
+            <p:seq concurrent="1" nextAc="seek">
+              <p:cTn id="2" dur="indefinite" nodeType="mainSeq">
+                <p:childTnLst>
+                  <p:par>
+                    <p:cTn id="3" fill="hold">
+                      <p:stCondLst>
+                        <p:cond delay="indefinite"/>
+                        <p:cond evt="onBegin" delay="0">
+                          <p:tn val="2"/>
+                        </p:cond>
+                      </p:stCondLst>
+                      <p:childTnLst>
+                        <p:par>
+                          <p:cTn id="4" fill="hold">
+                            <p:stCondLst>
+                              <p:cond delay="0"/>
+                            </p:stCondLst>
+                            <p:childTnLst>
+                              <p:par>
+                                <p:cTn id="5" presetID="47" presetClass="entr" presetSubtype="0" fill="hold" grpId="0" nodeType="afterEffect">
+                                  <p:stCondLst>
+                                    <p:cond delay="0"/>
+                                  </p:stCondLst>
+                                  <p:childTnLst>
+                                    <p:set>
+                                      <p:cBhvr>
+                                        <p:cTn id="6" dur="1" fill="hold">
+                                          <p:stCondLst>
+                                            <p:cond delay="0"/>
+                                          </p:stCondLst>
+                                        </p:cTn>
+                                        <p:tgtEl>
+                                          <p:spTgt spid="2"/>
+                                        </p:tgtEl>
+                                        <p:attrNameLst>
+                                          <p:attrName>style.visibility</p:attrName>
+                                        </p:attrNameLst>
+                                      </p:cBhvr>
+                                      <p:to>
+                                        <p:strVal val="visible"/>
+                                      </p:to>
+                                    </p:set>
+                                    <p:animEffect transition="in" filter="fade">
+                                      <p:cBhvr>
+                                        <p:cTn id="7" dur="1000"/>
+                                        <p:tgtEl>
+                                          <p:spTgt spid="2"/>
+                                        </p:tgtEl>
+                                      </p:cBhvr>
+                                    </p:animEffect>
+                                    <p:anim calcmode="lin" valueType="num">
+                                      <p:cBhvr>
+                                        <p:cTn id="8" dur="1000" fill="hold"/>
+                                        <p:tgtEl>
+                                          <p:spTgt spid="2"/>
+                                        </p:tgtEl>
+                                        <p:attrNameLst>
+                                          <p:attrName>ppt_x</p:attrName>
+                                        </p:attrNameLst>
+                                      </p:cBhvr>
+                                      <p:tavLst>
+                                        <p:tav tm="0">
+                                          <p:val>
+                                            <p:strVal val="#ppt_x"/>
+                                          </p:val>
+                                        </p:tav>
+                                        <p:tav tm="100000">
+                                          <p:val>
+                                            <p:strVal val="#ppt_x"/>
+                                          </p:val>
+                                        </p:tav>
+                                      </p:tavLst>
+                                    </p:anim>
+                                    <p:anim calcmode="lin" valueType="num">
+                                      <p:cBhvr>
+                                        <p:cTn id="9" dur="1000" fill="hold"/>
+                                        <p:tgtEl>
+                                          <p:spTgt spid="2"/>
+                                        </p:tgtEl>
+                                        <p:attrNameLst>
+                                          <p:attrName>ppt_y</p:attrName>
+                                        </p:attrNameLst>
+                                      </p:cBhvr>
+                                      <p:tavLst>
+                                        <p:tav tm="0">
+                                          <p:val>
+                                            <p:strVal val="#ppt_y-.1"/>
+                                          </p:val>
+                                        </p:tav>
+                                        <p:tav tm="100000">
+                                          <p:val>
+                                            <p:strVal val="#ppt_y"/>
+                                          </p:val>
+                                        </p:tav>
+                                      </p:tavLst>
+                                    </p:anim>
+                                  </p:childTnLst>
+                                </p:cTn>
+                              </p:par>
+                            </p:childTnLst>
+                          </p:cTn>
+                        </p:par>
+                        <p:par>
+                          <p:cTn id="10" fill="hold">
+                            <p:stCondLst>
+                              <p:cond delay="1000"/>
+                            </p:stCondLst>
+                            <p:childTnLst>
+                              <p:par>
+                                <p:cTn id="11" presetID="10" presetClass="entr" presetSubtype="0" fill="hold" nodeType="afterEffect">
+                                  <p:stCondLst>
+                                    <p:cond delay="0"/>
+                                  </p:stCondLst>
+                                  <p:childTnLst>
+                                    <p:set>
+                                      <p:cBhvr>
+                                        <p:cTn id="12" dur="1" fill="hold">
+                                          <p:stCondLst>
+                                            <p:cond delay="0"/>
+                                          </p:stCondLst>
+                                        </p:cTn>
+                                        <p:tgtEl>
+                                          <p:spTgt spid="3">
+                                            <p:txEl>
+                                              <p:pRg st="0" end="0"/>
+                                            </p:txEl>
+                                          </p:spTgt>
+                                        </p:tgtEl>
+                                        <p:attrNameLst>
+                                          <p:attrName>style.visibility</p:attrName>
+                                        </p:attrNameLst>
+                                      </p:cBhvr>
+                                      <p:to>
+                                        <p:strVal val="visible"/>
+                                      </p:to>
+                                    </p:set>
+                                    <p:animEffect transition="in" filter="fade">
+                                      <p:cBhvr>
+                                        <p:cTn id="13" dur="500"/>
+                                        <p:tgtEl>
+                                          <p:spTgt spid="3">
+                                            <p:txEl>
+                                              <p:pRg st="0" end="0"/>
+                                            </p:txEl>
+                                          </p:spTgt>
+                                        </p:tgtEl>
+                                      </p:cBhvr>
+                                    </p:animEffect>
+                                  </p:childTnLst>
+                                </p:cTn>
+                              </p:par>
+                            </p:childTnLst>
+                          </p:cTn>
+                        </p:par>
+                        <p:par>
+                          <p:cTn id="14" fill="hold">
+                            <p:stCondLst>
+                              <p:cond delay="1500"/>
+                            </p:stCondLst>
+                            <p:childTnLst>
+                              <p:par>
+                                <p:cTn id="15" presetID="10" presetClass="entr" presetSubtype="0" fill="hold" nodeType="afterEffect">
+                                  <p:stCondLst>
+                                    <p:cond delay="0"/>
+                                  </p:stCondLst>
+                                  <p:childTnLst>
+                                    <p:set>
+                                      <p:cBhvr>
+                                        <p:cTn id="16" dur="1" fill="hold">
+                                          <p:stCondLst>
+                                            <p:cond delay="0"/>
+                                          </p:stCondLst>
+                                        </p:cTn>
+                                        <p:tgtEl>
+                                          <p:spTgt spid="3">
+                                            <p:txEl>
+                                              <p:pRg st="1" end="1"/>
+                                            </p:txEl>
+                                          </p:spTgt>
+                                        </p:tgtEl>
+                                        <p:attrNameLst>
+                                          <p:attrName>style.visibility</p:attrName>
+                                        </p:attrNameLst>
+                                      </p:cBhvr>
+                                      <p:to>
+                                        <p:strVal val="visible"/>
+                                      </p:to>
+                                    </p:set>
+                                    <p:animEffect transition="in" filter="fade">
+                                      <p:cBhvr>
+                                        <p:cTn id="17" dur="500"/>
+                                        <p:tgtEl>
+                                          <p:spTgt spid="3">
+                                            <p:txEl>
+                                              <p:pRg st="1" end="1"/>
+                                            </p:txEl>
+                                          </p:spTgt>
+                                        </p:tgtEl>
+                                      </p:cBhvr>
+                                    </p:animEffect>
+                                  </p:childTnLst>
+                                </p:cTn>
+                              </p:par>
+                            </p:childTnLst>
+                          </p:cTn>
+                        </p:par>
+                        <p:par>
+                          <p:cTn id="18" fill="hold">
+                            <p:stCondLst>
+                              <p:cond delay="2000"/>
+                            </p:stCondLst>
+                            <p:childTnLst>
+                              <p:par>
+                                <p:cTn id="19" presetID="10" presetClass="entr" presetSubtype="0" fill="hold" nodeType="afterEffect">
+                                  <p:stCondLst>
+                                    <p:cond delay="0"/>
+                                  </p:stCondLst>
+                                  <p:childTnLst>
+                                    <p:set>
+                                      <p:cBhvr>
+                                        <p:cTn id="20" dur="1" fill="hold">
+                                          <p:stCondLst>
+                                            <p:cond delay="0"/>
+                                          </p:stCondLst>
+                                        </p:cTn>
+                                        <p:tgtEl>
+                                          <p:spTgt spid="3">
+                                            <p:txEl>
+                                              <p:pRg st="2" end="2"/>
+                                            </p:txEl>
+                                          </p:spTgt>
+                                        </p:tgtEl>
+                                        <p:attrNameLst>
+                                          <p:attrName>style.visibility</p:attrName>
+                                        </p:attrNameLst>
+                                      </p:cBhvr>
+                                      <p:to>
+                                        <p:strVal val="visible"/>
+                                      </p:to>
+                                    </p:set>
+                                    <p:animEffect transition="in" filter="fade">
+                                      <p:cBhvr>
+                                        <p:cTn id="21" dur="500"/>
+                                        <p:tgtEl>
+                                          <p:spTgt spid="3">
+                                            <p:txEl>
+                                              <p:pRg st="2" end="2"/>
+                                            </p:txEl>
+                                          </p:spTgt>
+                                        </p:tgtEl>
+                                      </p:cBhvr>
+                                    </p:animEffect>
+                                  </p:childTnLst>
+                                </p:cTn>
+                              </p:par>
+                            </p:childTnLst>
+                          </p:cTn>
+                        </p:par>
+                        <p:par>
+                          <p:cTn id="22" fill="hold">
+                            <p:stCondLst>
+                              <p:cond delay="2500"/>
+                            </p:stCondLst>
+                            <p:childTnLst>
+                              <p:par>
+                                <p:cTn id="23" presetID="10" presetClass="entr" presetSubtype="0" fill="hold" nodeType="afterEffect">
+                                  <p:stCondLst>
+                                    <p:cond delay="0"/>
+                                  </p:stCondLst>
+                                  <p:childTnLst>
+                                    <p:set>
+                                      <p:cBhvr>
+                                        <p:cTn id="24" dur="1" fill="hold">
+                                          <p:stCondLst>
+                                            <p:cond delay="0"/>
+                                          </p:stCondLst>
+                                        </p:cTn>
+                                        <p:tgtEl>
+                                          <p:spTgt spid="3">
+                                            <p:txEl>
+                                              <p:pRg st="3" end="3"/>
+                                            </p:txEl>
+                                          </p:spTgt>
+                                        </p:tgtEl>
+                                        <p:attrNameLst>
+                                          <p:attrName>style.visibility</p:attrName>
+                                        </p:attrNameLst>
+                                      </p:cBhvr>
+                                      <p:to>
+                                        <p:strVal val="visible"/>
+                                      </p:to>
+                                    </p:set>
+                                    <p:animEffect transition="in" filter="fade">
+                                      <p:cBhvr>
+                                        <p:cTn id="25" dur="500"/>
+                                        <p:tgtEl>
+                                          <p:spTgt spid="3">
+                                            <p:txEl>
+                                              <p:pRg st="3" end="3"/>
+                                            </p:txEl>
+                                          </p:spTgt>
+                                        </p:tgtEl>
+                                      </p:cBhvr>
+                                    </p:animEffect>
+                                  </p:childTnLst>
+                                </p:cTn>
+                              </p:par>
+                            </p:childTnLst>
+                          </p:cTn>
+                        </p:par>
+                        <p:par>
+                          <p:cTn id="26" fill="hold">
+                            <p:stCondLst>
+                              <p:cond delay="3000"/>
+                            </p:stCondLst>
+                            <p:childTnLst>
+                              <p:par>
+                                <p:cTn id="27" presetID="10" presetClass="entr" presetSubtype="0" fill="hold" nodeType="afterEffect">
+                                  <p:stCondLst>
+                                    <p:cond delay="0"/>
+                                  </p:stCondLst>
+                                  <p:childTnLst>
+                                    <p:set>
+                                      <p:cBhvr>
+                                        <p:cTn id="28" dur="1" fill="hold">
+                                          <p:stCondLst>
+                                            <p:cond delay="0"/>
+                                          </p:stCondLst>
+                                        </p:cTn>
+                                        <p:tgtEl>
+                                          <p:spTgt spid="3">
+                                            <p:txEl>
+                                              <p:pRg st="4" end="4"/>
+                                            </p:txEl>
+                                          </p:spTgt>
+                                        </p:tgtEl>
+                                        <p:attrNameLst>
+                                          <p:attrName>style.visibility</p:attrName>
+                                        </p:attrNameLst>
+                                      </p:cBhvr>
+                                      <p:to>
+                                        <p:strVal val="visible"/>
+                                      </p:to>
+                                    </p:set>
+                                    <p:animEffect transition="in" filter="fade">
+                                      <p:cBhvr>
+                                        <p:cTn id="29" dur="500"/>
+                                        <p:tgtEl>
+                                          <p:spTgt spid="3">
+                                            <p:txEl>
+                                              <p:pRg st="4" end="4"/>
+                                            </p:txEl>
+                                          </p:spTgt>
+                                        </p:tgtEl>
+                                      </p:cBhvr>
+                                    </p:animEffect>
+                                  </p:childTnLst>
+                                </p:cTn>
+                              </p:par>
+                            </p:childTnLst>
+                          </p:cTn>
+                        </p:par>
+                        <p:par>
+                          <p:cTn id="30" fill="hold">
+                            <p:stCondLst>
+                              <p:cond delay="3500"/>
+                            </p:stCondLst>
+                            <p:childTnLst>
+                              <p:par>
+                                <p:cTn id="31" presetID="10" presetClass="entr" presetSubtype="0" fill="hold" nodeType="afterEffect">
+                                  <p:stCondLst>
+                                    <p:cond delay="0"/>
+                                  </p:stCondLst>
+                                  <p:childTnLst>
+                                    <p:set>
+                                      <p:cBhvr>
+                                        <p:cTn id="32" dur="1" fill="hold">
+                                          <p:stCondLst>
+                                            <p:cond delay="0"/>
+                                          </p:stCondLst>
+                                        </p:cTn>
+                                        <p:tgtEl>
+                                          <p:spTgt spid="3">
+                                            <p:txEl>
+                                              <p:pRg st="5" end="5"/>
+                                            </p:txEl>
+                                          </p:spTgt>
+                                        </p:tgtEl>
+                                        <p:attrNameLst>
+                                          <p:attrName>style.visibility</p:attrName>
+                                        </p:attrNameLst>
+                                      </p:cBhvr>
+                                      <p:to>
+                                        <p:strVal val="visible"/>
+                                      </p:to>
+                                    </p:set>
+                                    <p:animEffect transition="in" filter="fade">
+                                      <p:cBhvr>
+                                        <p:cTn id="33" dur="500"/>
+                                        <p:tgtEl>
+                                          <p:spTgt spid="3">
+                                            <p:txEl>
+                                              <p:pRg st="5" end="5"/>
+                                            </p:txEl>
+                                          </p:spTgt>
+                                        </p:tgtEl>
+                                      </p:cBhvr>
+                                    </p:animEffect>
+                                  </p:childTnLst>
+                                </p:cTn>
+                              </p:par>
+                            </p:childTnLst>
+                          </p:cTn>
+                        </p:par>
+                      </p:childTnLst>
+                    </p:cTn>
+                  </p:par>
+                </p:childTnLst>
+              </p:cTn>
+              <p:prevCondLst>
+                <p:cond evt="onPrev" delay="0">
+                  <p:tgtEl>
+                    <p:sldTgt/>
+                  </p:tgtEl>
+                </p:cond>
+              </p:prevCondLst>
+              <p:nextCondLst>
+                <p:cond evt="onNext" delay="0">
+                  <p:tgtEl>
+                    <p:sldTgt/>
+                  </p:tgtEl>
+                </p:cond>
+              </p:nextCondLst>
+            </p:seq>
+          </p:childTnLst>
+        </p:cTn>
+      </p:par>
+    </p:tnLst>
+    <p:bldLst>
+      <p:bldP spid="2" grpId="0"/>
+    </p:bldLst>
+  </p:timing>
+</p:sld>
+</file>
+
+<file path=ppt/slides/slide6.xml><?xml version="1.0" encoding="utf-8"?>
+<p:sld xmlns:a="http://schemas.openxmlformats.org/drawingml/2006/main" xmlns:r="http://schemas.openxmlformats.org/officeDocument/2006/relationships" xmlns:p="http://schemas.openxmlformats.org/presentationml/2006/main">
+  <p:cSld>
+    <p:spTree>
+      <p:nvGrpSpPr>
+        <p:cNvPr id="1" name=""/>
+        <p:cNvGrpSpPr/>
+        <p:nvPr/>
+      </p:nvGrpSpPr>
+      <p:grpSpPr>
+        <a:xfrm>
+          <a:off x="0" y="0"/>
+          <a:ext cx="0" cy="0"/>
+          <a:chOff x="0" y="0"/>
+          <a:chExt cx="0" cy="0"/>
+        </a:xfrm>
+      </p:grpSpPr>
+      <p:sp>
+        <p:nvSpPr>
+          <p:cNvPr id="2" name="Заголовок 1">
+            <a:extLst>
+              <a:ext uri="{FF2B5EF4-FFF2-40B4-BE49-F238E27FC236}">
+                <a16:creationId xmlns:a16="http://schemas.microsoft.com/office/drawing/2014/main" id="{F209A495-8E3F-4CFE-86E0-75920089882B}"/>
+              </a:ext>
+            </a:extLst>
+          </p:cNvPr>
+          <p:cNvSpPr>
+            <a:spLocks noGrp="1"/>
+          </p:cNvSpPr>
+          <p:nvPr>
+            <p:ph type="title"/>
+          </p:nvPr>
+        </p:nvSpPr>
+        <p:spPr/>
+        <p:txBody>
+          <a:bodyPr>
+            <a:normAutofit/>
+          </a:bodyPr>
+          <a:lstStyle/>
+          <a:p>
+            <a:pPr algn="ctr"/>
+            <a:r>
+              <a:rPr lang="ru-RU" sz="4000" dirty="0" smtClean="0">
+                <a:solidFill>
+                  <a:srgbClr val="36A9E1"/>
+                </a:solidFill>
+                <a:latin typeface="Segoe UI Black" panose="020B0A02040204020203" pitchFamily="34" charset="0"/>
+                <a:ea typeface="Segoe UI Black" panose="020B0A02040204020203" pitchFamily="34" charset="0"/>
+              </a:rPr>
+              <a:t>Ресурсы проекта</a:t>
+            </a:r>
+            <a:endParaRPr lang="ru-RU" sz="4000" dirty="0">
+              <a:solidFill>
+                <a:srgbClr val="36A9E1"/>
+              </a:solidFill>
+              <a:latin typeface="Segoe UI Black" panose="020B0A02040204020203" pitchFamily="34" charset="0"/>
+              <a:ea typeface="Segoe UI Black" panose="020B0A02040204020203" pitchFamily="34" charset="0"/>
+            </a:endParaRPr>
+          </a:p>
+        </p:txBody>
+      </p:sp>
+      <p:sp>
+        <p:nvSpPr>
+          <p:cNvPr id="3" name="Объект 2">
+            <a:extLst>
+              <a:ext uri="{FF2B5EF4-FFF2-40B4-BE49-F238E27FC236}">
+                <a16:creationId xmlns:a16="http://schemas.microsoft.com/office/drawing/2014/main" id="{6B41888E-AA9C-4D55-AAD7-6D821BC62010}"/>
+              </a:ext>
+            </a:extLst>
+          </p:cNvPr>
+          <p:cNvSpPr>
+            <a:spLocks noGrp="1"/>
+          </p:cNvSpPr>
+          <p:nvPr>
+            <p:ph idx="1"/>
+          </p:nvPr>
+        </p:nvSpPr>
+        <p:spPr>
+          <a:xfrm>
+            <a:off x="480060" y="1800687"/>
+            <a:ext cx="11231880" cy="4351338"/>
+          </a:xfrm>
+        </p:spPr>
+        <p:txBody>
+          <a:bodyPr>
+            <a:noAutofit/>
+          </a:bodyPr>
+          <a:lstStyle/>
+          <a:p>
+            <a:pPr marL="0" indent="0">
+              <a:buNone/>
+            </a:pPr>
+            <a:r>
+              <a:rPr lang="ru-RU" sz="2400" dirty="0" smtClean="0">
+                <a:latin typeface="Segoe UI Light" panose="020B0502040204020203" pitchFamily="34" charset="0"/>
+                <a:ea typeface="Segoe UI Black" panose="020B0A02040204020203" pitchFamily="34" charset="0"/>
+                <a:cs typeface="Segoe UI Light" panose="020B0502040204020203" pitchFamily="34" charset="0"/>
+              </a:rPr>
+              <a:t>В проекте использовались следующие </a:t>
+            </a:r>
+            <a:r>
+              <a:rPr lang="ru-RU" sz="2400" dirty="0" err="1" smtClean="0">
+                <a:latin typeface="Segoe UI Light" panose="020B0502040204020203" pitchFamily="34" charset="0"/>
+                <a:ea typeface="Segoe UI Black" panose="020B0A02040204020203" pitchFamily="34" charset="0"/>
+                <a:cs typeface="Segoe UI Light" panose="020B0502040204020203" pitchFamily="34" charset="0"/>
+              </a:rPr>
+              <a:t>библеотеки</a:t>
+            </a:r>
+            <a:r>
+              <a:rPr lang="ru-RU" sz="2400" dirty="0" smtClean="0">
+                <a:latin typeface="Segoe UI Light" panose="020B0502040204020203" pitchFamily="34" charset="0"/>
+                <a:ea typeface="Segoe UI Black" panose="020B0A02040204020203" pitchFamily="34" charset="0"/>
+                <a:cs typeface="Segoe UI Light" panose="020B0502040204020203" pitchFamily="34" charset="0"/>
+              </a:rPr>
+              <a:t>:</a:t>
+            </a:r>
+          </a:p>
+          <a:p>
+            <a:pPr marL="0" indent="0">
+              <a:buNone/>
+            </a:pPr>
+            <a:r>
+              <a:rPr lang="ru-RU" sz="2400" dirty="0" smtClean="0">
+                <a:latin typeface="Segoe UI Light" panose="020B0502040204020203" pitchFamily="34" charset="0"/>
+                <a:ea typeface="Segoe UI Black" panose="020B0A02040204020203" pitchFamily="34" charset="0"/>
+                <a:cs typeface="Segoe UI Light" panose="020B0502040204020203" pitchFamily="34" charset="0"/>
+              </a:rPr>
+              <a:t>1) Серверное приложение реализовано с помощью </a:t>
+            </a:r>
+            <a:r>
+              <a:rPr lang="ru-RU" sz="2400" dirty="0" err="1" smtClean="0">
+                <a:latin typeface="Segoe UI Light" panose="020B0502040204020203" pitchFamily="34" charset="0"/>
+                <a:ea typeface="Segoe UI Black" panose="020B0A02040204020203" pitchFamily="34" charset="0"/>
+                <a:cs typeface="Segoe UI Light" panose="020B0502040204020203" pitchFamily="34" charset="0"/>
+              </a:rPr>
+              <a:t>библеотеки</a:t>
+            </a:r>
+            <a:r>
+              <a:rPr lang="ru-RU" sz="2400" dirty="0" smtClean="0">
+                <a:latin typeface="Segoe UI Light" panose="020B0502040204020203" pitchFamily="34" charset="0"/>
+                <a:ea typeface="Segoe UI Black" panose="020B0A02040204020203" pitchFamily="34" charset="0"/>
+                <a:cs typeface="Segoe UI Light" panose="020B0502040204020203" pitchFamily="34" charset="0"/>
+              </a:rPr>
+              <a:t> </a:t>
+            </a:r>
+            <a:r>
+              <a:rPr lang="ru-RU" sz="2400" b="1" i="1" dirty="0" err="1" smtClean="0">
+                <a:solidFill>
+                  <a:srgbClr val="36A9E1"/>
+                </a:solidFill>
+                <a:latin typeface="Segoe UI Light" panose="020B0502040204020203" pitchFamily="34" charset="0"/>
+                <a:ea typeface="Segoe UI Black" panose="020B0A02040204020203" pitchFamily="34" charset="0"/>
+                <a:cs typeface="Segoe UI Light" panose="020B0502040204020203" pitchFamily="34" charset="0"/>
+              </a:rPr>
+              <a:t>flask</a:t>
+            </a:r>
+            <a:r>
+              <a:rPr lang="ru-RU" sz="2400" dirty="0" smtClean="0">
+                <a:latin typeface="Segoe UI Light" panose="020B0502040204020203" pitchFamily="34" charset="0"/>
+                <a:ea typeface="Segoe UI Black" panose="020B0A02040204020203" pitchFamily="34" charset="0"/>
+                <a:cs typeface="Segoe UI Light" panose="020B0502040204020203" pitchFamily="34" charset="0"/>
+              </a:rPr>
+              <a:t>.</a:t>
+            </a:r>
+          </a:p>
+          <a:p>
+            <a:pPr marL="0" indent="0">
+              <a:buNone/>
+            </a:pPr>
+            <a:r>
+              <a:rPr lang="ru-RU" sz="2400" dirty="0" smtClean="0">
+                <a:latin typeface="Segoe UI Light" panose="020B0502040204020203" pitchFamily="34" charset="0"/>
+                <a:ea typeface="Segoe UI Black" panose="020B0A02040204020203" pitchFamily="34" charset="0"/>
+                <a:cs typeface="Segoe UI Light" panose="020B0502040204020203" pitchFamily="34" charset="0"/>
+              </a:rPr>
+              <a:t>2</a:t>
+            </a:r>
+            <a:r>
+              <a:rPr lang="ru-RU" sz="2400" dirty="0">
+                <a:latin typeface="Segoe UI Light" panose="020B0502040204020203" pitchFamily="34" charset="0"/>
+                <a:ea typeface="Segoe UI Black" panose="020B0A02040204020203" pitchFamily="34" charset="0"/>
+                <a:cs typeface="Segoe UI Light" panose="020B0502040204020203" pitchFamily="34" charset="0"/>
+              </a:rPr>
+              <a:t>) Взаимодействие с </a:t>
+            </a:r>
+            <a:r>
+              <a:rPr lang="ru-RU" sz="2400" dirty="0" smtClean="0">
+                <a:latin typeface="Segoe UI Light" panose="020B0502040204020203" pitchFamily="34" charset="0"/>
+                <a:ea typeface="Segoe UI Black" panose="020B0A02040204020203" pitchFamily="34" charset="0"/>
+                <a:cs typeface="Segoe UI Light" panose="020B0502040204020203" pitchFamily="34" charset="0"/>
+              </a:rPr>
+              <a:t>базой</a:t>
+            </a:r>
+            <a:r>
+              <a:rPr lang="en-US" sz="2400" dirty="0" smtClean="0">
+                <a:latin typeface="Segoe UI Light" panose="020B0502040204020203" pitchFamily="34" charset="0"/>
+                <a:ea typeface="Segoe UI Black" panose="020B0A02040204020203" pitchFamily="34" charset="0"/>
+                <a:cs typeface="Segoe UI Light" panose="020B0502040204020203" pitchFamily="34" charset="0"/>
+              </a:rPr>
+              <a:t> </a:t>
+            </a:r>
+            <a:r>
+              <a:rPr lang="ru-RU" sz="2400" dirty="0" smtClean="0">
+                <a:latin typeface="Segoe UI Light" panose="020B0502040204020203" pitchFamily="34" charset="0"/>
+                <a:ea typeface="Segoe UI Black" panose="020B0A02040204020203" pitchFamily="34" charset="0"/>
+                <a:cs typeface="Segoe UI Light" panose="020B0502040204020203" pitchFamily="34" charset="0"/>
+              </a:rPr>
+              <a:t>данных </a:t>
+            </a:r>
+            <a:r>
+              <a:rPr lang="ru-RU" sz="2400" dirty="0">
+                <a:latin typeface="Segoe UI Light" panose="020B0502040204020203" pitchFamily="34" charset="0"/>
+                <a:ea typeface="Segoe UI Black" panose="020B0A02040204020203" pitchFamily="34" charset="0"/>
+                <a:cs typeface="Segoe UI Light" panose="020B0502040204020203" pitchFamily="34" charset="0"/>
+              </a:rPr>
+              <a:t>реализовано при помощи </a:t>
+            </a:r>
+            <a:r>
+              <a:rPr lang="ru-RU" sz="2400" dirty="0" err="1">
+                <a:latin typeface="Segoe UI Light" panose="020B0502040204020203" pitchFamily="34" charset="0"/>
+                <a:ea typeface="Segoe UI Black" panose="020B0A02040204020203" pitchFamily="34" charset="0"/>
+                <a:cs typeface="Segoe UI Light" panose="020B0502040204020203" pitchFamily="34" charset="0"/>
+              </a:rPr>
+              <a:t>библеотеки</a:t>
+            </a:r>
+            <a:r>
+              <a:rPr lang="ru-RU" sz="2400" dirty="0">
+                <a:latin typeface="Segoe UI Light" panose="020B0502040204020203" pitchFamily="34" charset="0"/>
+                <a:ea typeface="Segoe UI Black" panose="020B0A02040204020203" pitchFamily="34" charset="0"/>
+                <a:cs typeface="Segoe UI Light" panose="020B0502040204020203" pitchFamily="34" charset="0"/>
+              </a:rPr>
+              <a:t> </a:t>
+            </a:r>
+            <a:r>
+              <a:rPr lang="ru-RU" sz="2400" b="1" i="1" dirty="0" err="1">
+                <a:solidFill>
+                  <a:srgbClr val="36A9E1"/>
+                </a:solidFill>
+                <a:latin typeface="Segoe UI Light" panose="020B0502040204020203" pitchFamily="34" charset="0"/>
+                <a:ea typeface="Segoe UI Black" panose="020B0A02040204020203" pitchFamily="34" charset="0"/>
+                <a:cs typeface="Segoe UI Light" panose="020B0502040204020203" pitchFamily="34" charset="0"/>
+              </a:rPr>
+              <a:t>sqlalchemy</a:t>
+            </a:r>
+            <a:r>
+              <a:rPr lang="ru-RU" sz="2400" dirty="0">
+                <a:latin typeface="Segoe UI Light" panose="020B0502040204020203" pitchFamily="34" charset="0"/>
+                <a:ea typeface="Segoe UI Black" panose="020B0A02040204020203" pitchFamily="34" charset="0"/>
+                <a:cs typeface="Segoe UI Light" panose="020B0502040204020203" pitchFamily="34" charset="0"/>
+              </a:rPr>
+              <a:t>.</a:t>
+            </a:r>
+          </a:p>
+          <a:p>
+            <a:pPr marL="0" indent="0">
+              <a:buNone/>
+            </a:pPr>
+            <a:r>
+              <a:rPr lang="ru-RU" sz="2400" dirty="0">
+                <a:latin typeface="Segoe UI Light" panose="020B0502040204020203" pitchFamily="34" charset="0"/>
+                <a:ea typeface="Segoe UI Black" panose="020B0A02040204020203" pitchFamily="34" charset="0"/>
+                <a:cs typeface="Segoe UI Light" panose="020B0502040204020203" pitchFamily="34" charset="0"/>
+              </a:rPr>
+              <a:t>3) </a:t>
+            </a:r>
+            <a:r>
+              <a:rPr lang="ru-RU" sz="2400" dirty="0" err="1">
+                <a:latin typeface="Segoe UI Light" panose="020B0502040204020203" pitchFamily="34" charset="0"/>
+                <a:ea typeface="Segoe UI Black" panose="020B0A02040204020203" pitchFamily="34" charset="0"/>
+                <a:cs typeface="Segoe UI Light" panose="020B0502040204020203" pitchFamily="34" charset="0"/>
+              </a:rPr>
+              <a:t>Аутификация</a:t>
+            </a:r>
+            <a:r>
+              <a:rPr lang="ru-RU" sz="2400" dirty="0">
+                <a:latin typeface="Segoe UI Light" panose="020B0502040204020203" pitchFamily="34" charset="0"/>
+                <a:ea typeface="Segoe UI Black" panose="020B0A02040204020203" pitchFamily="34" charset="0"/>
+                <a:cs typeface="Segoe UI Light" panose="020B0502040204020203" pitchFamily="34" charset="0"/>
+              </a:rPr>
+              <a:t> пользователя реализовано при помощи </a:t>
+            </a:r>
+            <a:r>
+              <a:rPr lang="ru-RU" sz="2400" dirty="0" err="1">
+                <a:latin typeface="Segoe UI Light" panose="020B0502040204020203" pitchFamily="34" charset="0"/>
+                <a:ea typeface="Segoe UI Black" panose="020B0A02040204020203" pitchFamily="34" charset="0"/>
+                <a:cs typeface="Segoe UI Light" panose="020B0502040204020203" pitchFamily="34" charset="0"/>
+              </a:rPr>
+              <a:t>библеоткеки</a:t>
+            </a:r>
+            <a:r>
+              <a:rPr lang="ru-RU" sz="2400" dirty="0">
+                <a:latin typeface="Segoe UI Light" panose="020B0502040204020203" pitchFamily="34" charset="0"/>
+                <a:ea typeface="Segoe UI Black" panose="020B0A02040204020203" pitchFamily="34" charset="0"/>
+                <a:cs typeface="Segoe UI Light" panose="020B0502040204020203" pitchFamily="34" charset="0"/>
+              </a:rPr>
+              <a:t> </a:t>
+            </a:r>
+            <a:r>
+              <a:rPr lang="ru-RU" sz="2400" b="1" i="1" dirty="0" err="1">
+                <a:solidFill>
+                  <a:srgbClr val="36A9E1"/>
+                </a:solidFill>
+                <a:latin typeface="Segoe UI Light" panose="020B0502040204020203" pitchFamily="34" charset="0"/>
+                <a:ea typeface="Segoe UI Black" panose="020B0A02040204020203" pitchFamily="34" charset="0"/>
+                <a:cs typeface="Segoe UI Light" panose="020B0502040204020203" pitchFamily="34" charset="0"/>
+              </a:rPr>
+              <a:t>flask_login</a:t>
+            </a:r>
+            <a:r>
+              <a:rPr lang="ru-RU" sz="2400" dirty="0">
+                <a:latin typeface="Segoe UI Light" panose="020B0502040204020203" pitchFamily="34" charset="0"/>
+                <a:ea typeface="Segoe UI Black" panose="020B0A02040204020203" pitchFamily="34" charset="0"/>
+                <a:cs typeface="Segoe UI Light" panose="020B0502040204020203" pitchFamily="34" charset="0"/>
+              </a:rPr>
+              <a:t>.</a:t>
+            </a:r>
+          </a:p>
+          <a:p>
+            <a:pPr marL="0" indent="0">
+              <a:buNone/>
+            </a:pPr>
+            <a:r>
+              <a:rPr lang="ru-RU" sz="2400" dirty="0">
+                <a:latin typeface="Segoe UI Light" panose="020B0502040204020203" pitchFamily="34" charset="0"/>
+                <a:ea typeface="Segoe UI Black" panose="020B0A02040204020203" pitchFamily="34" charset="0"/>
+                <a:cs typeface="Segoe UI Light" panose="020B0502040204020203" pitchFamily="34" charset="0"/>
+              </a:rPr>
+              <a:t>4) HTML-формы реализованы с помощью </a:t>
+            </a:r>
+            <a:r>
+              <a:rPr lang="ru-RU" sz="2400" b="1" i="1" dirty="0" err="1">
+                <a:solidFill>
+                  <a:srgbClr val="36A9E1"/>
+                </a:solidFill>
+                <a:latin typeface="Segoe UI Light" panose="020B0502040204020203" pitchFamily="34" charset="0"/>
+                <a:ea typeface="Segoe UI Black" panose="020B0A02040204020203" pitchFamily="34" charset="0"/>
+                <a:cs typeface="Segoe UI Light" panose="020B0502040204020203" pitchFamily="34" charset="0"/>
+              </a:rPr>
+              <a:t>wtforms</a:t>
+            </a:r>
+            <a:r>
+              <a:rPr lang="ru-RU" sz="2400" dirty="0">
+                <a:latin typeface="Segoe UI Light" panose="020B0502040204020203" pitchFamily="34" charset="0"/>
+                <a:ea typeface="Segoe UI Black" panose="020B0A02040204020203" pitchFamily="34" charset="0"/>
+                <a:cs typeface="Segoe UI Light" panose="020B0502040204020203" pitchFamily="34" charset="0"/>
+              </a:rPr>
+              <a:t>.</a:t>
+            </a:r>
+          </a:p>
+          <a:p>
+            <a:pPr marL="0" indent="0">
+              <a:buNone/>
+            </a:pPr>
+            <a:endParaRPr lang="ru-RU" sz="2400" dirty="0">
+              <a:latin typeface="Segoe UI Light" panose="020B0502040204020203" pitchFamily="34" charset="0"/>
+              <a:ea typeface="Segoe UI Black" panose="020B0A02040204020203" pitchFamily="34" charset="0"/>
+              <a:cs typeface="Segoe UI Light" panose="020B0502040204020203" pitchFamily="34" charset="0"/>
+            </a:endParaRPr>
+          </a:p>
+        </p:txBody>
+      </p:sp>
+    </p:spTree>
+    <p:extLst>
+      <p:ext uri="{BB962C8B-B14F-4D97-AF65-F5344CB8AC3E}">
+        <p14:creationId xmlns:p14="http://schemas.microsoft.com/office/powerpoint/2010/main" val="2431688720"/>
+      </p:ext>
+    </p:extLst>
+  </p:cSld>
+  <p:clrMapOvr>
+    <a:masterClrMapping/>
+  </p:clrMapOvr>
+  <p:timing>
+    <p:tnLst>
+      <p:par>
+        <p:cTn id="1" dur="indefinite" restart="never" nodeType="tmRoot">
+          <p:childTnLst>
+            <p:seq concurrent="1" nextAc="seek">
+              <p:cTn id="2" dur="indefinite" nodeType="mainSeq">
+                <p:childTnLst>
+                  <p:par>
+                    <p:cTn id="3" fill="hold">
+                      <p:stCondLst>
+                        <p:cond delay="indefinite"/>
+                        <p:cond evt="onBegin" delay="0">
+                          <p:tn val="2"/>
+                        </p:cond>
+                      </p:stCondLst>
+                      <p:childTnLst>
+                        <p:par>
+                          <p:cTn id="4" fill="hold">
+                            <p:stCondLst>
+                              <p:cond delay="0"/>
+                            </p:stCondLst>
+                            <p:childTnLst>
+                              <p:par>
+                                <p:cTn id="5" presetID="47" presetClass="entr" presetSubtype="0" fill="hold" grpId="0" nodeType="afterEffect">
+                                  <p:stCondLst>
+                                    <p:cond delay="0"/>
+                                  </p:stCondLst>
+                                  <p:childTnLst>
+                                    <p:set>
+                                      <p:cBhvr>
+                                        <p:cTn id="6" dur="1" fill="hold">
+                                          <p:stCondLst>
+                                            <p:cond delay="0"/>
+                                          </p:stCondLst>
+                                        </p:cTn>
+                                        <p:tgtEl>
+                                          <p:spTgt spid="2"/>
+                                        </p:tgtEl>
+                                        <p:attrNameLst>
+                                          <p:attrName>style.visibility</p:attrName>
+                                        </p:attrNameLst>
+                                      </p:cBhvr>
+                                      <p:to>
+                                        <p:strVal val="visible"/>
+                                      </p:to>
+                                    </p:set>
+                                    <p:animEffect transition="in" filter="fade">
+                                      <p:cBhvr>
+                                        <p:cTn id="7" dur="1000"/>
+                                        <p:tgtEl>
+                                          <p:spTgt spid="2"/>
+                                        </p:tgtEl>
+                                      </p:cBhvr>
+                                    </p:animEffect>
+                                    <p:anim calcmode="lin" valueType="num">
+                                      <p:cBhvr>
+                                        <p:cTn id="8" dur="1000" fill="hold"/>
+                                        <p:tgtEl>
+                                          <p:spTgt spid="2"/>
+                                        </p:tgtEl>
+                                        <p:attrNameLst>
+                                          <p:attrName>ppt_x</p:attrName>
+                                        </p:attrNameLst>
+                                      </p:cBhvr>
+                                      <p:tavLst>
+                                        <p:tav tm="0">
+                                          <p:val>
+                                            <p:strVal val="#ppt_x"/>
+                                          </p:val>
+                                        </p:tav>
+                                        <p:tav tm="100000">
+                                          <p:val>
+                                            <p:strVal val="#ppt_x"/>
+                                          </p:val>
+                                        </p:tav>
+                                      </p:tavLst>
+                                    </p:anim>
+                                    <p:anim calcmode="lin" valueType="num">
+                                      <p:cBhvr>
+                                        <p:cTn id="9" dur="1000" fill="hold"/>
+                                        <p:tgtEl>
+                                          <p:spTgt spid="2"/>
+                                        </p:tgtEl>
+                                        <p:attrNameLst>
+                                          <p:attrName>ppt_y</p:attrName>
+                                        </p:attrNameLst>
+                                      </p:cBhvr>
+                                      <p:tavLst>
+                                        <p:tav tm="0">
+                                          <p:val>
+                                            <p:strVal val="#ppt_y-.1"/>
+                                          </p:val>
+                                        </p:tav>
+                                        <p:tav tm="100000">
+                                          <p:val>
+                                            <p:strVal val="#ppt_y"/>
+                                          </p:val>
+                                        </p:tav>
+                                      </p:tavLst>
+                                    </p:anim>
+                                  </p:childTnLst>
+                                </p:cTn>
+                              </p:par>
+                            </p:childTnLst>
+                          </p:cTn>
+                        </p:par>
+                        <p:par>
+                          <p:cTn id="10" fill="hold">
+                            <p:stCondLst>
+                              <p:cond delay="1000"/>
+                            </p:stCondLst>
+                            <p:childTnLst>
+                              <p:par>
+                                <p:cTn id="11" presetID="10" presetClass="entr" presetSubtype="0" fill="hold" nodeType="afterEffect">
+                                  <p:stCondLst>
+                                    <p:cond delay="0"/>
+                                  </p:stCondLst>
+                                  <p:childTnLst>
+                                    <p:set>
+                                      <p:cBhvr>
+                                        <p:cTn id="12" dur="1" fill="hold">
+                                          <p:stCondLst>
+                                            <p:cond delay="0"/>
+                                          </p:stCondLst>
+                                        </p:cTn>
+                                        <p:tgtEl>
+                                          <p:spTgt spid="3">
+                                            <p:txEl>
+                                              <p:pRg st="0" end="0"/>
+                                            </p:txEl>
+                                          </p:spTgt>
+                                        </p:tgtEl>
+                                        <p:attrNameLst>
+                                          <p:attrName>style.visibility</p:attrName>
+                                        </p:attrNameLst>
+                                      </p:cBhvr>
+                                      <p:to>
+                                        <p:strVal val="visible"/>
+                                      </p:to>
+                                    </p:set>
+                                    <p:animEffect transition="in" filter="fade">
+                                      <p:cBhvr>
+                                        <p:cTn id="13" dur="500"/>
+                                        <p:tgtEl>
+                                          <p:spTgt spid="3">
+                                            <p:txEl>
+                                              <p:pRg st="0" end="0"/>
+                                            </p:txEl>
+                                          </p:spTgt>
+                                        </p:tgtEl>
+                                      </p:cBhvr>
+                                    </p:animEffect>
+                                  </p:childTnLst>
+                                </p:cTn>
+                              </p:par>
+                            </p:childTnLst>
+                          </p:cTn>
+                        </p:par>
+                        <p:par>
+                          <p:cTn id="14" fill="hold">
+                            <p:stCondLst>
+                              <p:cond delay="1500"/>
+                            </p:stCondLst>
+                            <p:childTnLst>
+                              <p:par>
+                                <p:cTn id="15" presetID="10" presetClass="entr" presetSubtype="0" fill="hold" nodeType="afterEffect">
+                                  <p:stCondLst>
+                                    <p:cond delay="0"/>
+                                  </p:stCondLst>
+                                  <p:childTnLst>
+                                    <p:set>
+                                      <p:cBhvr>
+                                        <p:cTn id="16" dur="1" fill="hold">
+                                          <p:stCondLst>
+                                            <p:cond delay="0"/>
+                                          </p:stCondLst>
+                                        </p:cTn>
+                                        <p:tgtEl>
+                                          <p:spTgt spid="3">
+                                            <p:txEl>
+                                              <p:pRg st="1" end="1"/>
+                                            </p:txEl>
+                                          </p:spTgt>
+                                        </p:tgtEl>
+                                        <p:attrNameLst>
+                                          <p:attrName>style.visibility</p:attrName>
+                                        </p:attrNameLst>
+                                      </p:cBhvr>
+                                      <p:to>
+                                        <p:strVal val="visible"/>
+                                      </p:to>
+                                    </p:set>
+                                    <p:animEffect transition="in" filter="fade">
+                                      <p:cBhvr>
+                                        <p:cTn id="17" dur="500"/>
+                                        <p:tgtEl>
+                                          <p:spTgt spid="3">
+                                            <p:txEl>
+                                              <p:pRg st="1" end="1"/>
+                                            </p:txEl>
+                                          </p:spTgt>
+                                        </p:tgtEl>
+                                      </p:cBhvr>
+                                    </p:animEffect>
+                                  </p:childTnLst>
+                                </p:cTn>
+                              </p:par>
+                            </p:childTnLst>
+                          </p:cTn>
+                        </p:par>
+                        <p:par>
+                          <p:cTn id="18" fill="hold">
+                            <p:stCondLst>
+                              <p:cond delay="2000"/>
+                            </p:stCondLst>
+                            <p:childTnLst>
+                              <p:par>
+                                <p:cTn id="19" presetID="10" presetClass="entr" presetSubtype="0" fill="hold" nodeType="afterEffect">
+                                  <p:stCondLst>
+                                    <p:cond delay="0"/>
+                                  </p:stCondLst>
+                                  <p:childTnLst>
+                                    <p:set>
+                                      <p:cBhvr>
+                                        <p:cTn id="20" dur="1" fill="hold">
+                                          <p:stCondLst>
+                                            <p:cond delay="0"/>
+                                          </p:stCondLst>
+                                        </p:cTn>
+                                        <p:tgtEl>
+                                          <p:spTgt spid="3">
+                                            <p:txEl>
+                                              <p:pRg st="2" end="2"/>
+                                            </p:txEl>
+                                          </p:spTgt>
+                                        </p:tgtEl>
+                                        <p:attrNameLst>
+                                          <p:attrName>style.visibility</p:attrName>
+                                        </p:attrNameLst>
+                                      </p:cBhvr>
+                                      <p:to>
+                                        <p:strVal val="visible"/>
+                                      </p:to>
+                                    </p:set>
+                                    <p:animEffect transition="in" filter="fade">
+                                      <p:cBhvr>
+                                        <p:cTn id="21" dur="500"/>
+                                        <p:tgtEl>
+                                          <p:spTgt spid="3">
+                                            <p:txEl>
+                                              <p:pRg st="2" end="2"/>
+                                            </p:txEl>
+                                          </p:spTgt>
+                                        </p:tgtEl>
+                                      </p:cBhvr>
+                                    </p:animEffect>
+                                  </p:childTnLst>
+                                </p:cTn>
+                              </p:par>
+                            </p:childTnLst>
+                          </p:cTn>
+                        </p:par>
+                        <p:par>
+                          <p:cTn id="22" fill="hold">
+                            <p:stCondLst>
+                              <p:cond delay="2500"/>
+                            </p:stCondLst>
+                            <p:childTnLst>
+                              <p:par>
+                                <p:cTn id="23" presetID="10" presetClass="entr" presetSubtype="0" fill="hold" nodeType="afterEffect">
+                                  <p:stCondLst>
+                                    <p:cond delay="0"/>
+                                  </p:stCondLst>
+                                  <p:childTnLst>
+                                    <p:set>
+                                      <p:cBhvr>
+                                        <p:cTn id="24" dur="1" fill="hold">
+                                          <p:stCondLst>
+                                            <p:cond delay="0"/>
+                                          </p:stCondLst>
+                                        </p:cTn>
+                                        <p:tgtEl>
+                                          <p:spTgt spid="3">
+                                            <p:txEl>
+                                              <p:pRg st="3" end="3"/>
+                                            </p:txEl>
+                                          </p:spTgt>
+                                        </p:tgtEl>
+                                        <p:attrNameLst>
+                                          <p:attrName>style.visibility</p:attrName>
+                                        </p:attrNameLst>
+                                      </p:cBhvr>
+                                      <p:to>
+                                        <p:strVal val="visible"/>
+                                      </p:to>
+                                    </p:set>
+                                    <p:animEffect transition="in" filter="fade">
+                                      <p:cBhvr>
+                                        <p:cTn id="25" dur="500"/>
+                                        <p:tgtEl>
+                                          <p:spTgt spid="3">
+                                            <p:txEl>
+                                              <p:pRg st="3" end="3"/>
+                                            </p:txEl>
+                                          </p:spTgt>
+                                        </p:tgtEl>
+                                      </p:cBhvr>
+                                    </p:animEffect>
+                                  </p:childTnLst>
+                                </p:cTn>
+                              </p:par>
+                            </p:childTnLst>
+                          </p:cTn>
+                        </p:par>
+                        <p:par>
+                          <p:cTn id="26" fill="hold">
+                            <p:stCondLst>
+                              <p:cond delay="3000"/>
+                            </p:stCondLst>
+                            <p:childTnLst>
+                              <p:par>
+                                <p:cTn id="27" presetID="10" presetClass="entr" presetSubtype="0" fill="hold" nodeType="afterEffect">
+                                  <p:stCondLst>
+                                    <p:cond delay="0"/>
+                                  </p:stCondLst>
+                                  <p:childTnLst>
+                                    <p:set>
+                                      <p:cBhvr>
+                                        <p:cTn id="28" dur="1" fill="hold">
+                                          <p:stCondLst>
+                                            <p:cond delay="0"/>
+                                          </p:stCondLst>
+                                        </p:cTn>
+                                        <p:tgtEl>
+                                          <p:spTgt spid="3">
+                                            <p:txEl>
+                                              <p:pRg st="4" end="4"/>
+                                            </p:txEl>
+                                          </p:spTgt>
+                                        </p:tgtEl>
+                                        <p:attrNameLst>
+                                          <p:attrName>style.visibility</p:attrName>
+                                        </p:attrNameLst>
+                                      </p:cBhvr>
+                                      <p:to>
+                                        <p:strVal val="visible"/>
+                                      </p:to>
+                                    </p:set>
+                                    <p:animEffect transition="in" filter="fade">
+                                      <p:cBhvr>
+                                        <p:cTn id="29" dur="500"/>
+                                        <p:tgtEl>
+                                          <p:spTgt spid="3">
+                                            <p:txEl>
+                                              <p:pRg st="4" end="4"/>
+                                            </p:txEl>
+                                          </p:spTgt>
+                                        </p:tgtEl>
+                                      </p:cBhvr>
+                                    </p:animEffect>
+                                  </p:childTnLst>
+                                </p:cTn>
+                              </p:par>
+                            </p:childTnLst>
+                          </p:cTn>
+                        </p:par>
+                      </p:childTnLst>
+                    </p:cTn>
+                  </p:par>
+                </p:childTnLst>
+              </p:cTn>
+              <p:prevCondLst>
+                <p:cond evt="onPrev" delay="0">
+                  <p:tgtEl>
+                    <p:sldTgt/>
+                  </p:tgtEl>
+                </p:cond>
+              </p:prevCondLst>
+              <p:nextCondLst>
+                <p:cond evt="onNext" delay="0">
+                  <p:tgtEl>
+                    <p:sldTgt/>
+                  </p:tgtEl>
+                </p:cond>
+              </p:nextCondLst>
+            </p:seq>
+          </p:childTnLst>
+        </p:cTn>
+      </p:par>
+    </p:tnLst>
+    <p:bldLst>
+      <p:bldP spid="2" grpId="0"/>
+    </p:bldLst>
+  </p:timing>
+</p:sld>
+</file>
+
+<file path=ppt/slides/slide7.xml><?xml version="1.0" encoding="utf-8"?>
+<p:sld xmlns:a="http://schemas.openxmlformats.org/drawingml/2006/main" xmlns:r="http://schemas.openxmlformats.org/officeDocument/2006/relationships" xmlns:p="http://schemas.openxmlformats.org/presentationml/2006/main">
+  <p:cSld>
+    <p:spTree>
+      <p:nvGrpSpPr>
+        <p:cNvPr id="1" name=""/>
+        <p:cNvGrpSpPr/>
+        <p:nvPr/>
+      </p:nvGrpSpPr>
+      <p:grpSpPr>
+        <a:xfrm>
+          <a:off x="0" y="0"/>
+          <a:ext cx="0" cy="0"/>
+          <a:chOff x="0" y="0"/>
+          <a:chExt cx="0" cy="0"/>
+        </a:xfrm>
+      </p:grpSpPr>
+      <p:sp>
+        <p:nvSpPr>
+          <p:cNvPr id="2" name="Заголовок 1">
+            <a:extLst>
+              <a:ext uri="{FF2B5EF4-FFF2-40B4-BE49-F238E27FC236}">
+                <a16:creationId xmlns:a16="http://schemas.microsoft.com/office/drawing/2014/main" id="{F209A495-8E3F-4CFE-86E0-75920089882B}"/>
+              </a:ext>
+            </a:extLst>
+          </p:cNvPr>
+          <p:cNvSpPr>
+            <a:spLocks noGrp="1"/>
+          </p:cNvSpPr>
+          <p:nvPr>
+            <p:ph type="title"/>
+          </p:nvPr>
+        </p:nvSpPr>
+        <p:spPr/>
+        <p:txBody>
+          <a:bodyPr>
+            <a:normAutofit/>
+          </a:bodyPr>
+          <a:lstStyle/>
+          <a:p>
+            <a:pPr algn="ctr"/>
+            <a:r>
+              <a:rPr lang="ru-RU" sz="4000" dirty="0" smtClean="0">
+                <a:solidFill>
+                  <a:srgbClr val="36A9E1"/>
+                </a:solidFill>
+                <a:latin typeface="Segoe UI Black" panose="020B0A02040204020203" pitchFamily="34" charset="0"/>
+                <a:ea typeface="Segoe UI Black" panose="020B0A02040204020203" pitchFamily="34" charset="0"/>
+              </a:rPr>
+              <a:t>Скриншоты</a:t>
+            </a:r>
+            <a:endParaRPr lang="ru-RU" sz="4000" dirty="0">
+              <a:solidFill>
+                <a:srgbClr val="36A9E1"/>
+              </a:solidFill>
+              <a:latin typeface="Segoe UI Black" panose="020B0A02040204020203" pitchFamily="34" charset="0"/>
+              <a:ea typeface="Segoe UI Black" panose="020B0A02040204020203" pitchFamily="34" charset="0"/>
+            </a:endParaRPr>
+          </a:p>
+        </p:txBody>
+      </p:sp>
+      <p:pic>
+        <p:nvPicPr>
+          <p:cNvPr id="4" name="Рисунок 3"/>
+          <p:cNvPicPr>
+            <a:picLocks noChangeAspect="1"/>
+          </p:cNvPicPr>
+          <p:nvPr/>
+        </p:nvPicPr>
+        <p:blipFill>
+          <a:blip r:embed="rId2">
+            <a:extLst>
+              <a:ext uri="{28A0092B-C50C-407E-A947-70E740481C1C}">
+                <a14:useLocalDpi xmlns:a14="http://schemas.microsoft.com/office/drawing/2010/main" val="0"/>
+              </a:ext>
+            </a:extLst>
+          </a:blip>
+          <a:stretch>
+            <a:fillRect/>
+          </a:stretch>
+        </p:blipFill>
+        <p:spPr>
+          <a:xfrm>
+            <a:off x="340798" y="1521461"/>
+            <a:ext cx="5929769" cy="2864804"/>
+          </a:xfrm>
+          <a:prstGeom prst="rect">
+            <a:avLst/>
+          </a:prstGeom>
+          <a:ln>
+            <a:noFill/>
+          </a:ln>
+          <a:effectLst>
+            <a:outerShdw blurRad="292100" dist="139700" dir="2700000" algn="tl" rotWithShape="0">
+              <a:srgbClr val="333333">
+                <a:alpha val="65000"/>
+              </a:srgbClr>
+            </a:outerShdw>
+          </a:effectLst>
+        </p:spPr>
+      </p:pic>
+      <p:pic>
+        <p:nvPicPr>
+          <p:cNvPr id="5" name="Рисунок 4"/>
+          <p:cNvPicPr>
+            <a:picLocks noChangeAspect="1"/>
+          </p:cNvPicPr>
+          <p:nvPr/>
+        </p:nvPicPr>
+        <p:blipFill>
+          <a:blip r:embed="rId3">
+            <a:extLst>
+              <a:ext uri="{28A0092B-C50C-407E-A947-70E740481C1C}">
+                <a14:useLocalDpi xmlns:a14="http://schemas.microsoft.com/office/drawing/2010/main" val="0"/>
+              </a:ext>
+            </a:extLst>
+          </a:blip>
+          <a:stretch>
+            <a:fillRect/>
+          </a:stretch>
+        </p:blipFill>
+        <p:spPr>
+          <a:xfrm>
+            <a:off x="5471953" y="3233424"/>
+            <a:ext cx="6006538" cy="2864804"/>
+          </a:xfrm>
+          <a:prstGeom prst="rect">
+            <a:avLst/>
+          </a:prstGeom>
+          <a:ln>
+            <a:noFill/>
+          </a:ln>
+          <a:effectLst>
+            <a:outerShdw blurRad="292100" dist="139700" dir="2700000" algn="tl" rotWithShape="0">
+              <a:srgbClr val="333333">
+                <a:alpha val="65000"/>
+              </a:srgbClr>
+            </a:outerShdw>
+          </a:effectLst>
+        </p:spPr>
+      </p:pic>
+    </p:spTree>
+    <p:extLst>
+      <p:ext uri="{BB962C8B-B14F-4D97-AF65-F5344CB8AC3E}">
+        <p14:creationId xmlns:p14="http://schemas.microsoft.com/office/powerpoint/2010/main" val="3967417998"/>
+      </p:ext>
+    </p:extLst>
+  </p:cSld>
+  <p:clrMapOvr>
+    <a:masterClrMapping/>
+  </p:clrMapOvr>
+  <p:timing>
+    <p:tnLst>
+      <p:par>
+        <p:cTn id="1" dur="indefinite" restart="never" nodeType="tmRoot">
+          <p:childTnLst>
+            <p:seq concurrent="1" nextAc="seek">
+              <p:cTn id="2" dur="indefinite" nodeType="mainSeq">
+                <p:childTnLst>
+                  <p:par>
+                    <p:cTn id="3" fill="hold">
+                      <p:stCondLst>
+                        <p:cond delay="indefinite"/>
+                        <p:cond evt="onBegin" delay="0">
+                          <p:tn val="2"/>
+                        </p:cond>
+                      </p:stCondLst>
+                      <p:childTnLst>
+                        <p:par>
+                          <p:cTn id="4" fill="hold">
+                            <p:stCondLst>
+                              <p:cond delay="0"/>
+                            </p:stCondLst>
+                            <p:childTnLst>
+                              <p:par>
+                                <p:cTn id="5" presetID="47" presetClass="entr" presetSubtype="0" fill="hold" grpId="0" nodeType="afterEffect">
+                                  <p:stCondLst>
+                                    <p:cond delay="0"/>
+                                  </p:stCondLst>
+                                  <p:childTnLst>
+                                    <p:set>
+                                      <p:cBhvr>
+                                        <p:cTn id="6" dur="1" fill="hold">
+                                          <p:stCondLst>
+                                            <p:cond delay="0"/>
+                                          </p:stCondLst>
+                                        </p:cTn>
+                                        <p:tgtEl>
+                                          <p:spTgt spid="2"/>
+                                        </p:tgtEl>
+                                        <p:attrNameLst>
+                                          <p:attrName>style.visibility</p:attrName>
+                                        </p:attrNameLst>
+                                      </p:cBhvr>
+                                      <p:to>
+                                        <p:strVal val="visible"/>
+                                      </p:to>
+                                    </p:set>
+                                    <p:animEffect transition="in" filter="fade">
+                                      <p:cBhvr>
+                                        <p:cTn id="7" dur="1000"/>
+                                        <p:tgtEl>
+                                          <p:spTgt spid="2"/>
+                                        </p:tgtEl>
+                                      </p:cBhvr>
+                                    </p:animEffect>
+                                    <p:anim calcmode="lin" valueType="num">
+                                      <p:cBhvr>
+                                        <p:cTn id="8" dur="1000" fill="hold"/>
+                                        <p:tgtEl>
+                                          <p:spTgt spid="2"/>
+                                        </p:tgtEl>
+                                        <p:attrNameLst>
+                                          <p:attrName>ppt_x</p:attrName>
+                                        </p:attrNameLst>
+                                      </p:cBhvr>
+                                      <p:tavLst>
+                                        <p:tav tm="0">
+                                          <p:val>
+                                            <p:strVal val="#ppt_x"/>
+                                          </p:val>
+                                        </p:tav>
+                                        <p:tav tm="100000">
+                                          <p:val>
+                                            <p:strVal val="#ppt_x"/>
+                                          </p:val>
+                                        </p:tav>
+                                      </p:tavLst>
+                                    </p:anim>
+                                    <p:anim calcmode="lin" valueType="num">
+                                      <p:cBhvr>
+                                        <p:cTn id="9" dur="1000" fill="hold"/>
+                                        <p:tgtEl>
+                                          <p:spTgt spid="2"/>
+                                        </p:tgtEl>
+                                        <p:attrNameLst>
+                                          <p:attrName>ppt_y</p:attrName>
+                                        </p:attrNameLst>
+                                      </p:cBhvr>
+                                      <p:tavLst>
+                                        <p:tav tm="0">
+                                          <p:val>
+                                            <p:strVal val="#ppt_y-.1"/>
+                                          </p:val>
+                                        </p:tav>
+                                        <p:tav tm="100000">
+                                          <p:val>
+                                            <p:strVal val="#ppt_y"/>
+                                          </p:val>
+                                        </p:tav>
+                                      </p:tavLst>
+                                    </p:anim>
+                                  </p:childTnLst>
+                                </p:cTn>
+                              </p:par>
+                            </p:childTnLst>
+                          </p:cTn>
+                        </p:par>
+                        <p:par>
+                          <p:cTn id="10" fill="hold">
+                            <p:stCondLst>
+                              <p:cond delay="1000"/>
+                            </p:stCondLst>
+                            <p:childTnLst>
+                              <p:par>
+                                <p:cTn id="11" presetID="53" presetClass="entr" presetSubtype="16" fill="hold" nodeType="afterEffect">
+                                  <p:stCondLst>
+                                    <p:cond delay="0"/>
+                                  </p:stCondLst>
+                                  <p:childTnLst>
+                                    <p:set>
+                                      <p:cBhvr>
+                                        <p:cTn id="12" dur="1" fill="hold">
+                                          <p:stCondLst>
+                                            <p:cond delay="0"/>
+                                          </p:stCondLst>
+                                        </p:cTn>
+                                        <p:tgtEl>
+                                          <p:spTgt spid="4"/>
+                                        </p:tgtEl>
+                                        <p:attrNameLst>
+                                          <p:attrName>style.visibility</p:attrName>
+                                        </p:attrNameLst>
+                                      </p:cBhvr>
+                                      <p:to>
+                                        <p:strVal val="visible"/>
+                                      </p:to>
+                                    </p:set>
+                                    <p:anim calcmode="lin" valueType="num">
+                                      <p:cBhvr>
+                                        <p:cTn id="13" dur="500" fill="hold"/>
+                                        <p:tgtEl>
+                                          <p:spTgt spid="4"/>
+                                        </p:tgtEl>
+                                        <p:attrNameLst>
+                                          <p:attrName>ppt_w</p:attrName>
+                                        </p:attrNameLst>
+                                      </p:cBhvr>
+                                      <p:tavLst>
+                                        <p:tav tm="0">
+                                          <p:val>
+                                            <p:fltVal val="0"/>
+                                          </p:val>
+                                        </p:tav>
+                                        <p:tav tm="100000">
+                                          <p:val>
+                                            <p:strVal val="#ppt_w"/>
+                                          </p:val>
+                                        </p:tav>
+                                      </p:tavLst>
+                                    </p:anim>
+                                    <p:anim calcmode="lin" valueType="num">
+                                      <p:cBhvr>
+                                        <p:cTn id="14" dur="500" fill="hold"/>
+                                        <p:tgtEl>
+                                          <p:spTgt spid="4"/>
+                                        </p:tgtEl>
+                                        <p:attrNameLst>
+                                          <p:attrName>ppt_h</p:attrName>
+                                        </p:attrNameLst>
+                                      </p:cBhvr>
+                                      <p:tavLst>
+                                        <p:tav tm="0">
+                                          <p:val>
+                                            <p:fltVal val="0"/>
+                                          </p:val>
+                                        </p:tav>
+                                        <p:tav tm="100000">
+                                          <p:val>
+                                            <p:strVal val="#ppt_h"/>
+                                          </p:val>
+                                        </p:tav>
+                                      </p:tavLst>
+                                    </p:anim>
+                                    <p:animEffect transition="in" filter="fade">
+                                      <p:cBhvr>
+                                        <p:cTn id="15" dur="500"/>
+                                        <p:tgtEl>
+                                          <p:spTgt spid="4"/>
+                                        </p:tgtEl>
+                                      </p:cBhvr>
+                                    </p:animEffect>
+                                  </p:childTnLst>
+                                </p:cTn>
+                              </p:par>
+                            </p:childTnLst>
+                          </p:cTn>
+                        </p:par>
+                        <p:par>
+                          <p:cTn id="16" fill="hold">
+                            <p:stCondLst>
+                              <p:cond delay="1500"/>
+                            </p:stCondLst>
+                            <p:childTnLst>
+                              <p:par>
+                                <p:cTn id="17" presetID="53" presetClass="entr" presetSubtype="16" fill="hold" nodeType="afterEffect">
+                                  <p:stCondLst>
+                                    <p:cond delay="0"/>
+                                  </p:stCondLst>
+                                  <p:childTnLst>
+                                    <p:set>
+                                      <p:cBhvr>
+                                        <p:cTn id="18" dur="1" fill="hold">
+                                          <p:stCondLst>
+                                            <p:cond delay="0"/>
+                                          </p:stCondLst>
+                                        </p:cTn>
+                                        <p:tgtEl>
+                                          <p:spTgt spid="5"/>
+                                        </p:tgtEl>
+                                        <p:attrNameLst>
+                                          <p:attrName>style.visibility</p:attrName>
+                                        </p:attrNameLst>
+                                      </p:cBhvr>
+                                      <p:to>
+                                        <p:strVal val="visible"/>
+                                      </p:to>
+                                    </p:set>
+                                    <p:anim calcmode="lin" valueType="num">
+                                      <p:cBhvr>
+                                        <p:cTn id="19" dur="500" fill="hold"/>
+                                        <p:tgtEl>
+                                          <p:spTgt spid="5"/>
+                                        </p:tgtEl>
+                                        <p:attrNameLst>
+                                          <p:attrName>ppt_w</p:attrName>
+                                        </p:attrNameLst>
+                                      </p:cBhvr>
+                                      <p:tavLst>
+                                        <p:tav tm="0">
+                                          <p:val>
+                                            <p:fltVal val="0"/>
+                                          </p:val>
+                                        </p:tav>
+                                        <p:tav tm="100000">
+                                          <p:val>
+                                            <p:strVal val="#ppt_w"/>
+                                          </p:val>
+                                        </p:tav>
+                                      </p:tavLst>
+                                    </p:anim>
+                                    <p:anim calcmode="lin" valueType="num">
+                                      <p:cBhvr>
+                                        <p:cTn id="20" dur="500" fill="hold"/>
+                                        <p:tgtEl>
+                                          <p:spTgt spid="5"/>
+                                        </p:tgtEl>
+                                        <p:attrNameLst>
+                                          <p:attrName>ppt_h</p:attrName>
+                                        </p:attrNameLst>
+                                      </p:cBhvr>
+                                      <p:tavLst>
+                                        <p:tav tm="0">
+                                          <p:val>
+                                            <p:fltVal val="0"/>
+                                          </p:val>
+                                        </p:tav>
+                                        <p:tav tm="100000">
+                                          <p:val>
+                                            <p:strVal val="#ppt_h"/>
+                                          </p:val>
+                                        </p:tav>
+                                      </p:tavLst>
+                                    </p:anim>
+                                    <p:animEffect transition="in" filter="fade">
+                                      <p:cBhvr>
+                                        <p:cTn id="21" dur="500"/>
+                                        <p:tgtEl>
+                                          <p:spTgt spid="5"/>
+                                        </p:tgtEl>
+                                      </p:cBhvr>
+                                    </p:animEffect>
+                                  </p:childTnLst>
+                                </p:cTn>
+                              </p:par>
+                            </p:childTnLst>
+                          </p:cTn>
+                        </p:par>
+                      </p:childTnLst>
+                    </p:cTn>
+                  </p:par>
+                </p:childTnLst>
+              </p:cTn>
+              <p:prevCondLst>
+                <p:cond evt="onPrev" delay="0">
+                  <p:tgtEl>
+                    <p:sldTgt/>
+                  </p:tgtEl>
+                </p:cond>
+              </p:prevCondLst>
+              <p:nextCondLst>
+                <p:cond evt="onNext" delay="0">
+                  <p:tgtEl>
+                    <p:sldTgt/>
+                  </p:tgtEl>
+                </p:cond>
+              </p:nextCondLst>
+            </p:seq>
+          </p:childTnLst>
+        </p:cTn>
+      </p:par>
+    </p:tnLst>
+    <p:bldLst>
+      <p:bldP spid="2" grpId="0"/>
+    </p:bldLst>
+  </p:timing>
+</p:sld>
+</file>
+
+<file path=ppt/slides/slide8.xml><?xml version="1.0" encoding="utf-8"?>
+<p:sld xmlns:a="http://schemas.openxmlformats.org/drawingml/2006/main" xmlns:r="http://schemas.openxmlformats.org/officeDocument/2006/relationships" xmlns:p="http://schemas.openxmlformats.org/presentationml/2006/main">
+  <p:cSld>
+    <p:spTree>
+      <p:nvGrpSpPr>
+        <p:cNvPr id="1" name=""/>
+        <p:cNvGrpSpPr/>
+        <p:nvPr/>
+      </p:nvGrpSpPr>
+      <p:grpSpPr>
+        <a:xfrm>
+          <a:off x="0" y="0"/>
+          <a:ext cx="0" cy="0"/>
+          <a:chOff x="0" y="0"/>
+          <a:chExt cx="0" cy="0"/>
+        </a:xfrm>
+      </p:grpSpPr>
+      <p:sp>
+        <p:nvSpPr>
+          <p:cNvPr id="2" name="Заголовок 1">
+            <a:extLst>
+              <a:ext uri="{FF2B5EF4-FFF2-40B4-BE49-F238E27FC236}">
+                <a16:creationId xmlns:a16="http://schemas.microsoft.com/office/drawing/2014/main" id="{F209A495-8E3F-4CFE-86E0-75920089882B}"/>
+              </a:ext>
+            </a:extLst>
+          </p:cNvPr>
+          <p:cNvSpPr>
+            <a:spLocks noGrp="1"/>
+          </p:cNvSpPr>
+          <p:nvPr>
+            <p:ph type="title"/>
+          </p:nvPr>
+        </p:nvSpPr>
+        <p:spPr/>
+        <p:txBody>
+          <a:bodyPr>
+            <a:normAutofit/>
+          </a:bodyPr>
+          <a:lstStyle/>
+          <a:p>
+            <a:pPr algn="ctr"/>
+            <a:r>
+              <a:rPr lang="ru-RU" sz="4000" dirty="0" smtClean="0">
+                <a:solidFill>
+                  <a:srgbClr val="36A9E1"/>
+                </a:solidFill>
+                <a:latin typeface="Segoe UI Black" panose="020B0A02040204020203" pitchFamily="34" charset="0"/>
+                <a:ea typeface="Segoe UI Black" panose="020B0A02040204020203" pitchFamily="34" charset="0"/>
+              </a:rPr>
+              <a:t>Скриншоты</a:t>
+            </a:r>
+            <a:endParaRPr lang="ru-RU" sz="4000" dirty="0">
+              <a:solidFill>
+                <a:srgbClr val="36A9E1"/>
+              </a:solidFill>
+              <a:latin typeface="Segoe UI Black" panose="020B0A02040204020203" pitchFamily="34" charset="0"/>
+              <a:ea typeface="Segoe UI Black" panose="020B0A02040204020203" pitchFamily="34" charset="0"/>
+            </a:endParaRPr>
+          </a:p>
+        </p:txBody>
+      </p:sp>
+      <p:pic>
+        <p:nvPicPr>
+          <p:cNvPr id="4" name="Рисунок 3"/>
+          <p:cNvPicPr>
+            <a:picLocks noChangeAspect="1"/>
+          </p:cNvPicPr>
+          <p:nvPr/>
+        </p:nvPicPr>
+        <p:blipFill>
+          <a:blip r:embed="rId2" cstate="print">
+            <a:extLst>
+              <a:ext uri="{28A0092B-C50C-407E-A947-70E740481C1C}">
+                <a14:useLocalDpi xmlns:a14="http://schemas.microsoft.com/office/drawing/2010/main" val="0"/>
+              </a:ext>
+            </a:extLst>
+          </a:blip>
+          <a:stretch>
+            <a:fillRect/>
+          </a:stretch>
+        </p:blipFill>
+        <p:spPr>
+          <a:xfrm>
+            <a:off x="355785" y="1521461"/>
+            <a:ext cx="5899794" cy="2864804"/>
+          </a:xfrm>
+          <a:prstGeom prst="rect">
+            <a:avLst/>
+          </a:prstGeom>
+          <a:ln>
+            <a:noFill/>
+          </a:ln>
+          <a:effectLst>
+            <a:outerShdw blurRad="292100" dist="139700" dir="2700000" algn="tl" rotWithShape="0">
+              <a:srgbClr val="333333">
+                <a:alpha val="65000"/>
+              </a:srgbClr>
+            </a:outerShdw>
+          </a:effectLst>
+        </p:spPr>
+      </p:pic>
+      <p:pic>
+        <p:nvPicPr>
+          <p:cNvPr id="5" name="Рисунок 4"/>
+          <p:cNvPicPr>
+            <a:picLocks noChangeAspect="1"/>
+          </p:cNvPicPr>
+          <p:nvPr/>
+        </p:nvPicPr>
+        <p:blipFill>
+          <a:blip r:embed="rId3" cstate="print">
+            <a:extLst>
+              <a:ext uri="{28A0092B-C50C-407E-A947-70E740481C1C}">
+                <a14:useLocalDpi xmlns:a14="http://schemas.microsoft.com/office/drawing/2010/main" val="0"/>
+              </a:ext>
+            </a:extLst>
+          </a:blip>
+          <a:stretch>
+            <a:fillRect/>
+          </a:stretch>
+        </p:blipFill>
+        <p:spPr>
+          <a:xfrm>
+            <a:off x="5471953" y="3274736"/>
+            <a:ext cx="6006538" cy="2782179"/>
+          </a:xfrm>
+          <a:prstGeom prst="rect">
+            <a:avLst/>
+          </a:prstGeom>
+          <a:ln>
+            <a:noFill/>
+          </a:ln>
+          <a:effectLst>
+            <a:outerShdw blurRad="292100" dist="139700" dir="2700000" algn="tl" rotWithShape="0">
+              <a:srgbClr val="333333">
+                <a:alpha val="65000"/>
+              </a:srgbClr>
+            </a:outerShdw>
+          </a:effectLst>
+        </p:spPr>
+      </p:pic>
+    </p:spTree>
+    <p:extLst>
+      <p:ext uri="{BB962C8B-B14F-4D97-AF65-F5344CB8AC3E}">
+        <p14:creationId xmlns:p14="http://schemas.microsoft.com/office/powerpoint/2010/main" val="3225230124"/>
+      </p:ext>
+    </p:extLst>
+  </p:cSld>
+  <p:clrMapOvr>
+    <a:masterClrMapping/>
+  </p:clrMapOvr>
+  <p:timing>
+    <p:tnLst>
+      <p:par>
+        <p:cTn id="1" dur="indefinite" restart="never" nodeType="tmRoot">
+          <p:childTnLst>
+            <p:seq concurrent="1" nextAc="seek">
+              <p:cTn id="2" dur="indefinite" nodeType="mainSeq">
+                <p:childTnLst>
+                  <p:par>
+                    <p:cTn id="3" fill="hold">
+                      <p:stCondLst>
+                        <p:cond delay="indefinite"/>
+                        <p:cond evt="onBegin" delay="0">
+                          <p:tn val="2"/>
+                        </p:cond>
+                      </p:stCondLst>
+                      <p:childTnLst>
+                        <p:par>
+                          <p:cTn id="4" fill="hold">
+                            <p:stCondLst>
+                              <p:cond delay="0"/>
+                            </p:stCondLst>
+                            <p:childTnLst>
+                              <p:par>
+                                <p:cTn id="5" presetID="47" presetClass="entr" presetSubtype="0" fill="hold" grpId="0" nodeType="afterEffect">
+                                  <p:stCondLst>
+                                    <p:cond delay="0"/>
+                                  </p:stCondLst>
+                                  <p:childTnLst>
+                                    <p:set>
+                                      <p:cBhvr>
+                                        <p:cTn id="6" dur="1" fill="hold">
+                                          <p:stCondLst>
+                                            <p:cond delay="0"/>
+                                          </p:stCondLst>
+                                        </p:cTn>
+                                        <p:tgtEl>
+                                          <p:spTgt spid="2"/>
+                                        </p:tgtEl>
+                                        <p:attrNameLst>
+                                          <p:attrName>style.visibility</p:attrName>
+                                        </p:attrNameLst>
+                                      </p:cBhvr>
+                                      <p:to>
+                                        <p:strVal val="visible"/>
+                                      </p:to>
+                                    </p:set>
+                                    <p:animEffect transition="in" filter="fade">
+                                      <p:cBhvr>
+                                        <p:cTn id="7" dur="1000"/>
+                                        <p:tgtEl>
+                                          <p:spTgt spid="2"/>
+                                        </p:tgtEl>
+                                      </p:cBhvr>
+                                    </p:animEffect>
+                                    <p:anim calcmode="lin" valueType="num">
+                                      <p:cBhvr>
+                                        <p:cTn id="8" dur="1000" fill="hold"/>
+                                        <p:tgtEl>
+                                          <p:spTgt spid="2"/>
+                                        </p:tgtEl>
+                                        <p:attrNameLst>
+                                          <p:attrName>ppt_x</p:attrName>
+                                        </p:attrNameLst>
+                                      </p:cBhvr>
+                                      <p:tavLst>
+                                        <p:tav tm="0">
+                                          <p:val>
+                                            <p:strVal val="#ppt_x"/>
+                                          </p:val>
+                                        </p:tav>
+                                        <p:tav tm="100000">
+                                          <p:val>
+                                            <p:strVal val="#ppt_x"/>
+                                          </p:val>
+                                        </p:tav>
+                                      </p:tavLst>
+                                    </p:anim>
+                                    <p:anim calcmode="lin" valueType="num">
+                                      <p:cBhvr>
+                                        <p:cTn id="9" dur="1000" fill="hold"/>
+                                        <p:tgtEl>
+                                          <p:spTgt spid="2"/>
+                                        </p:tgtEl>
+                                        <p:attrNameLst>
+                                          <p:attrName>ppt_y</p:attrName>
+                                        </p:attrNameLst>
+                                      </p:cBhvr>
+                                      <p:tavLst>
+                                        <p:tav tm="0">
+                                          <p:val>
+                                            <p:strVal val="#ppt_y-.1"/>
+                                          </p:val>
+                                        </p:tav>
+                                        <p:tav tm="100000">
+                                          <p:val>
+                                            <p:strVal val="#ppt_y"/>
+                                          </p:val>
+                                        </p:tav>
+                                      </p:tavLst>
+                                    </p:anim>
+                                  </p:childTnLst>
+                                </p:cTn>
+                              </p:par>
+                            </p:childTnLst>
+                          </p:cTn>
+                        </p:par>
+                        <p:par>
+                          <p:cTn id="10" fill="hold">
+                            <p:stCondLst>
+                              <p:cond delay="1000"/>
+                            </p:stCondLst>
+                            <p:childTnLst>
+                              <p:par>
+                                <p:cTn id="11" presetID="53" presetClass="entr" presetSubtype="16" fill="hold" nodeType="afterEffect">
+                                  <p:stCondLst>
+                                    <p:cond delay="0"/>
+                                  </p:stCondLst>
+                                  <p:childTnLst>
+                                    <p:set>
+                                      <p:cBhvr>
+                                        <p:cTn id="12" dur="1" fill="hold">
+                                          <p:stCondLst>
+                                            <p:cond delay="0"/>
+                                          </p:stCondLst>
+                                        </p:cTn>
+                                        <p:tgtEl>
+                                          <p:spTgt spid="4"/>
+                                        </p:tgtEl>
+                                        <p:attrNameLst>
+                                          <p:attrName>style.visibility</p:attrName>
+                                        </p:attrNameLst>
+                                      </p:cBhvr>
+                                      <p:to>
+                                        <p:strVal val="visible"/>
+                                      </p:to>
+                                    </p:set>
+                                    <p:anim calcmode="lin" valueType="num">
+                                      <p:cBhvr>
+                                        <p:cTn id="13" dur="500" fill="hold"/>
+                                        <p:tgtEl>
+                                          <p:spTgt spid="4"/>
+                                        </p:tgtEl>
+                                        <p:attrNameLst>
+                                          <p:attrName>ppt_w</p:attrName>
+                                        </p:attrNameLst>
+                                      </p:cBhvr>
+                                      <p:tavLst>
+                                        <p:tav tm="0">
+                                          <p:val>
+                                            <p:fltVal val="0"/>
+                                          </p:val>
+                                        </p:tav>
+                                        <p:tav tm="100000">
+                                          <p:val>
+                                            <p:strVal val="#ppt_w"/>
+                                          </p:val>
+                                        </p:tav>
+                                      </p:tavLst>
+                                    </p:anim>
+                                    <p:anim calcmode="lin" valueType="num">
+                                      <p:cBhvr>
+                                        <p:cTn id="14" dur="500" fill="hold"/>
+                                        <p:tgtEl>
+                                          <p:spTgt spid="4"/>
+                                        </p:tgtEl>
+                                        <p:attrNameLst>
+                                          <p:attrName>ppt_h</p:attrName>
+                                        </p:attrNameLst>
+                                      </p:cBhvr>
+                                      <p:tavLst>
+                                        <p:tav tm="0">
+                                          <p:val>
+                                            <p:fltVal val="0"/>
+                                          </p:val>
+                                        </p:tav>
+                                        <p:tav tm="100000">
+                                          <p:val>
+                                            <p:strVal val="#ppt_h"/>
+                                          </p:val>
+                                        </p:tav>
+                                      </p:tavLst>
+                                    </p:anim>
+                                    <p:animEffect transition="in" filter="fade">
+                                      <p:cBhvr>
+                                        <p:cTn id="15" dur="500"/>
+                                        <p:tgtEl>
+                                          <p:spTgt spid="4"/>
+                                        </p:tgtEl>
+                                      </p:cBhvr>
+                                    </p:animEffect>
+                                  </p:childTnLst>
+                                </p:cTn>
+                              </p:par>
+                            </p:childTnLst>
+                          </p:cTn>
+                        </p:par>
+                        <p:par>
+                          <p:cTn id="16" fill="hold">
+                            <p:stCondLst>
+                              <p:cond delay="1500"/>
+                            </p:stCondLst>
+                            <p:childTnLst>
+                              <p:par>
+                                <p:cTn id="17" presetID="53" presetClass="entr" presetSubtype="16" fill="hold" nodeType="afterEffect">
+                                  <p:stCondLst>
+                                    <p:cond delay="0"/>
+                                  </p:stCondLst>
+                                  <p:childTnLst>
+                                    <p:set>
+                                      <p:cBhvr>
+                                        <p:cTn id="18" dur="1" fill="hold">
+                                          <p:stCondLst>
+                                            <p:cond delay="0"/>
+                                          </p:stCondLst>
+                                        </p:cTn>
+                                        <p:tgtEl>
+                                          <p:spTgt spid="5"/>
+                                        </p:tgtEl>
+                                        <p:attrNameLst>
+                                          <p:attrName>style.visibility</p:attrName>
+                                        </p:attrNameLst>
+                                      </p:cBhvr>
+                                      <p:to>
+                                        <p:strVal val="visible"/>
+                                      </p:to>
+                                    </p:set>
+                                    <p:anim calcmode="lin" valueType="num">
+                                      <p:cBhvr>
+                                        <p:cTn id="19" dur="500" fill="hold"/>
+                                        <p:tgtEl>
+                                          <p:spTgt spid="5"/>
+                                        </p:tgtEl>
+                                        <p:attrNameLst>
+                                          <p:attrName>ppt_w</p:attrName>
+                                        </p:attrNameLst>
+                                      </p:cBhvr>
+                                      <p:tavLst>
+                                        <p:tav tm="0">
+                                          <p:val>
+                                            <p:fltVal val="0"/>
+                                          </p:val>
+                                        </p:tav>
+                                        <p:tav tm="100000">
+                                          <p:val>
+                                            <p:strVal val="#ppt_w"/>
+                                          </p:val>
+                                        </p:tav>
+                                      </p:tavLst>
+                                    </p:anim>
+                                    <p:anim calcmode="lin" valueType="num">
+                                      <p:cBhvr>
+                                        <p:cTn id="20" dur="500" fill="hold"/>
+                                        <p:tgtEl>
+                                          <p:spTgt spid="5"/>
+                                        </p:tgtEl>
+                                        <p:attrNameLst>
+                                          <p:attrName>ppt_h</p:attrName>
+                                        </p:attrNameLst>
+                                      </p:cBhvr>
+                                      <p:tavLst>
+                                        <p:tav tm="0">
+                                          <p:val>
+                                            <p:fltVal val="0"/>
+                                          </p:val>
+                                        </p:tav>
+                                        <p:tav tm="100000">
+                                          <p:val>
+                                            <p:strVal val="#ppt_h"/>
+                                          </p:val>
+                                        </p:tav>
+                                      </p:tavLst>
+                                    </p:anim>
+                                    <p:animEffect transition="in" filter="fade">
+                                      <p:cBhvr>
+                                        <p:cTn id="21" dur="500"/>
+                                        <p:tgtEl>
+                                          <p:spTgt spid="5"/>
+                                        </p:tgtEl>
+                                      </p:cBhvr>
+                                    </p:animEffect>
+                                  </p:childTnLst>
+                                </p:cTn>
+                              </p:par>
+                            </p:childTnLst>
+                          </p:cTn>
+                        </p:par>
+                      </p:childTnLst>
+                    </p:cTn>
+                  </p:par>
+                </p:childTnLst>
+              </p:cTn>
+              <p:prevCondLst>
+                <p:cond evt="onPrev" delay="0">
+                  <p:tgtEl>
+                    <p:sldTgt/>
+                  </p:tgtEl>
+                </p:cond>
+              </p:prevCondLst>
+              <p:nextCondLst>
+                <p:cond evt="onNext" delay="0">
+                  <p:tgtEl>
+                    <p:sldTgt/>
+                  </p:tgtEl>
+                </p:cond>
+              </p:nextCondLst>
+            </p:seq>
+          </p:childTnLst>
+        </p:cTn>
+      </p:par>
+    </p:tnLst>
+    <p:bldLst>
+      <p:bldP spid="2" grpId="0"/>
+    </p:bldLst>
+  </p:timing>
+</p:sld>
+</file>
+
+<file path=ppt/slides/slide9.xml><?xml version="1.0" encoding="utf-8"?>
+<p:sld xmlns:a="http://schemas.openxmlformats.org/drawingml/2006/main" xmlns:r="http://schemas.openxmlformats.org/officeDocument/2006/relationships" xmlns:p="http://schemas.openxmlformats.org/presentationml/2006/main">
+  <p:cSld>
+    <p:spTree>
+      <p:nvGrpSpPr>
+        <p:cNvPr id="1" name=""/>
+        <p:cNvGrpSpPr/>
+        <p:nvPr/>
+      </p:nvGrpSpPr>
+      <p:grpSpPr>
+        <a:xfrm>
+          <a:off x="0" y="0"/>
+          <a:ext cx="0" cy="0"/>
+          <a:chOff x="0" y="0"/>
+          <a:chExt cx="0" cy="0"/>
+        </a:xfrm>
+      </p:grpSpPr>
+      <p:sp>
+        <p:nvSpPr>
+          <p:cNvPr id="2" name="Заголовок 1">
+            <a:extLst>
+              <a:ext uri="{FF2B5EF4-FFF2-40B4-BE49-F238E27FC236}">
+                <a16:creationId xmlns:a16="http://schemas.microsoft.com/office/drawing/2014/main" id="{F209A495-8E3F-4CFE-86E0-75920089882B}"/>
+              </a:ext>
+            </a:extLst>
+          </p:cNvPr>
+          <p:cNvSpPr>
+            <a:spLocks noGrp="1"/>
+          </p:cNvSpPr>
+          <p:nvPr>
+            <p:ph type="title"/>
+          </p:nvPr>
+        </p:nvSpPr>
+        <p:spPr/>
+        <p:txBody>
+          <a:bodyPr>
+            <a:normAutofit/>
+          </a:bodyPr>
+          <a:lstStyle/>
+          <a:p>
+            <a:pPr algn="ctr"/>
+            <a:r>
+              <a:rPr lang="ru-RU" sz="4000" dirty="0" smtClean="0">
+                <a:solidFill>
+                  <a:srgbClr val="36A9E1"/>
+                </a:solidFill>
+                <a:latin typeface="Segoe UI Black" panose="020B0A02040204020203" pitchFamily="34" charset="0"/>
+                <a:ea typeface="Segoe UI Black" panose="020B0A02040204020203" pitchFamily="34" charset="0"/>
+              </a:rPr>
+              <a:t>Скриншоты</a:t>
+            </a:r>
+            <a:endParaRPr lang="ru-RU" sz="4000" dirty="0">
+              <a:solidFill>
+                <a:srgbClr val="36A9E1"/>
+              </a:solidFill>
+              <a:latin typeface="Segoe UI Black" panose="020B0A02040204020203" pitchFamily="34" charset="0"/>
+              <a:ea typeface="Segoe UI Black" panose="020B0A02040204020203" pitchFamily="34" charset="0"/>
+            </a:endParaRPr>
+          </a:p>
+        </p:txBody>
+      </p:sp>
+      <p:pic>
+        <p:nvPicPr>
+          <p:cNvPr id="4" name="Рисунок 3"/>
+          <p:cNvPicPr>
+            <a:picLocks noChangeAspect="1"/>
+          </p:cNvPicPr>
+          <p:nvPr/>
+        </p:nvPicPr>
+        <p:blipFill>
+          <a:blip r:embed="rId2" cstate="print">
+            <a:extLst>
+              <a:ext uri="{28A0092B-C50C-407E-A947-70E740481C1C}">
+                <a14:useLocalDpi xmlns:a14="http://schemas.microsoft.com/office/drawing/2010/main" val="0"/>
+              </a:ext>
+            </a:extLst>
+          </a:blip>
+          <a:stretch>
+            <a:fillRect/>
+          </a:stretch>
+        </p:blipFill>
+        <p:spPr>
+          <a:xfrm>
+            <a:off x="355785" y="1560554"/>
+            <a:ext cx="5899794" cy="2786618"/>
+          </a:xfrm>
+          <a:prstGeom prst="rect">
+            <a:avLst/>
+          </a:prstGeom>
+          <a:ln>
+            <a:noFill/>
+          </a:ln>
+          <a:effectLst>
+            <a:outerShdw blurRad="292100" dist="139700" dir="2700000" algn="tl" rotWithShape="0">
+              <a:srgbClr val="333333">
+                <a:alpha val="65000"/>
+              </a:srgbClr>
+            </a:outerShdw>
+          </a:effectLst>
+        </p:spPr>
+      </p:pic>
+      <p:pic>
+        <p:nvPicPr>
+          <p:cNvPr id="5" name="Рисунок 4"/>
+          <p:cNvPicPr>
+            <a:picLocks noChangeAspect="1"/>
+          </p:cNvPicPr>
+          <p:nvPr/>
+        </p:nvPicPr>
+        <p:blipFill>
+          <a:blip r:embed="rId3" cstate="print">
+            <a:extLst>
+              <a:ext uri="{28A0092B-C50C-407E-A947-70E740481C1C}">
+                <a14:useLocalDpi xmlns:a14="http://schemas.microsoft.com/office/drawing/2010/main" val="0"/>
+              </a:ext>
+            </a:extLst>
+          </a:blip>
+          <a:stretch>
+            <a:fillRect/>
+          </a:stretch>
+        </p:blipFill>
+        <p:spPr>
+          <a:xfrm>
+            <a:off x="5477185" y="3274736"/>
+            <a:ext cx="5996074" cy="2782179"/>
+          </a:xfrm>
+          <a:prstGeom prst="rect">
+            <a:avLst/>
+          </a:prstGeom>
+          <a:ln>
+            <a:noFill/>
+          </a:ln>
+          <a:effectLst>
+            <a:outerShdw blurRad="292100" dist="139700" dir="2700000" algn="tl" rotWithShape="0">
+              <a:srgbClr val="333333">
+                <a:alpha val="65000"/>
+              </a:srgbClr>
+            </a:outerShdw>
+          </a:effectLst>
+        </p:spPr>
+      </p:pic>
+    </p:spTree>
+    <p:extLst>
+      <p:ext uri="{BB962C8B-B14F-4D97-AF65-F5344CB8AC3E}">
+        <p14:creationId xmlns:p14="http://schemas.microsoft.com/office/powerpoint/2010/main" val="2251170707"/>
+      </p:ext>
+    </p:extLst>
+  </p:cSld>
+  <p:clrMapOvr>
+    <a:masterClrMapping/>
+  </p:clrMapOvr>
+  <p:timing>
+    <p:tnLst>
+      <p:par>
+        <p:cTn id="1" dur="indefinite" restart="never" nodeType="tmRoot">
+          <p:childTnLst>
+            <p:seq concurrent="1" nextAc="seek">
+              <p:cTn id="2" dur="indefinite" nodeType="mainSeq">
+                <p:childTnLst>
+                  <p:par>
+                    <p:cTn id="3" fill="hold">
+                      <p:stCondLst>
+                        <p:cond delay="indefinite"/>
+                        <p:cond evt="onBegin" delay="0">
+                          <p:tn val="2"/>
+                        </p:cond>
+                      </p:stCondLst>
+                      <p:childTnLst>
+                        <p:par>
+                          <p:cTn id="4" fill="hold">
+                            <p:stCondLst>
+                              <p:cond delay="0"/>
+                            </p:stCondLst>
+                            <p:childTnLst>
+                              <p:par>
+                                <p:cTn id="5" presetID="47" presetClass="entr" presetSubtype="0" fill="hold" grpId="0" nodeType="afterEffect">
+                                  <p:stCondLst>
+                                    <p:cond delay="0"/>
+                                  </p:stCondLst>
+                                  <p:childTnLst>
+                                    <p:set>
+                                      <p:cBhvr>
+                                        <p:cTn id="6" dur="1" fill="hold">
+                                          <p:stCondLst>
+                                            <p:cond delay="0"/>
+                                          </p:stCondLst>
+                                        </p:cTn>
+                                        <p:tgtEl>
+                                          <p:spTgt spid="2"/>
+                                        </p:tgtEl>
+                                        <p:attrNameLst>
+                                          <p:attrName>style.visibility</p:attrName>
+                                        </p:attrNameLst>
+                                      </p:cBhvr>
+                                      <p:to>
+                                        <p:strVal val="visible"/>
+                                      </p:to>
+                                    </p:set>
+                                    <p:animEffect transition="in" filter="fade">
+                                      <p:cBhvr>
+                                        <p:cTn id="7" dur="1000"/>
+                                        <p:tgtEl>
+                                          <p:spTgt spid="2"/>
+                                        </p:tgtEl>
+                                      </p:cBhvr>
+                                    </p:animEffect>
+                                    <p:anim calcmode="lin" valueType="num">
+                                      <p:cBhvr>
+                                        <p:cTn id="8" dur="1000" fill="hold"/>
+                                        <p:tgtEl>
+                                          <p:spTgt spid="2"/>
+                                        </p:tgtEl>
+                                        <p:attrNameLst>
+                                          <p:attrName>ppt_x</p:attrName>
+                                        </p:attrNameLst>
+                                      </p:cBhvr>
+                                      <p:tavLst>
+                                        <p:tav tm="0">
+                                          <p:val>
+                                            <p:strVal val="#ppt_x"/>
+                                          </p:val>
+                                        </p:tav>
+                                        <p:tav tm="100000">
+                                          <p:val>
+                                            <p:strVal val="#ppt_x"/>
+                                          </p:val>
+                                        </p:tav>
+                                      </p:tavLst>
+                                    </p:anim>
+                                    <p:anim calcmode="lin" valueType="num">
+                                      <p:cBhvr>
+                                        <p:cTn id="9" dur="1000" fill="hold"/>
+                                        <p:tgtEl>
+                                          <p:spTgt spid="2"/>
+                                        </p:tgtEl>
+                                        <p:attrNameLst>
+                                          <p:attrName>ppt_y</p:attrName>
+                                        </p:attrNameLst>
+                                      </p:cBhvr>
+                                      <p:tavLst>
+                                        <p:tav tm="0">
+                                          <p:val>
+                                            <p:strVal val="#ppt_y-.1"/>
+                                          </p:val>
+                                        </p:tav>
+                                        <p:tav tm="100000">
+                                          <p:val>
+                                            <p:strVal val="#ppt_y"/>
+                                          </p:val>
+                                        </p:tav>
+                                      </p:tavLst>
+                                    </p:anim>
+                                  </p:childTnLst>
+                                </p:cTn>
+                              </p:par>
+                            </p:childTnLst>
+                          </p:cTn>
+                        </p:par>
+                        <p:par>
+                          <p:cTn id="10" fill="hold">
+                            <p:stCondLst>
+                              <p:cond delay="1000"/>
+                            </p:stCondLst>
+                            <p:childTnLst>
+                              <p:par>
+                                <p:cTn id="11" presetID="53" presetClass="entr" presetSubtype="16" fill="hold" nodeType="afterEffect">
+                                  <p:stCondLst>
+                                    <p:cond delay="0"/>
+                                  </p:stCondLst>
+                                  <p:childTnLst>
+                                    <p:set>
+                                      <p:cBhvr>
+                                        <p:cTn id="12" dur="1" fill="hold">
+                                          <p:stCondLst>
+                                            <p:cond delay="0"/>
+                                          </p:stCondLst>
+                                        </p:cTn>
+                                        <p:tgtEl>
+                                          <p:spTgt spid="4"/>
+                                        </p:tgtEl>
+                                        <p:attrNameLst>
+                                          <p:attrName>style.visibility</p:attrName>
+                                        </p:attrNameLst>
+                                      </p:cBhvr>
+                                      <p:to>
+                                        <p:strVal val="visible"/>
+                                      </p:to>
+                                    </p:set>
+                                    <p:anim calcmode="lin" valueType="num">
+                                      <p:cBhvr>
+                                        <p:cTn id="13" dur="500" fill="hold"/>
+                                        <p:tgtEl>
+                                          <p:spTgt spid="4"/>
+                                        </p:tgtEl>
+                                        <p:attrNameLst>
+                                          <p:attrName>ppt_w</p:attrName>
+                                        </p:attrNameLst>
+                                      </p:cBhvr>
+                                      <p:tavLst>
+                                        <p:tav tm="0">
+                                          <p:val>
+                                            <p:fltVal val="0"/>
+                                          </p:val>
+                                        </p:tav>
+                                        <p:tav tm="100000">
+                                          <p:val>
+                                            <p:strVal val="#ppt_w"/>
+                                          </p:val>
+                                        </p:tav>
+                                      </p:tavLst>
+                                    </p:anim>
+                                    <p:anim calcmode="lin" valueType="num">
+                                      <p:cBhvr>
+                                        <p:cTn id="14" dur="500" fill="hold"/>
+                                        <p:tgtEl>
+                                          <p:spTgt spid="4"/>
+                                        </p:tgtEl>
+                                        <p:attrNameLst>
+                                          <p:attrName>ppt_h</p:attrName>
+                                        </p:attrNameLst>
+                                      </p:cBhvr>
+                                      <p:tavLst>
+                                        <p:tav tm="0">
+                                          <p:val>
+                                            <p:fltVal val="0"/>
+                                          </p:val>
+                                        </p:tav>
+                                        <p:tav tm="100000">
+                                          <p:val>
+                                            <p:strVal val="#ppt_h"/>
+                                          </p:val>
+                                        </p:tav>
+                                      </p:tavLst>
+                                    </p:anim>
+                                    <p:animEffect transition="in" filter="fade">
+                                      <p:cBhvr>
+                                        <p:cTn id="15" dur="500"/>
+                                        <p:tgtEl>
+                                          <p:spTgt spid="4"/>
+                                        </p:tgtEl>
+                                      </p:cBhvr>
+                                    </p:animEffect>
+                                  </p:childTnLst>
+                                </p:cTn>
+                              </p:par>
+                            </p:childTnLst>
+                          </p:cTn>
+                        </p:par>
+                        <p:par>
+                          <p:cTn id="16" fill="hold">
+                            <p:stCondLst>
+                              <p:cond delay="1500"/>
+                            </p:stCondLst>
+                            <p:childTnLst>
+                              <p:par>
+                                <p:cTn id="17" presetID="53" presetClass="entr" presetSubtype="16" fill="hold" nodeType="afterEffect">
+                                  <p:stCondLst>
+                                    <p:cond delay="0"/>
+                                  </p:stCondLst>
+                                  <p:childTnLst>
+                                    <p:set>
+                                      <p:cBhvr>
+                                        <p:cTn id="18" dur="1" fill="hold">
+                                          <p:stCondLst>
+                                            <p:cond delay="0"/>
+                                          </p:stCondLst>
+                                        </p:cTn>
+                                        <p:tgtEl>
+                                          <p:spTgt spid="5"/>
+                                        </p:tgtEl>
+                                        <p:attrNameLst>
+                                          <p:attrName>style.visibility</p:attrName>
+                                        </p:attrNameLst>
+                                      </p:cBhvr>
+                                      <p:to>
+                                        <p:strVal val="visible"/>
+                                      </p:to>
+                                    </p:set>
+                                    <p:anim calcmode="lin" valueType="num">
+                                      <p:cBhvr>
+                                        <p:cTn id="19" dur="500" fill="hold"/>
+                                        <p:tgtEl>
+                                          <p:spTgt spid="5"/>
+                                        </p:tgtEl>
+                                        <p:attrNameLst>
+                                          <p:attrName>ppt_w</p:attrName>
+                                        </p:attrNameLst>
+                                      </p:cBhvr>
+                                      <p:tavLst>
+                                        <p:tav tm="0">
+                                          <p:val>
+                                            <p:fltVal val="0"/>
+                                          </p:val>
+                                        </p:tav>
+                                        <p:tav tm="100000">
+                                          <p:val>
+                                            <p:strVal val="#ppt_w"/>
+                                          </p:val>
+                                        </p:tav>
+                                      </p:tavLst>
+                                    </p:anim>
+                                    <p:anim calcmode="lin" valueType="num">
+                                      <p:cBhvr>
+                                        <p:cTn id="20" dur="500" fill="hold"/>
+                                        <p:tgtEl>
+                                          <p:spTgt spid="5"/>
+                                        </p:tgtEl>
+                                        <p:attrNameLst>
+                                          <p:attrName>ppt_h</p:attrName>
+                                        </p:attrNameLst>
+                                      </p:cBhvr>
+                                      <p:tavLst>
+                                        <p:tav tm="0">
+                                          <p:val>
+                                            <p:fltVal val="0"/>
+                                          </p:val>
+                                        </p:tav>
+                                        <p:tav tm="100000">
+                                          <p:val>
+                                            <p:strVal val="#ppt_h"/>
+                                          </p:val>
+                                        </p:tav>
+                                      </p:tavLst>
+                                    </p:anim>
+                                    <p:animEffect transition="in" filter="fade">
+                                      <p:cBhvr>
+                                        <p:cTn id="21" dur="500"/>
+                                        <p:tgtEl>
+                                          <p:spTgt spid="5"/>
+                                        </p:tgtEl>
+                                      </p:cBhvr>
+                                    </p:animEffect>
+                                  </p:childTnLst>
+                                </p:cTn>
+                              </p:par>
+                            </p:childTnLst>
+                          </p:cTn>
+                        </p:par>
+                      </p:childTnLst>
+                    </p:cTn>
+                  </p:par>
+                </p:childTnLst>
+              </p:cTn>
+              <p:prevCondLst>
+                <p:cond evt="onPrev" delay="0">
+                  <p:tgtEl>
+                    <p:sldTgt/>
+                  </p:tgtEl>
+                </p:cond>
+              </p:prevCondLst>
+              <p:nextCondLst>
+                <p:cond evt="onNext" delay="0">
+                  <p:tgtEl>
+                    <p:sldTgt/>
+                  </p:tgtEl>
+                </p:cond>
+              </p:nextCondLst>
+            </p:seq>
+          </p:childTnLst>
+        </p:cTn>
+      </p:par>
+    </p:tnLst>
+    <p:bldLst>
+      <p:bldP spid="2" grpId="0"/>
+    </p:bldLst>
+  </p:timing>
 </p:sld>
 </file>
 

</xml_diff>